<commit_message>
Make the case language more direct
</commit_message>
<xml_diff>
--- a/deck/coca-cola-india-occasion-to-habit-case.pptx
+++ b/deck/coca-cola-india-occasion-to-habit-case.pptx
@@ -2,22 +2,22 @@
 <file path=ppt/presentation.xml><?xml version="1.0" encoding="utf-8"?>
 <p:presentation xmlns:p="http://schemas.openxmlformats.org/presentationml/2006/main">
   <p:sldMasterIdLst>
-    <p:sldMasterId xmlns:r="http://schemas.openxmlformats.org/officeDocument/2006/relationships" id="2147483648" r:id="R49139f8a941b4ebb"/>
+    <p:sldMasterId xmlns:r="http://schemas.openxmlformats.org/officeDocument/2006/relationships" id="2147483648" r:id="R6fc4f2c356e446a2"/>
   </p:sldMasterIdLst>
   <p:notesMasterIdLst>
-    <p:notesMasterId xmlns:r="http://schemas.openxmlformats.org/officeDocument/2006/relationships" r:id="R64d25aff86c442f3"/>
+    <p:notesMasterId xmlns:r="http://schemas.openxmlformats.org/officeDocument/2006/relationships" r:id="Rdcae89da6a434131"/>
   </p:notesMasterIdLst>
   <p:sldIdLst>
-    <p:sldId xmlns:r="http://schemas.openxmlformats.org/officeDocument/2006/relationships" id="256" r:id="Rb754dc8fe5df46d7"/>
-    <p:sldId xmlns:r="http://schemas.openxmlformats.org/officeDocument/2006/relationships" id="257" r:id="Rda419850d1d24d06"/>
-    <p:sldId xmlns:r="http://schemas.openxmlformats.org/officeDocument/2006/relationships" id="258" r:id="R01da1fcdab9c4d1f"/>
-    <p:sldId xmlns:r="http://schemas.openxmlformats.org/officeDocument/2006/relationships" id="259" r:id="R082612da790a402e"/>
-    <p:sldId xmlns:r="http://schemas.openxmlformats.org/officeDocument/2006/relationships" id="260" r:id="R64c98cab4dcd4c43"/>
-    <p:sldId xmlns:r="http://schemas.openxmlformats.org/officeDocument/2006/relationships" id="261" r:id="R386d1566f59b46c0"/>
-    <p:sldId xmlns:r="http://schemas.openxmlformats.org/officeDocument/2006/relationships" id="262" r:id="R3b8260c06b87490a"/>
-    <p:sldId xmlns:r="http://schemas.openxmlformats.org/officeDocument/2006/relationships" id="263" r:id="Raf981dcd1e414e41"/>
-    <p:sldId xmlns:r="http://schemas.openxmlformats.org/officeDocument/2006/relationships" id="264" r:id="R86c70b99347d4da2"/>
-    <p:sldId xmlns:r="http://schemas.openxmlformats.org/officeDocument/2006/relationships" id="265" r:id="Rb4ec1688338a491b"/>
+    <p:sldId xmlns:r="http://schemas.openxmlformats.org/officeDocument/2006/relationships" id="256" r:id="R6734e99c1f664686"/>
+    <p:sldId xmlns:r="http://schemas.openxmlformats.org/officeDocument/2006/relationships" id="257" r:id="Rc40935bc9f004ff8"/>
+    <p:sldId xmlns:r="http://schemas.openxmlformats.org/officeDocument/2006/relationships" id="258" r:id="R5eaedc987e944ccb"/>
+    <p:sldId xmlns:r="http://schemas.openxmlformats.org/officeDocument/2006/relationships" id="259" r:id="R1cc8f135edb7410a"/>
+    <p:sldId xmlns:r="http://schemas.openxmlformats.org/officeDocument/2006/relationships" id="260" r:id="R8c8071ba953c4e2c"/>
+    <p:sldId xmlns:r="http://schemas.openxmlformats.org/officeDocument/2006/relationships" id="261" r:id="R611fd980da934449"/>
+    <p:sldId xmlns:r="http://schemas.openxmlformats.org/officeDocument/2006/relationships" id="262" r:id="Rd004dd8160414786"/>
+    <p:sldId xmlns:r="http://schemas.openxmlformats.org/officeDocument/2006/relationships" id="263" r:id="R9eef925a46644ea7"/>
+    <p:sldId xmlns:r="http://schemas.openxmlformats.org/officeDocument/2006/relationships" id="264" r:id="Ra6582bad71394e3f"/>
+    <p:sldId xmlns:r="http://schemas.openxmlformats.org/officeDocument/2006/relationships" id="265" r:id="R4442db7aecd247dd"/>
   </p:sldIdLst>
   <p:sldSz cx="12192000" cy="6858000"/>
   <p:notesSz cx="6858000" cy="9144000"/>
@@ -471,7 +471,7 @@
           </a:p>
           <a:p xmlns:a="http://schemas.openxmlformats.org/drawingml/2006/main">
             <a:r>
-              <a:t>Independent portfolio case. I did not work for Coca-Cola.</a:t>
+              <a:t>Independent public-source case. I did not work for Coca-Cola.</a:t>
             </a:r>
           </a:p>
         </p:txBody>
@@ -1334,7 +1334,7 @@
   </p:cSld>
   <p:clrMap bg1="lt1" tx1="dk1" bg2="lt2" tx2="dk2" accent1="accent1" accent2="accent2" accent3="accent3" accent4="accent4" accent5="accent5" accent6="accent6" hlink="hlink" folHlink="folHlink"/>
   <p:sldLayoutIdLst>
-    <p:sldLayoutId xmlns:r="http://schemas.openxmlformats.org/officeDocument/2006/relationships" id="2147483649" r:id="R72908a26d0d84d2d"/>
+    <p:sldLayoutId xmlns:r="http://schemas.openxmlformats.org/officeDocument/2006/relationships" id="2147483649" r:id="R7ddb115d39dc4705"/>
   </p:sldLayoutIdLst>
   <p:txStyles>
     <p:titleStyle>
@@ -1885,7 +1885,7 @@
           <p:cNvPr id="9" name="">
             <a:extLst xmlns:a="http://schemas.openxmlformats.org/drawingml/2006/main">
               <a:ext uri="{FF2B5EF4-FFF2-40B4-BE49-F238E27FC236}">
-                <a16:creationId xmlns:a16="http://schemas.microsoft.com/office/drawing/2014/main" id="{5C4D6A30-A630-4935-8E02-C367403980E6}"/>
+                <a16:creationId xmlns:a16="http://schemas.microsoft.com/office/drawing/2014/main" id="{B8DD5103-567E-4D07-84CD-D627220A7146}"/>
               </a:ext>
             </a:extLst>
           </p:cNvPr>
@@ -1913,10 +1913,10 @@
       </p:sp>
       <p:sp>
         <p:nvSpPr>
-          <p:cNvPr id="2" name="text-jfdwjcwss7c">
-            <a:extLst xmlns:a="http://schemas.openxmlformats.org/drawingml/2006/main">
-              <a:ext uri="{FF2B5EF4-FFF2-40B4-BE49-F238E27FC236}">
-                <a16:creationId xmlns:a16="http://schemas.microsoft.com/office/drawing/2014/main" id="{A7F8F52E-1139-45C7-95D5-71E8D1431D85}"/>
+          <p:cNvPr id="2" name="text-yr1cbs6yp5">
+            <a:extLst xmlns:a="http://schemas.openxmlformats.org/drawingml/2006/main">
+              <a:ext uri="{FF2B5EF4-FFF2-40B4-BE49-F238E27FC236}">
+                <a16:creationId xmlns:a16="http://schemas.microsoft.com/office/drawing/2014/main" id="{7C74B9AD-F080-43ED-B9FD-2197411328C2}"/>
               </a:ext>
             </a:extLst>
           </p:cNvPr>
@@ -1971,10 +1971,10 @@
       </p:sp>
       <p:sp>
         <p:nvSpPr>
-          <p:cNvPr id="3" name="text-uk98bvx7rs">
-            <a:extLst xmlns:a="http://schemas.openxmlformats.org/drawingml/2006/main">
-              <a:ext uri="{FF2B5EF4-FFF2-40B4-BE49-F238E27FC236}">
-                <a16:creationId xmlns:a16="http://schemas.microsoft.com/office/drawing/2014/main" id="{B40997F5-4A7E-4443-9D9B-5B288C1D59F8}"/>
+          <p:cNvPr id="3" name="text-bjrd2pc70t9">
+            <a:extLst xmlns:a="http://schemas.openxmlformats.org/drawingml/2006/main">
+              <a:ext uri="{FF2B5EF4-FFF2-40B4-BE49-F238E27FC236}">
+                <a16:creationId xmlns:a16="http://schemas.microsoft.com/office/drawing/2014/main" id="{63CF8678-BF47-4E9A-968A-A0C403ACB594}"/>
               </a:ext>
             </a:extLst>
           </p:cNvPr>
@@ -2029,10 +2029,10 @@
       </p:sp>
       <p:sp>
         <p:nvSpPr>
-          <p:cNvPr id="4" name="text-e1w0idvszp">
-            <a:extLst xmlns:a="http://schemas.openxmlformats.org/drawingml/2006/main">
-              <a:ext uri="{FF2B5EF4-FFF2-40B4-BE49-F238E27FC236}">
-                <a16:creationId xmlns:a16="http://schemas.microsoft.com/office/drawing/2014/main" id="{51990078-731B-4E4C-B4E9-0A0119464A75}"/>
+          <p:cNvPr id="4" name="text-znpnb3eq3on">
+            <a:extLst xmlns:a="http://schemas.openxmlformats.org/drawingml/2006/main">
+              <a:ext uri="{FF2B5EF4-FFF2-40B4-BE49-F238E27FC236}">
+                <a16:creationId xmlns:a16="http://schemas.microsoft.com/office/drawing/2014/main" id="{4A2FDC17-7190-49CD-B748-647FDE4616C5}"/>
               </a:ext>
             </a:extLst>
           </p:cNvPr>
@@ -2090,7 +2090,7 @@
           <p:cNvPr id="5" name="">
             <a:extLst xmlns:a="http://schemas.openxmlformats.org/drawingml/2006/main">
               <a:ext uri="{FF2B5EF4-FFF2-40B4-BE49-F238E27FC236}">
-                <a16:creationId xmlns:a16="http://schemas.microsoft.com/office/drawing/2014/main" id="{B9584E89-5ED9-4A66-BED7-C60384C17331}"/>
+                <a16:creationId xmlns:a16="http://schemas.microsoft.com/office/drawing/2014/main" id="{529F6134-D5FC-4E5F-BDA8-4CDBB2964155}"/>
               </a:ext>
             </a:extLst>
           </p:cNvPr>
@@ -2118,10 +2118,10 @@
       </p:sp>
       <p:sp>
         <p:nvSpPr>
-          <p:cNvPr id="6" name="text-fz2wyyazoyo">
-            <a:extLst xmlns:a="http://schemas.openxmlformats.org/drawingml/2006/main">
-              <a:ext uri="{FF2B5EF4-FFF2-40B4-BE49-F238E27FC236}">
-                <a16:creationId xmlns:a16="http://schemas.microsoft.com/office/drawing/2014/main" id="{1F7F00F0-83DE-47E2-9230-34D0093E7DD8}"/>
+          <p:cNvPr id="6" name="text-038921vgmvf">
+            <a:extLst xmlns:a="http://schemas.openxmlformats.org/drawingml/2006/main">
+              <a:ext uri="{FF2B5EF4-FFF2-40B4-BE49-F238E27FC236}">
+                <a16:creationId xmlns:a16="http://schemas.microsoft.com/office/drawing/2014/main" id="{F6168E8F-2C98-45F5-AEDB-B8936DC105A2}"/>
               </a:ext>
             </a:extLst>
           </p:cNvPr>
@@ -2176,10 +2176,10 @@
       </p:sp>
       <p:sp>
         <p:nvSpPr>
-          <p:cNvPr id="7" name="text-yyy582kzvpb">
-            <a:extLst xmlns:a="http://schemas.openxmlformats.org/drawingml/2006/main">
-              <a:ext uri="{FF2B5EF4-FFF2-40B4-BE49-F238E27FC236}">
-                <a16:creationId xmlns:a16="http://schemas.microsoft.com/office/drawing/2014/main" id="{4A1A7EDB-7AD7-4670-94CC-1DD2C327712A}"/>
+          <p:cNvPr id="7" name="text-cjjnys3ryo5">
+            <a:extLst xmlns:a="http://schemas.openxmlformats.org/drawingml/2006/main">
+              <a:ext uri="{FF2B5EF4-FFF2-40B4-BE49-F238E27FC236}">
+                <a16:creationId xmlns:a16="http://schemas.microsoft.com/office/drawing/2014/main" id="{3F0290BA-7F79-4E70-A772-EBC116D5C000}"/>
               </a:ext>
             </a:extLst>
           </p:cNvPr>
@@ -2234,10 +2234,10 @@
       </p:sp>
       <p:sp>
         <p:nvSpPr>
-          <p:cNvPr id="8" name="text-nyhdcccdgof">
-            <a:extLst xmlns:a="http://schemas.openxmlformats.org/drawingml/2006/main">
-              <a:ext uri="{FF2B5EF4-FFF2-40B4-BE49-F238E27FC236}">
-                <a16:creationId xmlns:a16="http://schemas.microsoft.com/office/drawing/2014/main" id="{16CDC057-F4E7-4584-8AB8-DEA97EBD83A5}"/>
+          <p:cNvPr id="8" name="text-abnlh0hokcj">
+            <a:extLst xmlns:a="http://schemas.openxmlformats.org/drawingml/2006/main">
+              <a:ext uri="{FF2B5EF4-FFF2-40B4-BE49-F238E27FC236}">
+                <a16:creationId xmlns:a16="http://schemas.microsoft.com/office/drawing/2014/main" id="{93524D25-558A-48F1-9A12-0F66C8BE84D1}"/>
               </a:ext>
             </a:extLst>
           </p:cNvPr>
@@ -2293,7 +2293,7 @@
     </p:spTree>
     <p:extLst>
       <p:ext uri="{BB962C8B-B14F-4D97-AF65-F5344CB8AC3E}">
-        <p14:creationId xmlns:p14="http://schemas.microsoft.com/office/powerpoint/2010/main" val="186257714"/>
+        <p14:creationId xmlns:p14="http://schemas.microsoft.com/office/powerpoint/2010/main" val="258964886"/>
       </p:ext>
     </p:extLst>
   </p:cSld>
@@ -2321,10 +2321,10 @@
       </p:grpSpPr>
       <p:sp>
         <p:nvSpPr>
-          <p:cNvPr id="6" name="text-dihwiirfjsv">
-            <a:extLst xmlns:a="http://schemas.openxmlformats.org/drawingml/2006/main">
-              <a:ext uri="{FF2B5EF4-FFF2-40B4-BE49-F238E27FC236}">
-                <a16:creationId xmlns:a16="http://schemas.microsoft.com/office/drawing/2014/main" id="{42F6AAAA-BDA6-4029-9915-71B76B239CA5}"/>
+          <p:cNvPr id="6" name="text-dcj1z8vf8h">
+            <a:extLst xmlns:a="http://schemas.openxmlformats.org/drawingml/2006/main">
+              <a:ext uri="{FF2B5EF4-FFF2-40B4-BE49-F238E27FC236}">
+                <a16:creationId xmlns:a16="http://schemas.microsoft.com/office/drawing/2014/main" id="{6310D907-65BC-44FD-9172-8F829F3A4E8D}"/>
               </a:ext>
             </a:extLst>
           </p:cNvPr>
@@ -2379,10 +2379,10 @@
       </p:sp>
       <p:sp>
         <p:nvSpPr>
-          <p:cNvPr id="2" name="text-1zau4ts97g5">
-            <a:extLst xmlns:a="http://schemas.openxmlformats.org/drawingml/2006/main">
-              <a:ext uri="{FF2B5EF4-FFF2-40B4-BE49-F238E27FC236}">
-                <a16:creationId xmlns:a16="http://schemas.microsoft.com/office/drawing/2014/main" id="{CFC07298-08DC-433F-B1AB-B6400889992C}"/>
+          <p:cNvPr id="2" name="text-qpr0i83amca">
+            <a:extLst xmlns:a="http://schemas.openxmlformats.org/drawingml/2006/main">
+              <a:ext uri="{FF2B5EF4-FFF2-40B4-BE49-F238E27FC236}">
+                <a16:creationId xmlns:a16="http://schemas.microsoft.com/office/drawing/2014/main" id="{E32A8604-328B-44ED-8B4F-F9D6B5571EB5}"/>
               </a:ext>
             </a:extLst>
           </p:cNvPr>
@@ -2437,10 +2437,10 @@
       </p:sp>
       <p:sp>
         <p:nvSpPr>
-          <p:cNvPr id="3" name="text-zp2pjoagj5r">
-            <a:extLst xmlns:a="http://schemas.openxmlformats.org/drawingml/2006/main">
-              <a:ext uri="{FF2B5EF4-FFF2-40B4-BE49-F238E27FC236}">
-                <a16:creationId xmlns:a16="http://schemas.microsoft.com/office/drawing/2014/main" id="{1A5735A5-9B8E-4D90-9482-50C502F393DF}"/>
+          <p:cNvPr id="3" name="text-ox27ive7n">
+            <a:extLst xmlns:a="http://schemas.openxmlformats.org/drawingml/2006/main">
+              <a:ext uri="{FF2B5EF4-FFF2-40B4-BE49-F238E27FC236}">
+                <a16:creationId xmlns:a16="http://schemas.microsoft.com/office/drawing/2014/main" id="{E5A7BE1F-7510-44BC-BDC7-4FC8BF215DD9}"/>
               </a:ext>
             </a:extLst>
           </p:cNvPr>
@@ -2573,10 +2573,10 @@
       </p:cxnSp>
       <p:sp>
         <p:nvSpPr>
-          <p:cNvPr id="5" name="text-sfw4p47f37n">
-            <a:extLst xmlns:a="http://schemas.openxmlformats.org/drawingml/2006/main">
-              <a:ext uri="{FF2B5EF4-FFF2-40B4-BE49-F238E27FC236}">
-                <a16:creationId xmlns:a16="http://schemas.microsoft.com/office/drawing/2014/main" id="{7D542A8A-5A16-44AE-8CBB-D83D6DA1C5BE}"/>
+          <p:cNvPr id="5" name="text-ggn2dhypeas">
+            <a:extLst xmlns:a="http://schemas.openxmlformats.org/drawingml/2006/main">
+              <a:ext uri="{FF2B5EF4-FFF2-40B4-BE49-F238E27FC236}">
+                <a16:creationId xmlns:a16="http://schemas.microsoft.com/office/drawing/2014/main" id="{D326EC26-6E92-4DB3-B538-7433F20CCFDA}"/>
               </a:ext>
             </a:extLst>
           </p:cNvPr>
@@ -2632,7 +2632,7 @@
     </p:spTree>
     <p:extLst>
       <p:ext uri="{BB962C8B-B14F-4D97-AF65-F5344CB8AC3E}">
-        <p14:creationId xmlns:p14="http://schemas.microsoft.com/office/powerpoint/2010/main" val="1883392669"/>
+        <p14:creationId xmlns:p14="http://schemas.microsoft.com/office/powerpoint/2010/main" val="1226363921"/>
       </p:ext>
     </p:extLst>
   </p:cSld>
@@ -2660,10 +2660,10 @@
       </p:grpSpPr>
       <p:sp>
         <p:nvSpPr>
-          <p:cNvPr id="10" name="text-r4e03k506yk">
-            <a:extLst xmlns:a="http://schemas.openxmlformats.org/drawingml/2006/main">
-              <a:ext uri="{FF2B5EF4-FFF2-40B4-BE49-F238E27FC236}">
-                <a16:creationId xmlns:a16="http://schemas.microsoft.com/office/drawing/2014/main" id="{D8ECC2B7-C2E6-4975-A71E-BC89139E018A}"/>
+          <p:cNvPr id="10" name="text-310vsc4udve">
+            <a:extLst xmlns:a="http://schemas.openxmlformats.org/drawingml/2006/main">
+              <a:ext uri="{FF2B5EF4-FFF2-40B4-BE49-F238E27FC236}">
+                <a16:creationId xmlns:a16="http://schemas.microsoft.com/office/drawing/2014/main" id="{A43D153D-A40C-4777-BEE9-244C5AF28284}"/>
               </a:ext>
             </a:extLst>
           </p:cNvPr>
@@ -2718,10 +2718,10 @@
       </p:sp>
       <p:sp>
         <p:nvSpPr>
-          <p:cNvPr id="2" name="text-dg4qld0kwke">
-            <a:extLst xmlns:a="http://schemas.openxmlformats.org/drawingml/2006/main">
-              <a:ext uri="{FF2B5EF4-FFF2-40B4-BE49-F238E27FC236}">
-                <a16:creationId xmlns:a16="http://schemas.microsoft.com/office/drawing/2014/main" id="{E7398B81-E4E1-4E34-84F3-1EA450D77B69}"/>
+          <p:cNvPr id="2" name="text-26ziq8fyjjh">
+            <a:extLst xmlns:a="http://schemas.openxmlformats.org/drawingml/2006/main">
+              <a:ext uri="{FF2B5EF4-FFF2-40B4-BE49-F238E27FC236}">
+                <a16:creationId xmlns:a16="http://schemas.microsoft.com/office/drawing/2014/main" id="{3C70B14A-DE60-4D64-87D1-D12D2AF95829}"/>
               </a:ext>
             </a:extLst>
           </p:cNvPr>
@@ -2776,10 +2776,10 @@
       </p:sp>
       <p:sp>
         <p:nvSpPr>
-          <p:cNvPr id="3" name="text-nmvpst4ow2e">
-            <a:extLst xmlns:a="http://schemas.openxmlformats.org/drawingml/2006/main">
-              <a:ext uri="{FF2B5EF4-FFF2-40B4-BE49-F238E27FC236}">
-                <a16:creationId xmlns:a16="http://schemas.microsoft.com/office/drawing/2014/main" id="{439A6F12-8158-4CE4-8059-E1F952F88D87}"/>
+          <p:cNvPr id="3" name="text-cscz67vlyva">
+            <a:extLst xmlns:a="http://schemas.openxmlformats.org/drawingml/2006/main">
+              <a:ext uri="{FF2B5EF4-FFF2-40B4-BE49-F238E27FC236}">
+                <a16:creationId xmlns:a16="http://schemas.microsoft.com/office/drawing/2014/main" id="{298BEBB1-DF87-4639-8006-27706F947B8A}"/>
               </a:ext>
             </a:extLst>
           </p:cNvPr>
@@ -2834,10 +2834,10 @@
       </p:sp>
       <p:sp>
         <p:nvSpPr>
-          <p:cNvPr id="4" name="text-2egdycnz9rp">
-            <a:extLst xmlns:a="http://schemas.openxmlformats.org/drawingml/2006/main">
-              <a:ext uri="{FF2B5EF4-FFF2-40B4-BE49-F238E27FC236}">
-                <a16:creationId xmlns:a16="http://schemas.microsoft.com/office/drawing/2014/main" id="{10032236-5C17-4E64-AD88-35E263BAC33E}"/>
+          <p:cNvPr id="4" name="text-qsjbvihe80g">
+            <a:extLst xmlns:a="http://schemas.openxmlformats.org/drawingml/2006/main">
+              <a:ext uri="{FF2B5EF4-FFF2-40B4-BE49-F238E27FC236}">
+                <a16:creationId xmlns:a16="http://schemas.microsoft.com/office/drawing/2014/main" id="{52602DA3-FD6D-46E0-B49D-39B3639924A7}"/>
               </a:ext>
             </a:extLst>
           </p:cNvPr>
@@ -2892,10 +2892,10 @@
       </p:sp>
       <p:sp>
         <p:nvSpPr>
-          <p:cNvPr id="5" name="text-r24u7qe2wpg">
-            <a:extLst xmlns:a="http://schemas.openxmlformats.org/drawingml/2006/main">
-              <a:ext uri="{FF2B5EF4-FFF2-40B4-BE49-F238E27FC236}">
-                <a16:creationId xmlns:a16="http://schemas.microsoft.com/office/drawing/2014/main" id="{13E1ECA9-9925-4D5D-95D4-1E734ABD05EF}"/>
+          <p:cNvPr id="5" name="text-gbc81knm0iv">
+            <a:extLst xmlns:a="http://schemas.openxmlformats.org/drawingml/2006/main">
+              <a:ext uri="{FF2B5EF4-FFF2-40B4-BE49-F238E27FC236}">
+                <a16:creationId xmlns:a16="http://schemas.microsoft.com/office/drawing/2014/main" id="{B9D57A50-BB96-4FFC-898D-02310647FBF8}"/>
               </a:ext>
             </a:extLst>
           </p:cNvPr>
@@ -2953,7 +2953,7 @@
           <p:cNvPr id="6" name="">
             <a:extLst xmlns:a="http://schemas.openxmlformats.org/drawingml/2006/main">
               <a:ext uri="{FF2B5EF4-FFF2-40B4-BE49-F238E27FC236}">
-                <a16:creationId xmlns:a16="http://schemas.microsoft.com/office/drawing/2014/main" id="{6214459F-046A-4004-A41B-A421F91C94B9}"/>
+                <a16:creationId xmlns:a16="http://schemas.microsoft.com/office/drawing/2014/main" id="{81324CF8-9EC6-4F05-81B2-8317E2E72817}"/>
               </a:ext>
             </a:extLst>
           </p:cNvPr>
@@ -2981,10 +2981,10 @@
       </p:sp>
       <p:sp>
         <p:nvSpPr>
-          <p:cNvPr id="7" name="text-syyvrfgocr">
-            <a:extLst xmlns:a="http://schemas.openxmlformats.org/drawingml/2006/main">
-              <a:ext uri="{FF2B5EF4-FFF2-40B4-BE49-F238E27FC236}">
-                <a16:creationId xmlns:a16="http://schemas.microsoft.com/office/drawing/2014/main" id="{2A4FF22C-777C-4C13-9DA9-E1C95BFDB220}"/>
+          <p:cNvPr id="7" name="text-m4vlac7uxol">
+            <a:extLst xmlns:a="http://schemas.openxmlformats.org/drawingml/2006/main">
+              <a:ext uri="{FF2B5EF4-FFF2-40B4-BE49-F238E27FC236}">
+                <a16:creationId xmlns:a16="http://schemas.microsoft.com/office/drawing/2014/main" id="{75020A4E-19C8-45A1-9CEC-9AFF714D4863}"/>
               </a:ext>
             </a:extLst>
           </p:cNvPr>
@@ -3039,10 +3039,10 @@
       </p:sp>
       <p:sp>
         <p:nvSpPr>
-          <p:cNvPr id="8" name="text-re8pz7uuevj">
-            <a:extLst xmlns:a="http://schemas.openxmlformats.org/drawingml/2006/main">
-              <a:ext uri="{FF2B5EF4-FFF2-40B4-BE49-F238E27FC236}">
-                <a16:creationId xmlns:a16="http://schemas.microsoft.com/office/drawing/2014/main" id="{002498BA-D2A9-4776-A1AB-D478CA41039B}"/>
+          <p:cNvPr id="8" name="text-uubdf3qekzn">
+            <a:extLst xmlns:a="http://schemas.openxmlformats.org/drawingml/2006/main">
+              <a:ext uri="{FF2B5EF4-FFF2-40B4-BE49-F238E27FC236}">
+                <a16:creationId xmlns:a16="http://schemas.microsoft.com/office/drawing/2014/main" id="{B7B859CE-E1B2-4384-BC8F-0FA41411C7D3}"/>
               </a:ext>
             </a:extLst>
           </p:cNvPr>
@@ -3181,10 +3181,10 @@
       </p:sp>
       <p:sp>
         <p:nvSpPr>
-          <p:cNvPr id="9" name="text-hseokiw8o3a">
-            <a:extLst xmlns:a="http://schemas.openxmlformats.org/drawingml/2006/main">
-              <a:ext uri="{FF2B5EF4-FFF2-40B4-BE49-F238E27FC236}">
-                <a16:creationId xmlns:a16="http://schemas.microsoft.com/office/drawing/2014/main" id="{A59D67F0-B3BE-4C84-8B51-BDCE0622394E}"/>
+          <p:cNvPr id="9" name="text-rpq868axokg">
+            <a:extLst xmlns:a="http://schemas.openxmlformats.org/drawingml/2006/main">
+              <a:ext uri="{FF2B5EF4-FFF2-40B4-BE49-F238E27FC236}">
+                <a16:creationId xmlns:a16="http://schemas.microsoft.com/office/drawing/2014/main" id="{DD5E93F8-8B80-4000-93F3-65D7BDEEF5AB}"/>
               </a:ext>
             </a:extLst>
           </p:cNvPr>
@@ -3240,7 +3240,7 @@
     </p:spTree>
     <p:extLst>
       <p:ext uri="{BB962C8B-B14F-4D97-AF65-F5344CB8AC3E}">
-        <p14:creationId xmlns:p14="http://schemas.microsoft.com/office/powerpoint/2010/main" val="2082130"/>
+        <p14:creationId xmlns:p14="http://schemas.microsoft.com/office/powerpoint/2010/main" val="550934353"/>
       </p:ext>
     </p:extLst>
   </p:cSld>
@@ -3268,10 +3268,10 @@
       </p:grpSpPr>
       <p:sp>
         <p:nvSpPr>
-          <p:cNvPr id="19" name="text-i4c0o223k3">
-            <a:extLst xmlns:a="http://schemas.openxmlformats.org/drawingml/2006/main">
-              <a:ext uri="{FF2B5EF4-FFF2-40B4-BE49-F238E27FC236}">
-                <a16:creationId xmlns:a16="http://schemas.microsoft.com/office/drawing/2014/main" id="{03B3BE8F-E528-4FD0-B7AD-A8B5A2E060FD}"/>
+          <p:cNvPr id="19" name="text-escdsn7o41v">
+            <a:extLst xmlns:a="http://schemas.openxmlformats.org/drawingml/2006/main">
+              <a:ext uri="{FF2B5EF4-FFF2-40B4-BE49-F238E27FC236}">
+                <a16:creationId xmlns:a16="http://schemas.microsoft.com/office/drawing/2014/main" id="{6A067A50-C5C9-44EE-9AC1-6E61802BAB40}"/>
               </a:ext>
             </a:extLst>
           </p:cNvPr>
@@ -3326,10 +3326,10 @@
       </p:sp>
       <p:sp>
         <p:nvSpPr>
-          <p:cNvPr id="2" name="text-levqh8yy6hf">
-            <a:extLst xmlns:a="http://schemas.openxmlformats.org/drawingml/2006/main">
-              <a:ext uri="{FF2B5EF4-FFF2-40B4-BE49-F238E27FC236}">
-                <a16:creationId xmlns:a16="http://schemas.microsoft.com/office/drawing/2014/main" id="{EE72FFD8-CEEA-4440-97EC-B45E756C3CBF}"/>
+          <p:cNvPr id="2" name="text-w7ap99c6rye">
+            <a:extLst xmlns:a="http://schemas.openxmlformats.org/drawingml/2006/main">
+              <a:ext uri="{FF2B5EF4-FFF2-40B4-BE49-F238E27FC236}">
+                <a16:creationId xmlns:a16="http://schemas.microsoft.com/office/drawing/2014/main" id="{3D14E118-E6F6-4693-B046-C119FB3A67B7}"/>
               </a:ext>
             </a:extLst>
           </p:cNvPr>
@@ -3384,10 +3384,10 @@
       </p:sp>
       <p:sp>
         <p:nvSpPr>
-          <p:cNvPr id="3" name="text-1d1f3g3f3vh">
-            <a:extLst xmlns:a="http://schemas.openxmlformats.org/drawingml/2006/main">
-              <a:ext uri="{FF2B5EF4-FFF2-40B4-BE49-F238E27FC236}">
-                <a16:creationId xmlns:a16="http://schemas.microsoft.com/office/drawing/2014/main" id="{0169D75A-01BD-495B-BFAD-D4C61CE55F7D}"/>
+          <p:cNvPr id="3" name="text-2n41copztfc">
+            <a:extLst xmlns:a="http://schemas.openxmlformats.org/drawingml/2006/main">
+              <a:ext uri="{FF2B5EF4-FFF2-40B4-BE49-F238E27FC236}">
+                <a16:creationId xmlns:a16="http://schemas.microsoft.com/office/drawing/2014/main" id="{396E4CC5-9082-432B-8882-732C0BCFED75}"/>
               </a:ext>
             </a:extLst>
           </p:cNvPr>
@@ -3467,7 +3467,7 @@
           <p:cNvPr id="5" name="">
             <a:extLst xmlns:a="http://schemas.openxmlformats.org/drawingml/2006/main">
               <a:ext uri="{FF2B5EF4-FFF2-40B4-BE49-F238E27FC236}">
-                <a16:creationId xmlns:a16="http://schemas.microsoft.com/office/drawing/2014/main" id="{04916B7C-7784-49AF-8894-E61C6A297F31}"/>
+                <a16:creationId xmlns:a16="http://schemas.microsoft.com/office/drawing/2014/main" id="{A60E0378-4BB8-45D7-9AD5-F0995C873DE4}"/>
               </a:ext>
             </a:extLst>
           </p:cNvPr>
@@ -3497,10 +3497,10 @@
       </p:sp>
       <p:sp>
         <p:nvSpPr>
-          <p:cNvPr id="6" name="text-azn5hwxz43s">
-            <a:extLst xmlns:a="http://schemas.openxmlformats.org/drawingml/2006/main">
-              <a:ext uri="{FF2B5EF4-FFF2-40B4-BE49-F238E27FC236}">
-                <a16:creationId xmlns:a16="http://schemas.microsoft.com/office/drawing/2014/main" id="{E01946D6-597D-47DB-A7DC-7995A7A8B29F}"/>
+          <p:cNvPr id="6" name="text-q5sopl50v6">
+            <a:extLst xmlns:a="http://schemas.openxmlformats.org/drawingml/2006/main">
+              <a:ext uri="{FF2B5EF4-FFF2-40B4-BE49-F238E27FC236}">
+                <a16:creationId xmlns:a16="http://schemas.microsoft.com/office/drawing/2014/main" id="{2294FE50-05DD-4E68-902B-962241E12348}"/>
               </a:ext>
             </a:extLst>
           </p:cNvPr>
@@ -3555,10 +3555,10 @@
       </p:sp>
       <p:sp>
         <p:nvSpPr>
-          <p:cNvPr id="7" name="text-hwga9b8dyth">
-            <a:extLst xmlns:a="http://schemas.openxmlformats.org/drawingml/2006/main">
-              <a:ext uri="{FF2B5EF4-FFF2-40B4-BE49-F238E27FC236}">
-                <a16:creationId xmlns:a16="http://schemas.microsoft.com/office/drawing/2014/main" id="{7B0B4410-A7D9-4B0F-B7E4-EBB78956F0CC}"/>
+          <p:cNvPr id="7" name="text-pdf1e2stfup">
+            <a:extLst xmlns:a="http://schemas.openxmlformats.org/drawingml/2006/main">
+              <a:ext uri="{FF2B5EF4-FFF2-40B4-BE49-F238E27FC236}">
+                <a16:creationId xmlns:a16="http://schemas.microsoft.com/office/drawing/2014/main" id="{BD90B5C0-50F7-4F81-BD3D-AC67C5057E18}"/>
               </a:ext>
             </a:extLst>
           </p:cNvPr>
@@ -3613,10 +3613,10 @@
       </p:sp>
       <p:sp>
         <p:nvSpPr>
-          <p:cNvPr id="8" name="text-d7r0i3gwsv">
-            <a:extLst xmlns:a="http://schemas.openxmlformats.org/drawingml/2006/main">
-              <a:ext uri="{FF2B5EF4-FFF2-40B4-BE49-F238E27FC236}">
-                <a16:creationId xmlns:a16="http://schemas.microsoft.com/office/drawing/2014/main" id="{238612AF-D1BD-4123-9BE7-D220D0A1076B}"/>
+          <p:cNvPr id="8" name="text-7ls38ii1sjr">
+            <a:extLst xmlns:a="http://schemas.openxmlformats.org/drawingml/2006/main">
+              <a:ext uri="{FF2B5EF4-FFF2-40B4-BE49-F238E27FC236}">
+                <a16:creationId xmlns:a16="http://schemas.microsoft.com/office/drawing/2014/main" id="{CACEA017-C29F-4C73-99C4-EC181BA18C37}"/>
               </a:ext>
             </a:extLst>
           </p:cNvPr>
@@ -3674,7 +3674,7 @@
           <p:cNvPr id="9" name="">
             <a:extLst xmlns:a="http://schemas.openxmlformats.org/drawingml/2006/main">
               <a:ext uri="{FF2B5EF4-FFF2-40B4-BE49-F238E27FC236}">
-                <a16:creationId xmlns:a16="http://schemas.microsoft.com/office/drawing/2014/main" id="{2ED24A76-4ABF-408E-B4BA-CDF29B734F38}"/>
+                <a16:creationId xmlns:a16="http://schemas.microsoft.com/office/drawing/2014/main" id="{45545A3D-ABF7-44EC-97F1-EC24E3F5428C}"/>
               </a:ext>
             </a:extLst>
           </p:cNvPr>
@@ -3704,10 +3704,10 @@
       </p:sp>
       <p:sp>
         <p:nvSpPr>
-          <p:cNvPr id="10" name="text-l8vjdsbuets">
-            <a:extLst xmlns:a="http://schemas.openxmlformats.org/drawingml/2006/main">
-              <a:ext uri="{FF2B5EF4-FFF2-40B4-BE49-F238E27FC236}">
-                <a16:creationId xmlns:a16="http://schemas.microsoft.com/office/drawing/2014/main" id="{30CAC378-189F-4046-A018-34658F2914BF}"/>
+          <p:cNvPr id="10" name="text-sll3mrl8ueh">
+            <a:extLst xmlns:a="http://schemas.openxmlformats.org/drawingml/2006/main">
+              <a:ext uri="{FF2B5EF4-FFF2-40B4-BE49-F238E27FC236}">
+                <a16:creationId xmlns:a16="http://schemas.microsoft.com/office/drawing/2014/main" id="{0AF6C92D-18D5-40EE-9F87-BCCE7BB55D4D}"/>
               </a:ext>
             </a:extLst>
           </p:cNvPr>
@@ -3762,10 +3762,10 @@
       </p:sp>
       <p:sp>
         <p:nvSpPr>
-          <p:cNvPr id="11" name="text-zthkiss1fm">
-            <a:extLst xmlns:a="http://schemas.openxmlformats.org/drawingml/2006/main">
-              <a:ext uri="{FF2B5EF4-FFF2-40B4-BE49-F238E27FC236}">
-                <a16:creationId xmlns:a16="http://schemas.microsoft.com/office/drawing/2014/main" id="{34708A5B-FB98-4F2B-8202-1EE7B11EEDCF}"/>
+          <p:cNvPr id="11" name="text-p161q3ichnh">
+            <a:extLst xmlns:a="http://schemas.openxmlformats.org/drawingml/2006/main">
+              <a:ext uri="{FF2B5EF4-FFF2-40B4-BE49-F238E27FC236}">
+                <a16:creationId xmlns:a16="http://schemas.microsoft.com/office/drawing/2014/main" id="{624A9278-AF03-4AC0-B9B5-B9BF38BD885B}"/>
               </a:ext>
             </a:extLst>
           </p:cNvPr>
@@ -3820,10 +3820,10 @@
       </p:sp>
       <p:sp>
         <p:nvSpPr>
-          <p:cNvPr id="12" name="text-cvuwo9utwac">
-            <a:extLst xmlns:a="http://schemas.openxmlformats.org/drawingml/2006/main">
-              <a:ext uri="{FF2B5EF4-FFF2-40B4-BE49-F238E27FC236}">
-                <a16:creationId xmlns:a16="http://schemas.microsoft.com/office/drawing/2014/main" id="{FB556D7C-FD27-463D-A51F-1AF56E881579}"/>
+          <p:cNvPr id="12" name="text-d78w3za2a9r">
+            <a:extLst xmlns:a="http://schemas.openxmlformats.org/drawingml/2006/main">
+              <a:ext uri="{FF2B5EF4-FFF2-40B4-BE49-F238E27FC236}">
+                <a16:creationId xmlns:a16="http://schemas.microsoft.com/office/drawing/2014/main" id="{34209E3D-8897-4F3A-AABE-F1A4BBFE0ACF}"/>
               </a:ext>
             </a:extLst>
           </p:cNvPr>
@@ -3881,7 +3881,7 @@
           <p:cNvPr id="13" name="">
             <a:extLst xmlns:a="http://schemas.openxmlformats.org/drawingml/2006/main">
               <a:ext uri="{FF2B5EF4-FFF2-40B4-BE49-F238E27FC236}">
-                <a16:creationId xmlns:a16="http://schemas.microsoft.com/office/drawing/2014/main" id="{66C4EA0E-85F8-4B26-83A5-6AE7984DCAEC}"/>
+                <a16:creationId xmlns:a16="http://schemas.microsoft.com/office/drawing/2014/main" id="{3F532D35-A024-452C-94D0-DCF2764EE61A}"/>
               </a:ext>
             </a:extLst>
           </p:cNvPr>
@@ -3911,10 +3911,10 @@
       </p:sp>
       <p:sp>
         <p:nvSpPr>
-          <p:cNvPr id="14" name="text-x1r6k5g74z">
-            <a:extLst xmlns:a="http://schemas.openxmlformats.org/drawingml/2006/main">
-              <a:ext uri="{FF2B5EF4-FFF2-40B4-BE49-F238E27FC236}">
-                <a16:creationId xmlns:a16="http://schemas.microsoft.com/office/drawing/2014/main" id="{39FD3009-9B50-495D-BF20-9D5B463652FB}"/>
+          <p:cNvPr id="14" name="text-ozfee51672">
+            <a:extLst xmlns:a="http://schemas.openxmlformats.org/drawingml/2006/main">
+              <a:ext uri="{FF2B5EF4-FFF2-40B4-BE49-F238E27FC236}">
+                <a16:creationId xmlns:a16="http://schemas.microsoft.com/office/drawing/2014/main" id="{46CB2C3C-397C-4984-A160-1DB5BC198FD9}"/>
               </a:ext>
             </a:extLst>
           </p:cNvPr>
@@ -3969,10 +3969,10 @@
       </p:sp>
       <p:sp>
         <p:nvSpPr>
-          <p:cNvPr id="15" name="text-z36ralp70e">
-            <a:extLst xmlns:a="http://schemas.openxmlformats.org/drawingml/2006/main">
-              <a:ext uri="{FF2B5EF4-FFF2-40B4-BE49-F238E27FC236}">
-                <a16:creationId xmlns:a16="http://schemas.microsoft.com/office/drawing/2014/main" id="{2ADDC7A4-278C-4642-9D2A-2BE5D9AEC7BF}"/>
+          <p:cNvPr id="15" name="text-f0sp7c540wd">
+            <a:extLst xmlns:a="http://schemas.openxmlformats.org/drawingml/2006/main">
+              <a:ext uri="{FF2B5EF4-FFF2-40B4-BE49-F238E27FC236}">
+                <a16:creationId xmlns:a16="http://schemas.microsoft.com/office/drawing/2014/main" id="{F8378179-75B3-43D4-9034-7A0142718EA7}"/>
               </a:ext>
             </a:extLst>
           </p:cNvPr>
@@ -4027,10 +4027,10 @@
       </p:sp>
       <p:sp>
         <p:nvSpPr>
-          <p:cNvPr id="16" name="text-vc5itac9xlb">
-            <a:extLst xmlns:a="http://schemas.openxmlformats.org/drawingml/2006/main">
-              <a:ext uri="{FF2B5EF4-FFF2-40B4-BE49-F238E27FC236}">
-                <a16:creationId xmlns:a16="http://schemas.microsoft.com/office/drawing/2014/main" id="{72CA6E9E-FBDC-4260-8000-5BD55DA496F1}"/>
+          <p:cNvPr id="16" name="text-psk2s7jgnj">
+            <a:extLst xmlns:a="http://schemas.openxmlformats.org/drawingml/2006/main">
+              <a:ext uri="{FF2B5EF4-FFF2-40B4-BE49-F238E27FC236}">
+                <a16:creationId xmlns:a16="http://schemas.microsoft.com/office/drawing/2014/main" id="{D406363D-AE2E-43F0-96AE-A446FD12243E}"/>
               </a:ext>
             </a:extLst>
           </p:cNvPr>
@@ -4085,10 +4085,10 @@
       </p:sp>
       <p:sp>
         <p:nvSpPr>
-          <p:cNvPr id="17" name="text-vsjfcytnqb">
-            <a:extLst xmlns:a="http://schemas.openxmlformats.org/drawingml/2006/main">
-              <a:ext uri="{FF2B5EF4-FFF2-40B4-BE49-F238E27FC236}">
-                <a16:creationId xmlns:a16="http://schemas.microsoft.com/office/drawing/2014/main" id="{BD0BE9C9-4B04-4644-8001-1C28524FA793}"/>
+          <p:cNvPr id="17" name="text-8u1zacv3mdu">
+            <a:extLst xmlns:a="http://schemas.openxmlformats.org/drawingml/2006/main">
+              <a:ext uri="{FF2B5EF4-FFF2-40B4-BE49-F238E27FC236}">
+                <a16:creationId xmlns:a16="http://schemas.microsoft.com/office/drawing/2014/main" id="{FCAAB0DC-FEAC-4FFE-8662-EA8BA19F2B5F}"/>
               </a:ext>
             </a:extLst>
           </p:cNvPr>
@@ -4143,10 +4143,10 @@
       </p:sp>
       <p:sp>
         <p:nvSpPr>
-          <p:cNvPr id="18" name="text-0pzsn3wg76">
-            <a:extLst xmlns:a="http://schemas.openxmlformats.org/drawingml/2006/main">
-              <a:ext uri="{FF2B5EF4-FFF2-40B4-BE49-F238E27FC236}">
-                <a16:creationId xmlns:a16="http://schemas.microsoft.com/office/drawing/2014/main" id="{C15A6B3F-E451-4970-A5C4-7800F0D5EA98}"/>
+          <p:cNvPr id="18" name="text-6pifyduj5ug">
+            <a:extLst xmlns:a="http://schemas.openxmlformats.org/drawingml/2006/main">
+              <a:ext uri="{FF2B5EF4-FFF2-40B4-BE49-F238E27FC236}">
+                <a16:creationId xmlns:a16="http://schemas.microsoft.com/office/drawing/2014/main" id="{58CC8799-0B81-4989-B18E-BEE9A6EC8956}"/>
               </a:ext>
             </a:extLst>
           </p:cNvPr>
@@ -4202,7 +4202,7 @@
     </p:spTree>
     <p:extLst>
       <p:ext uri="{BB962C8B-B14F-4D97-AF65-F5344CB8AC3E}">
-        <p14:creationId xmlns:p14="http://schemas.microsoft.com/office/powerpoint/2010/main" val="712681050"/>
+        <p14:creationId xmlns:p14="http://schemas.microsoft.com/office/powerpoint/2010/main" val="1949343537"/>
       </p:ext>
     </p:extLst>
   </p:cSld>
@@ -4230,10 +4230,10 @@
       </p:grpSpPr>
       <p:sp>
         <p:nvSpPr>
-          <p:cNvPr id="18" name="text-tmvxdakcea">
-            <a:extLst xmlns:a="http://schemas.openxmlformats.org/drawingml/2006/main">
-              <a:ext uri="{FF2B5EF4-FFF2-40B4-BE49-F238E27FC236}">
-                <a16:creationId xmlns:a16="http://schemas.microsoft.com/office/drawing/2014/main" id="{7EF1E566-FEC6-4145-ABEA-B02CD16A57F5}"/>
+          <p:cNvPr id="18" name="text-2wfp9kmp675">
+            <a:extLst xmlns:a="http://schemas.openxmlformats.org/drawingml/2006/main">
+              <a:ext uri="{FF2B5EF4-FFF2-40B4-BE49-F238E27FC236}">
+                <a16:creationId xmlns:a16="http://schemas.microsoft.com/office/drawing/2014/main" id="{0D3ED4E2-1B2E-44D3-882C-017BEFB251A8}"/>
               </a:ext>
             </a:extLst>
           </p:cNvPr>
@@ -4288,10 +4288,10 @@
       </p:sp>
       <p:sp>
         <p:nvSpPr>
-          <p:cNvPr id="2" name="text-59zq0go4y1j">
-            <a:extLst xmlns:a="http://schemas.openxmlformats.org/drawingml/2006/main">
-              <a:ext uri="{FF2B5EF4-FFF2-40B4-BE49-F238E27FC236}">
-                <a16:creationId xmlns:a16="http://schemas.microsoft.com/office/drawing/2014/main" id="{827EA383-F867-41F9-81B7-7CA85FEABA5F}"/>
+          <p:cNvPr id="2" name="text-m95ktetsjzm">
+            <a:extLst xmlns:a="http://schemas.openxmlformats.org/drawingml/2006/main">
+              <a:ext uri="{FF2B5EF4-FFF2-40B4-BE49-F238E27FC236}">
+                <a16:creationId xmlns:a16="http://schemas.microsoft.com/office/drawing/2014/main" id="{22E78715-6464-4F86-A746-76B8D7DFD9C8}"/>
               </a:ext>
             </a:extLst>
           </p:cNvPr>
@@ -4316,7 +4316,7 @@
         </p:spPr>
         <p:txBody>
           <a:bodyPr xmlns:a="http://schemas.openxmlformats.org/drawingml/2006/main" anchor="t">
-            <a:normAutofit fontScale="100000"/>
+            <a:normAutofit fontScale="95049"/>
           </a:bodyPr>
           <a:lstStyle xmlns:a="http://schemas.openxmlformats.org/drawingml/2006/main"/>
           <a:p xmlns:a="http://schemas.openxmlformats.org/drawingml/2006/main">
@@ -4339,17 +4339,17 @@
                 <a:ea typeface="Arial"/>
                 <a:cs typeface="Arial"/>
               </a:rPr>
-              <a:t>Personalization works when the pack becomes a social object</a:t>
-            </a:r>
-          </a:p>
-        </p:txBody>
-      </p:sp>
-      <p:sp>
-        <p:nvSpPr>
-          <p:cNvPr id="3" name="text-0orqebwe113">
-            <a:extLst xmlns:a="http://schemas.openxmlformats.org/drawingml/2006/main">
-              <a:ext uri="{FF2B5EF4-FFF2-40B4-BE49-F238E27FC236}">
-                <a16:creationId xmlns:a16="http://schemas.microsoft.com/office/drawing/2014/main" id="{0EDD8A1D-50F0-4E96-8E74-ACDC3EFACDB2}"/>
+              <a:t>Personalization works when the pack feels personal and shareable</a:t>
+            </a:r>
+          </a:p>
+        </p:txBody>
+      </p:sp>
+      <p:sp>
+        <p:nvSpPr>
+          <p:cNvPr id="3" name="text-ao2orhw5hwb">
+            <a:extLst xmlns:a="http://schemas.openxmlformats.org/drawingml/2006/main">
+              <a:ext uri="{FF2B5EF4-FFF2-40B4-BE49-F238E27FC236}">
+                <a16:creationId xmlns:a16="http://schemas.microsoft.com/office/drawing/2014/main" id="{78C4D8A2-95A3-4FA3-B7D2-DC67AD84C745}"/>
               </a:ext>
             </a:extLst>
           </p:cNvPr>
@@ -4404,10 +4404,10 @@
       </p:sp>
       <p:sp>
         <p:nvSpPr>
-          <p:cNvPr id="4" name="text-edgkn4ctk4">
-            <a:extLst xmlns:a="http://schemas.openxmlformats.org/drawingml/2006/main">
-              <a:ext uri="{FF2B5EF4-FFF2-40B4-BE49-F238E27FC236}">
-                <a16:creationId xmlns:a16="http://schemas.microsoft.com/office/drawing/2014/main" id="{6A895AE3-7BBF-40BC-98E1-A4117BDA5ADB}"/>
+          <p:cNvPr id="4" name="text-91jgkhbw31j">
+            <a:extLst xmlns:a="http://schemas.openxmlformats.org/drawingml/2006/main">
+              <a:ext uri="{FF2B5EF4-FFF2-40B4-BE49-F238E27FC236}">
+                <a16:creationId xmlns:a16="http://schemas.microsoft.com/office/drawing/2014/main" id="{31B70F4E-C52D-4A71-AE9A-A5CBFEB64C4F}"/>
               </a:ext>
             </a:extLst>
           </p:cNvPr>
@@ -4462,10 +4462,10 @@
       </p:sp>
       <p:sp>
         <p:nvSpPr>
-          <p:cNvPr id="5" name="text-zutfjohptfr">
-            <a:extLst xmlns:a="http://schemas.openxmlformats.org/drawingml/2006/main">
-              <a:ext uri="{FF2B5EF4-FFF2-40B4-BE49-F238E27FC236}">
-                <a16:creationId xmlns:a16="http://schemas.microsoft.com/office/drawing/2014/main" id="{D60D3DD0-4C67-4765-98EC-288927529A36}"/>
+          <p:cNvPr id="5" name="text-mk9dfs2qyr">
+            <a:extLst xmlns:a="http://schemas.openxmlformats.org/drawingml/2006/main">
+              <a:ext uri="{FF2B5EF4-FFF2-40B4-BE49-F238E27FC236}">
+                <a16:creationId xmlns:a16="http://schemas.microsoft.com/office/drawing/2014/main" id="{D9148BC4-FAEE-4BBB-A811-B5CDA9A1E809}"/>
               </a:ext>
             </a:extLst>
           </p:cNvPr>
@@ -4542,10 +4542,10 @@
       </p:cxnSp>
       <p:sp>
         <p:nvSpPr>
-          <p:cNvPr id="7" name="text-9yiofi7hdes">
-            <a:extLst xmlns:a="http://schemas.openxmlformats.org/drawingml/2006/main">
-              <a:ext uri="{FF2B5EF4-FFF2-40B4-BE49-F238E27FC236}">
-                <a16:creationId xmlns:a16="http://schemas.microsoft.com/office/drawing/2014/main" id="{777612F8-09BF-420B-B9F2-3502D125D3C0}"/>
+          <p:cNvPr id="7" name="text-xx54e3kv5ya">
+            <a:extLst xmlns:a="http://schemas.openxmlformats.org/drawingml/2006/main">
+              <a:ext uri="{FF2B5EF4-FFF2-40B4-BE49-F238E27FC236}">
+                <a16:creationId xmlns:a16="http://schemas.microsoft.com/office/drawing/2014/main" id="{0F986EB1-604A-4E1A-87F0-CC39119B8436}"/>
               </a:ext>
             </a:extLst>
           </p:cNvPr>
@@ -4600,10 +4600,10 @@
       </p:sp>
       <p:sp>
         <p:nvSpPr>
-          <p:cNvPr id="8" name="text-re6tu5dpwqp">
-            <a:extLst xmlns:a="http://schemas.openxmlformats.org/drawingml/2006/main">
-              <a:ext uri="{FF2B5EF4-FFF2-40B4-BE49-F238E27FC236}">
-                <a16:creationId xmlns:a16="http://schemas.microsoft.com/office/drawing/2014/main" id="{C8227014-783B-495C-97F1-C0BAD1CBD371}"/>
+          <p:cNvPr id="8" name="text-d752jblehe6">
+            <a:extLst xmlns:a="http://schemas.openxmlformats.org/drawingml/2006/main">
+              <a:ext uri="{FF2B5EF4-FFF2-40B4-BE49-F238E27FC236}">
+                <a16:creationId xmlns:a16="http://schemas.microsoft.com/office/drawing/2014/main" id="{2D3C1847-21D3-425D-998D-5523DC5AB4D8}"/>
               </a:ext>
             </a:extLst>
           </p:cNvPr>
@@ -4658,10 +4658,10 @@
       </p:sp>
       <p:sp>
         <p:nvSpPr>
-          <p:cNvPr id="9" name="text-fmia7toaia7">
-            <a:extLst xmlns:a="http://schemas.openxmlformats.org/drawingml/2006/main">
-              <a:ext uri="{FF2B5EF4-FFF2-40B4-BE49-F238E27FC236}">
-                <a16:creationId xmlns:a16="http://schemas.microsoft.com/office/drawing/2014/main" id="{09C812BB-4362-47A8-A979-BABCA14AFEA4}"/>
+          <p:cNvPr id="9" name="text-0l93zxmhfo">
+            <a:extLst xmlns:a="http://schemas.openxmlformats.org/drawingml/2006/main">
+              <a:ext uri="{FF2B5EF4-FFF2-40B4-BE49-F238E27FC236}">
+                <a16:creationId xmlns:a16="http://schemas.microsoft.com/office/drawing/2014/main" id="{02715694-6673-41C8-9176-F685AA35D79D}"/>
               </a:ext>
             </a:extLst>
           </p:cNvPr>
@@ -4738,10 +4738,10 @@
       </p:cxnSp>
       <p:sp>
         <p:nvSpPr>
-          <p:cNvPr id="11" name="text-9gsfbtb4qx">
-            <a:extLst xmlns:a="http://schemas.openxmlformats.org/drawingml/2006/main">
-              <a:ext uri="{FF2B5EF4-FFF2-40B4-BE49-F238E27FC236}">
-                <a16:creationId xmlns:a16="http://schemas.microsoft.com/office/drawing/2014/main" id="{2EDC6F9E-C058-4DBA-A968-50FB5EEB270B}"/>
+          <p:cNvPr id="11" name="text-uf3on6193kk">
+            <a:extLst xmlns:a="http://schemas.openxmlformats.org/drawingml/2006/main">
+              <a:ext uri="{FF2B5EF4-FFF2-40B4-BE49-F238E27FC236}">
+                <a16:creationId xmlns:a16="http://schemas.microsoft.com/office/drawing/2014/main" id="{EA858077-E885-4EB0-8CEE-3AC3C49AD793}"/>
               </a:ext>
             </a:extLst>
           </p:cNvPr>
@@ -4796,10 +4796,10 @@
       </p:sp>
       <p:sp>
         <p:nvSpPr>
-          <p:cNvPr id="12" name="text-zzyjb0icyki">
-            <a:extLst xmlns:a="http://schemas.openxmlformats.org/drawingml/2006/main">
-              <a:ext uri="{FF2B5EF4-FFF2-40B4-BE49-F238E27FC236}">
-                <a16:creationId xmlns:a16="http://schemas.microsoft.com/office/drawing/2014/main" id="{2DC15C96-3ACB-4EBE-932E-687B1CEFE5FF}"/>
+          <p:cNvPr id="12" name="text-z6b8u1ov2q8">
+            <a:extLst xmlns:a="http://schemas.openxmlformats.org/drawingml/2006/main">
+              <a:ext uri="{FF2B5EF4-FFF2-40B4-BE49-F238E27FC236}">
+                <a16:creationId xmlns:a16="http://schemas.microsoft.com/office/drawing/2014/main" id="{A112509F-5F01-468C-8B49-F93231076B74}"/>
               </a:ext>
             </a:extLst>
           </p:cNvPr>
@@ -4854,10 +4854,10 @@
       </p:sp>
       <p:sp>
         <p:nvSpPr>
-          <p:cNvPr id="13" name="text-47k8gvegm84">
-            <a:extLst xmlns:a="http://schemas.openxmlformats.org/drawingml/2006/main">
-              <a:ext uri="{FF2B5EF4-FFF2-40B4-BE49-F238E27FC236}">
-                <a16:creationId xmlns:a16="http://schemas.microsoft.com/office/drawing/2014/main" id="{C0EB477C-0EAE-4707-82E4-EF6BBFAECCBF}"/>
+          <p:cNvPr id="13" name="text-dx8ix8i0lag">
+            <a:extLst xmlns:a="http://schemas.openxmlformats.org/drawingml/2006/main">
+              <a:ext uri="{FF2B5EF4-FFF2-40B4-BE49-F238E27FC236}">
+                <a16:creationId xmlns:a16="http://schemas.microsoft.com/office/drawing/2014/main" id="{04B0C3F2-16C6-4EEA-9269-FFE0B7F42D9C}"/>
               </a:ext>
             </a:extLst>
           </p:cNvPr>
@@ -4934,10 +4934,10 @@
       </p:cxnSp>
       <p:sp>
         <p:nvSpPr>
-          <p:cNvPr id="15" name="text-6qyupps0qhi">
-            <a:extLst xmlns:a="http://schemas.openxmlformats.org/drawingml/2006/main">
-              <a:ext uri="{FF2B5EF4-FFF2-40B4-BE49-F238E27FC236}">
-                <a16:creationId xmlns:a16="http://schemas.microsoft.com/office/drawing/2014/main" id="{9C57E11D-BC59-40B2-9595-DA851C0ECC9C}"/>
+          <p:cNvPr id="15" name="text-vlpq4ho2zji">
+            <a:extLst xmlns:a="http://schemas.openxmlformats.org/drawingml/2006/main">
+              <a:ext uri="{FF2B5EF4-FFF2-40B4-BE49-F238E27FC236}">
+                <a16:creationId xmlns:a16="http://schemas.microsoft.com/office/drawing/2014/main" id="{409B8732-5C5F-475C-A003-7EF97F49BC74}"/>
               </a:ext>
             </a:extLst>
           </p:cNvPr>
@@ -4992,10 +4992,10 @@
       </p:sp>
       <p:sp>
         <p:nvSpPr>
-          <p:cNvPr id="16" name="text-s18g7vhdl7l">
-            <a:extLst xmlns:a="http://schemas.openxmlformats.org/drawingml/2006/main">
-              <a:ext uri="{FF2B5EF4-FFF2-40B4-BE49-F238E27FC236}">
-                <a16:creationId xmlns:a16="http://schemas.microsoft.com/office/drawing/2014/main" id="{B3CAC5AC-FAF0-4CC3-BB54-8148C0F36174}"/>
+          <p:cNvPr id="16" name="text-pw9kkdmo1nj">
+            <a:extLst xmlns:a="http://schemas.openxmlformats.org/drawingml/2006/main">
+              <a:ext uri="{FF2B5EF4-FFF2-40B4-BE49-F238E27FC236}">
+                <a16:creationId xmlns:a16="http://schemas.microsoft.com/office/drawing/2014/main" id="{C2820A50-30E3-41A2-8549-5489BC1B0F57}"/>
               </a:ext>
             </a:extLst>
           </p:cNvPr>
@@ -5050,10 +5050,10 @@
       </p:sp>
       <p:sp>
         <p:nvSpPr>
-          <p:cNvPr id="17" name="text-igox30jujy9">
-            <a:extLst xmlns:a="http://schemas.openxmlformats.org/drawingml/2006/main">
-              <a:ext uri="{FF2B5EF4-FFF2-40B4-BE49-F238E27FC236}">
-                <a16:creationId xmlns:a16="http://schemas.microsoft.com/office/drawing/2014/main" id="{5D497332-13CA-4903-974A-F970330669CF}"/>
+          <p:cNvPr id="17" name="text-p3htuj9dre">
+            <a:extLst xmlns:a="http://schemas.openxmlformats.org/drawingml/2006/main">
+              <a:ext uri="{FF2B5EF4-FFF2-40B4-BE49-F238E27FC236}">
+                <a16:creationId xmlns:a16="http://schemas.microsoft.com/office/drawing/2014/main" id="{92265E74-A65B-4D7F-9E83-1A22102BCC1C}"/>
               </a:ext>
             </a:extLst>
           </p:cNvPr>
@@ -5109,7 +5109,7 @@
     </p:spTree>
     <p:extLst>
       <p:ext uri="{BB962C8B-B14F-4D97-AF65-F5344CB8AC3E}">
-        <p14:creationId xmlns:p14="http://schemas.microsoft.com/office/powerpoint/2010/main" val="1188564841"/>
+        <p14:creationId xmlns:p14="http://schemas.microsoft.com/office/powerpoint/2010/main" val="403269921"/>
       </p:ext>
     </p:extLst>
   </p:cSld>
@@ -5137,10 +5137,10 @@
       </p:grpSpPr>
       <p:sp>
         <p:nvSpPr>
-          <p:cNvPr id="30" name="text-we5lh94omgl">
-            <a:extLst xmlns:a="http://schemas.openxmlformats.org/drawingml/2006/main">
-              <a:ext uri="{FF2B5EF4-FFF2-40B4-BE49-F238E27FC236}">
-                <a16:creationId xmlns:a16="http://schemas.microsoft.com/office/drawing/2014/main" id="{98A1245F-088A-468D-A89F-1AC1F23E8342}"/>
+          <p:cNvPr id="30" name="text-vzcm5xu2akf">
+            <a:extLst xmlns:a="http://schemas.openxmlformats.org/drawingml/2006/main">
+              <a:ext uri="{FF2B5EF4-FFF2-40B4-BE49-F238E27FC236}">
+                <a16:creationId xmlns:a16="http://schemas.microsoft.com/office/drawing/2014/main" id="{D4FACC05-CEA6-479E-AF55-C61FA268A1D4}"/>
               </a:ext>
             </a:extLst>
           </p:cNvPr>
@@ -5195,10 +5195,10 @@
       </p:sp>
       <p:sp>
         <p:nvSpPr>
-          <p:cNvPr id="2" name="text-863lnyvkl8s">
-            <a:extLst xmlns:a="http://schemas.openxmlformats.org/drawingml/2006/main">
-              <a:ext uri="{FF2B5EF4-FFF2-40B4-BE49-F238E27FC236}">
-                <a16:creationId xmlns:a16="http://schemas.microsoft.com/office/drawing/2014/main" id="{533928EE-2602-413E-8BAF-4847294C7248}"/>
+          <p:cNvPr id="2" name="text-qnhgbclj99p">
+            <a:extLst xmlns:a="http://schemas.openxmlformats.org/drawingml/2006/main">
+              <a:ext uri="{FF2B5EF4-FFF2-40B4-BE49-F238E27FC236}">
+                <a16:creationId xmlns:a16="http://schemas.microsoft.com/office/drawing/2014/main" id="{A474E1DF-4010-4DE5-832D-BDFA5C064252}"/>
               </a:ext>
             </a:extLst>
           </p:cNvPr>
@@ -5253,10 +5253,10 @@
       </p:sp>
       <p:sp>
         <p:nvSpPr>
-          <p:cNvPr id="3" name="text-dzi3qf2bvqd">
-            <a:extLst xmlns:a="http://schemas.openxmlformats.org/drawingml/2006/main">
-              <a:ext uri="{FF2B5EF4-FFF2-40B4-BE49-F238E27FC236}">
-                <a16:creationId xmlns:a16="http://schemas.microsoft.com/office/drawing/2014/main" id="{7F4CBB61-DF41-4DD7-9E78-B4A6AE02D9FB}"/>
+          <p:cNvPr id="3" name="text-ur8ml4t65qn">
+            <a:extLst xmlns:a="http://schemas.openxmlformats.org/drawingml/2006/main">
+              <a:ext uri="{FF2B5EF4-FFF2-40B4-BE49-F238E27FC236}">
+                <a16:creationId xmlns:a16="http://schemas.microsoft.com/office/drawing/2014/main" id="{2DDEBB27-B9D0-452C-9421-21DC5FD7FF76}"/>
               </a:ext>
             </a:extLst>
           </p:cNvPr>
@@ -5336,7 +5336,7 @@
           <p:cNvPr id="5" name="">
             <a:extLst xmlns:a="http://schemas.openxmlformats.org/drawingml/2006/main">
               <a:ext uri="{FF2B5EF4-FFF2-40B4-BE49-F238E27FC236}">
-                <a16:creationId xmlns:a16="http://schemas.microsoft.com/office/drawing/2014/main" id="{5404C0A2-4343-4520-80B7-0471076B6B23}"/>
+                <a16:creationId xmlns:a16="http://schemas.microsoft.com/office/drawing/2014/main" id="{FC57B6FB-9E36-4A58-95EA-C36ADCC6DD8B}"/>
               </a:ext>
             </a:extLst>
           </p:cNvPr>
@@ -5366,10 +5366,10 @@
       </p:sp>
       <p:sp>
         <p:nvSpPr>
-          <p:cNvPr id="6" name="text-abdy2vweyr6">
-            <a:extLst xmlns:a="http://schemas.openxmlformats.org/drawingml/2006/main">
-              <a:ext uri="{FF2B5EF4-FFF2-40B4-BE49-F238E27FC236}">
-                <a16:creationId xmlns:a16="http://schemas.microsoft.com/office/drawing/2014/main" id="{07A6FAA8-3C9D-4BCB-A046-CC02198CC64A}"/>
+          <p:cNvPr id="6" name="text-hee08dy8v4o">
+            <a:extLst xmlns:a="http://schemas.openxmlformats.org/drawingml/2006/main">
+              <a:ext uri="{FF2B5EF4-FFF2-40B4-BE49-F238E27FC236}">
+                <a16:creationId xmlns:a16="http://schemas.microsoft.com/office/drawing/2014/main" id="{11FE8D93-A3DB-449F-950C-57789DB3F1F0}"/>
               </a:ext>
             </a:extLst>
           </p:cNvPr>
@@ -5424,10 +5424,10 @@
       </p:sp>
       <p:sp>
         <p:nvSpPr>
-          <p:cNvPr id="7" name="text-nt3axrosder">
-            <a:extLst xmlns:a="http://schemas.openxmlformats.org/drawingml/2006/main">
-              <a:ext uri="{FF2B5EF4-FFF2-40B4-BE49-F238E27FC236}">
-                <a16:creationId xmlns:a16="http://schemas.microsoft.com/office/drawing/2014/main" id="{8888946E-2B59-4527-9398-AA7354381DB4}"/>
+          <p:cNvPr id="7" name="text-s31m5imehhh">
+            <a:extLst xmlns:a="http://schemas.openxmlformats.org/drawingml/2006/main">
+              <a:ext uri="{FF2B5EF4-FFF2-40B4-BE49-F238E27FC236}">
+                <a16:creationId xmlns:a16="http://schemas.microsoft.com/office/drawing/2014/main" id="{841A500D-6AE5-4D49-992B-D0A4A1DC52A6}"/>
               </a:ext>
             </a:extLst>
           </p:cNvPr>
@@ -5482,10 +5482,10 @@
       </p:sp>
       <p:sp>
         <p:nvSpPr>
-          <p:cNvPr id="8" name="text-7uxhjaetexm">
-            <a:extLst xmlns:a="http://schemas.openxmlformats.org/drawingml/2006/main">
-              <a:ext uri="{FF2B5EF4-FFF2-40B4-BE49-F238E27FC236}">
-                <a16:creationId xmlns:a16="http://schemas.microsoft.com/office/drawing/2014/main" id="{C630F7D4-D590-4FBB-9356-BD0FAA20B45F}"/>
+          <p:cNvPr id="8" name="text-widf8l1bj9h">
+            <a:extLst xmlns:a="http://schemas.openxmlformats.org/drawingml/2006/main">
+              <a:ext uri="{FF2B5EF4-FFF2-40B4-BE49-F238E27FC236}">
+                <a16:creationId xmlns:a16="http://schemas.microsoft.com/office/drawing/2014/main" id="{BD2D3A69-A611-4C13-BC36-188BA689EB59}"/>
               </a:ext>
             </a:extLst>
           </p:cNvPr>
@@ -5565,7 +5565,7 @@
           <p:cNvPr id="10" name="">
             <a:extLst xmlns:a="http://schemas.openxmlformats.org/drawingml/2006/main">
               <a:ext uri="{FF2B5EF4-FFF2-40B4-BE49-F238E27FC236}">
-                <a16:creationId xmlns:a16="http://schemas.microsoft.com/office/drawing/2014/main" id="{0A064BFB-0564-4309-836D-A2DA0F983E57}"/>
+                <a16:creationId xmlns:a16="http://schemas.microsoft.com/office/drawing/2014/main" id="{2F434628-FF29-4C94-B4C4-67BD4190AD76}"/>
               </a:ext>
             </a:extLst>
           </p:cNvPr>
@@ -5595,10 +5595,10 @@
       </p:sp>
       <p:sp>
         <p:nvSpPr>
-          <p:cNvPr id="11" name="text-4b7rzevxh5e">
-            <a:extLst xmlns:a="http://schemas.openxmlformats.org/drawingml/2006/main">
-              <a:ext uri="{FF2B5EF4-FFF2-40B4-BE49-F238E27FC236}">
-                <a16:creationId xmlns:a16="http://schemas.microsoft.com/office/drawing/2014/main" id="{F1991C66-B6E4-40C0-9C91-A362EA8FF0A0}"/>
+          <p:cNvPr id="11" name="text-noexwmk7be">
+            <a:extLst xmlns:a="http://schemas.openxmlformats.org/drawingml/2006/main">
+              <a:ext uri="{FF2B5EF4-FFF2-40B4-BE49-F238E27FC236}">
+                <a16:creationId xmlns:a16="http://schemas.microsoft.com/office/drawing/2014/main" id="{34F1E619-6886-4AC2-85BD-CF43D125D8DE}"/>
               </a:ext>
             </a:extLst>
           </p:cNvPr>
@@ -5653,10 +5653,10 @@
       </p:sp>
       <p:sp>
         <p:nvSpPr>
-          <p:cNvPr id="12" name="text-j0wu3ah63f">
-            <a:extLst xmlns:a="http://schemas.openxmlformats.org/drawingml/2006/main">
-              <a:ext uri="{FF2B5EF4-FFF2-40B4-BE49-F238E27FC236}">
-                <a16:creationId xmlns:a16="http://schemas.microsoft.com/office/drawing/2014/main" id="{07041645-4A99-47D8-BB7A-84EDC26AEACF}"/>
+          <p:cNvPr id="12" name="text-t9uid2wb3bc">
+            <a:extLst xmlns:a="http://schemas.openxmlformats.org/drawingml/2006/main">
+              <a:ext uri="{FF2B5EF4-FFF2-40B4-BE49-F238E27FC236}">
+                <a16:creationId xmlns:a16="http://schemas.microsoft.com/office/drawing/2014/main" id="{9EBCB2D8-6D0E-4412-A09C-31E223C71DC7}"/>
               </a:ext>
             </a:extLst>
           </p:cNvPr>
@@ -5711,10 +5711,10 @@
       </p:sp>
       <p:sp>
         <p:nvSpPr>
-          <p:cNvPr id="13" name="text-ib2be7ngdnc">
-            <a:extLst xmlns:a="http://schemas.openxmlformats.org/drawingml/2006/main">
-              <a:ext uri="{FF2B5EF4-FFF2-40B4-BE49-F238E27FC236}">
-                <a16:creationId xmlns:a16="http://schemas.microsoft.com/office/drawing/2014/main" id="{5A757C0C-93F5-44D1-9ADA-A9201C641110}"/>
+          <p:cNvPr id="13" name="text-2uvh242hsfc">
+            <a:extLst xmlns:a="http://schemas.openxmlformats.org/drawingml/2006/main">
+              <a:ext uri="{FF2B5EF4-FFF2-40B4-BE49-F238E27FC236}">
+                <a16:creationId xmlns:a16="http://schemas.microsoft.com/office/drawing/2014/main" id="{FBCF0376-116F-42AD-871B-DB0097FAA9BD}"/>
               </a:ext>
             </a:extLst>
           </p:cNvPr>
@@ -5794,7 +5794,7 @@
           <p:cNvPr id="15" name="">
             <a:extLst xmlns:a="http://schemas.openxmlformats.org/drawingml/2006/main">
               <a:ext uri="{FF2B5EF4-FFF2-40B4-BE49-F238E27FC236}">
-                <a16:creationId xmlns:a16="http://schemas.microsoft.com/office/drawing/2014/main" id="{3FEBBE46-E192-4398-8651-15A030035800}"/>
+                <a16:creationId xmlns:a16="http://schemas.microsoft.com/office/drawing/2014/main" id="{995BB15D-2292-49A7-BF52-3AF0F3258FF8}"/>
               </a:ext>
             </a:extLst>
           </p:cNvPr>
@@ -5824,10 +5824,10 @@
       </p:sp>
       <p:sp>
         <p:nvSpPr>
-          <p:cNvPr id="16" name="text-8jyr7g4tttw">
-            <a:extLst xmlns:a="http://schemas.openxmlformats.org/drawingml/2006/main">
-              <a:ext uri="{FF2B5EF4-FFF2-40B4-BE49-F238E27FC236}">
-                <a16:creationId xmlns:a16="http://schemas.microsoft.com/office/drawing/2014/main" id="{311083B1-90B9-441A-AD25-D91025829588}"/>
+          <p:cNvPr id="16" name="text-1jx73s5ui53">
+            <a:extLst xmlns:a="http://schemas.openxmlformats.org/drawingml/2006/main">
+              <a:ext uri="{FF2B5EF4-FFF2-40B4-BE49-F238E27FC236}">
+                <a16:creationId xmlns:a16="http://schemas.microsoft.com/office/drawing/2014/main" id="{57EA9A2D-1D26-43C4-89F8-AEDDCD02F2C4}"/>
               </a:ext>
             </a:extLst>
           </p:cNvPr>
@@ -5882,10 +5882,10 @@
       </p:sp>
       <p:sp>
         <p:nvSpPr>
-          <p:cNvPr id="17" name="text-st3tuuorcds">
-            <a:extLst xmlns:a="http://schemas.openxmlformats.org/drawingml/2006/main">
-              <a:ext uri="{FF2B5EF4-FFF2-40B4-BE49-F238E27FC236}">
-                <a16:creationId xmlns:a16="http://schemas.microsoft.com/office/drawing/2014/main" id="{08630EE0-D959-4C56-B951-B3E6A44C6149}"/>
+          <p:cNvPr id="17" name="text-zkere0w1i8d">
+            <a:extLst xmlns:a="http://schemas.openxmlformats.org/drawingml/2006/main">
+              <a:ext uri="{FF2B5EF4-FFF2-40B4-BE49-F238E27FC236}">
+                <a16:creationId xmlns:a16="http://schemas.microsoft.com/office/drawing/2014/main" id="{8FC3DFA8-9FCC-4EC7-B898-0C9969406ACC}"/>
               </a:ext>
             </a:extLst>
           </p:cNvPr>
@@ -5940,10 +5940,10 @@
       </p:sp>
       <p:sp>
         <p:nvSpPr>
-          <p:cNvPr id="18" name="text-6v2twuk0l82">
-            <a:extLst xmlns:a="http://schemas.openxmlformats.org/drawingml/2006/main">
-              <a:ext uri="{FF2B5EF4-FFF2-40B4-BE49-F238E27FC236}">
-                <a16:creationId xmlns:a16="http://schemas.microsoft.com/office/drawing/2014/main" id="{E429FD7C-3783-40B6-B8E8-006B2F05FB4F}"/>
+          <p:cNvPr id="18" name="text-02s11z2wp3yh">
+            <a:extLst xmlns:a="http://schemas.openxmlformats.org/drawingml/2006/main">
+              <a:ext uri="{FF2B5EF4-FFF2-40B4-BE49-F238E27FC236}">
+                <a16:creationId xmlns:a16="http://schemas.microsoft.com/office/drawing/2014/main" id="{0DF8DCC1-5B69-486A-8DB1-BB00A0737B6D}"/>
               </a:ext>
             </a:extLst>
           </p:cNvPr>
@@ -6023,7 +6023,7 @@
           <p:cNvPr id="20" name="">
             <a:extLst xmlns:a="http://schemas.openxmlformats.org/drawingml/2006/main">
               <a:ext uri="{FF2B5EF4-FFF2-40B4-BE49-F238E27FC236}">
-                <a16:creationId xmlns:a16="http://schemas.microsoft.com/office/drawing/2014/main" id="{423E6899-964F-4194-BC42-418C4765FD75}"/>
+                <a16:creationId xmlns:a16="http://schemas.microsoft.com/office/drawing/2014/main" id="{27D69023-8B14-4BE3-A875-25460BE4437D}"/>
               </a:ext>
             </a:extLst>
           </p:cNvPr>
@@ -6053,10 +6053,10 @@
       </p:sp>
       <p:sp>
         <p:nvSpPr>
-          <p:cNvPr id="21" name="text-tougedmmh1i">
-            <a:extLst xmlns:a="http://schemas.openxmlformats.org/drawingml/2006/main">
-              <a:ext uri="{FF2B5EF4-FFF2-40B4-BE49-F238E27FC236}">
-                <a16:creationId xmlns:a16="http://schemas.microsoft.com/office/drawing/2014/main" id="{3B98A9CA-755C-4CA0-8DCE-AABFB6EA57D6}"/>
+          <p:cNvPr id="21" name="text-0aky9lr2sw4">
+            <a:extLst xmlns:a="http://schemas.openxmlformats.org/drawingml/2006/main">
+              <a:ext uri="{FF2B5EF4-FFF2-40B4-BE49-F238E27FC236}">
+                <a16:creationId xmlns:a16="http://schemas.microsoft.com/office/drawing/2014/main" id="{79C13ADC-EA3F-418F-AC0C-6CC320E5F6DE}"/>
               </a:ext>
             </a:extLst>
           </p:cNvPr>
@@ -6111,10 +6111,10 @@
       </p:sp>
       <p:sp>
         <p:nvSpPr>
-          <p:cNvPr id="22" name="text-p9nwjljdw8">
-            <a:extLst xmlns:a="http://schemas.openxmlformats.org/drawingml/2006/main">
-              <a:ext uri="{FF2B5EF4-FFF2-40B4-BE49-F238E27FC236}">
-                <a16:creationId xmlns:a16="http://schemas.microsoft.com/office/drawing/2014/main" id="{5CCDD840-EDEF-414B-ABEA-5FBB25D5C0CB}"/>
+          <p:cNvPr id="22" name="text-78welq56m5">
+            <a:extLst xmlns:a="http://schemas.openxmlformats.org/drawingml/2006/main">
+              <a:ext uri="{FF2B5EF4-FFF2-40B4-BE49-F238E27FC236}">
+                <a16:creationId xmlns:a16="http://schemas.microsoft.com/office/drawing/2014/main" id="{DCA96086-C7DA-4B8D-A984-A7B4CE870C8A}"/>
               </a:ext>
             </a:extLst>
           </p:cNvPr>
@@ -6169,10 +6169,10 @@
       </p:sp>
       <p:sp>
         <p:nvSpPr>
-          <p:cNvPr id="23" name="text-jo4i2ja1bwf">
-            <a:extLst xmlns:a="http://schemas.openxmlformats.org/drawingml/2006/main">
-              <a:ext uri="{FF2B5EF4-FFF2-40B4-BE49-F238E27FC236}">
-                <a16:creationId xmlns:a16="http://schemas.microsoft.com/office/drawing/2014/main" id="{961B909A-46C6-486B-B6FA-62197E718A82}"/>
+          <p:cNvPr id="23" name="text-knopsmybpnm">
+            <a:extLst xmlns:a="http://schemas.openxmlformats.org/drawingml/2006/main">
+              <a:ext uri="{FF2B5EF4-FFF2-40B4-BE49-F238E27FC236}">
+                <a16:creationId xmlns:a16="http://schemas.microsoft.com/office/drawing/2014/main" id="{67FE69CC-44DA-4F7E-B006-983623A438BF}"/>
               </a:ext>
             </a:extLst>
           </p:cNvPr>
@@ -6230,7 +6230,7 @@
           <p:cNvPr id="24" name="">
             <a:extLst xmlns:a="http://schemas.openxmlformats.org/drawingml/2006/main">
               <a:ext uri="{FF2B5EF4-FFF2-40B4-BE49-F238E27FC236}">
-                <a16:creationId xmlns:a16="http://schemas.microsoft.com/office/drawing/2014/main" id="{7DBFFDC9-3804-4A4E-B6B2-2F6FD92C98BA}"/>
+                <a16:creationId xmlns:a16="http://schemas.microsoft.com/office/drawing/2014/main" id="{40CE7840-E96F-4BA4-9539-398D6DCFCDC4}"/>
               </a:ext>
             </a:extLst>
           </p:cNvPr>
@@ -6260,10 +6260,10 @@
       </p:sp>
       <p:sp>
         <p:nvSpPr>
-          <p:cNvPr id="25" name="text-artp6p5g1fm">
-            <a:extLst xmlns:a="http://schemas.openxmlformats.org/drawingml/2006/main">
-              <a:ext uri="{FF2B5EF4-FFF2-40B4-BE49-F238E27FC236}">
-                <a16:creationId xmlns:a16="http://schemas.microsoft.com/office/drawing/2014/main" id="{8A0F986C-63F4-4D87-97AD-EF0C3DF9ADC2}"/>
+          <p:cNvPr id="25" name="text-odb97a6s0co">
+            <a:extLst xmlns:a="http://schemas.openxmlformats.org/drawingml/2006/main">
+              <a:ext uri="{FF2B5EF4-FFF2-40B4-BE49-F238E27FC236}">
+                <a16:creationId xmlns:a16="http://schemas.microsoft.com/office/drawing/2014/main" id="{729F2E18-6007-49BA-8227-1D0D320BEA79}"/>
               </a:ext>
             </a:extLst>
           </p:cNvPr>
@@ -6318,10 +6318,10 @@
       </p:sp>
       <p:sp>
         <p:nvSpPr>
-          <p:cNvPr id="26" name="text-6t5jqpckbf4">
-            <a:extLst xmlns:a="http://schemas.openxmlformats.org/drawingml/2006/main">
-              <a:ext uri="{FF2B5EF4-FFF2-40B4-BE49-F238E27FC236}">
-                <a16:creationId xmlns:a16="http://schemas.microsoft.com/office/drawing/2014/main" id="{AC313074-2DC7-4450-8301-FF681017BF6D}"/>
+          <p:cNvPr id="26" name="text-4a809a1bftf">
+            <a:extLst xmlns:a="http://schemas.openxmlformats.org/drawingml/2006/main">
+              <a:ext uri="{FF2B5EF4-FFF2-40B4-BE49-F238E27FC236}">
+                <a16:creationId xmlns:a16="http://schemas.microsoft.com/office/drawing/2014/main" id="{C676F80A-522A-4945-A3F2-979AE589385C}"/>
               </a:ext>
             </a:extLst>
           </p:cNvPr>
@@ -6376,10 +6376,10 @@
       </p:sp>
       <p:sp>
         <p:nvSpPr>
-          <p:cNvPr id="27" name="text-drf6smeguhk">
-            <a:extLst xmlns:a="http://schemas.openxmlformats.org/drawingml/2006/main">
-              <a:ext uri="{FF2B5EF4-FFF2-40B4-BE49-F238E27FC236}">
-                <a16:creationId xmlns:a16="http://schemas.microsoft.com/office/drawing/2014/main" id="{6685BF93-A972-4085-A4DA-609ED77D53AC}"/>
+          <p:cNvPr id="27" name="text-xkftoltty0n">
+            <a:extLst xmlns:a="http://schemas.openxmlformats.org/drawingml/2006/main">
+              <a:ext uri="{FF2B5EF4-FFF2-40B4-BE49-F238E27FC236}">
+                <a16:creationId xmlns:a16="http://schemas.microsoft.com/office/drawing/2014/main" id="{7FB0ED9D-18DB-410F-89DF-B482B65CE089}"/>
               </a:ext>
             </a:extLst>
           </p:cNvPr>
@@ -6437,7 +6437,7 @@
           <p:cNvPr id="28" name="">
             <a:extLst xmlns:a="http://schemas.openxmlformats.org/drawingml/2006/main">
               <a:ext uri="{FF2B5EF4-FFF2-40B4-BE49-F238E27FC236}">
-                <a16:creationId xmlns:a16="http://schemas.microsoft.com/office/drawing/2014/main" id="{4E66DD39-E3B7-4767-9159-6DCF60C505EE}"/>
+                <a16:creationId xmlns:a16="http://schemas.microsoft.com/office/drawing/2014/main" id="{A7224E48-F86B-46FE-9AF6-B9E1C7E31C89}"/>
               </a:ext>
             </a:extLst>
           </p:cNvPr>
@@ -6465,10 +6465,10 @@
       </p:sp>
       <p:sp>
         <p:nvSpPr>
-          <p:cNvPr id="29" name="text-eo3te519rgn">
-            <a:extLst xmlns:a="http://schemas.openxmlformats.org/drawingml/2006/main">
-              <a:ext uri="{FF2B5EF4-FFF2-40B4-BE49-F238E27FC236}">
-                <a16:creationId xmlns:a16="http://schemas.microsoft.com/office/drawing/2014/main" id="{AA1B45FE-86A3-42D0-9422-F9F1438526D3}"/>
+          <p:cNvPr id="29" name="text-6menv0mdbz">
+            <a:extLst xmlns:a="http://schemas.openxmlformats.org/drawingml/2006/main">
+              <a:ext uri="{FF2B5EF4-FFF2-40B4-BE49-F238E27FC236}">
+                <a16:creationId xmlns:a16="http://schemas.microsoft.com/office/drawing/2014/main" id="{73C4E757-CE4A-4677-A8F7-0F82BDF6E6B3}"/>
               </a:ext>
             </a:extLst>
           </p:cNvPr>
@@ -6524,7 +6524,7 @@
     </p:spTree>
     <p:extLst>
       <p:ext uri="{BB962C8B-B14F-4D97-AF65-F5344CB8AC3E}">
-        <p14:creationId xmlns:p14="http://schemas.microsoft.com/office/powerpoint/2010/main" val="60015171"/>
+        <p14:creationId xmlns:p14="http://schemas.microsoft.com/office/powerpoint/2010/main" val="715472734"/>
       </p:ext>
     </p:extLst>
   </p:cSld>
@@ -6552,10 +6552,10 @@
       </p:grpSpPr>
       <p:sp>
         <p:nvSpPr>
-          <p:cNvPr id="21" name="text-ezk6t226o95">
-            <a:extLst xmlns:a="http://schemas.openxmlformats.org/drawingml/2006/main">
-              <a:ext uri="{FF2B5EF4-FFF2-40B4-BE49-F238E27FC236}">
-                <a16:creationId xmlns:a16="http://schemas.microsoft.com/office/drawing/2014/main" id="{18D7A80C-2B00-453D-8024-79C1C1CC8731}"/>
+          <p:cNvPr id="21" name="text-qkgwcp0dnz8">
+            <a:extLst xmlns:a="http://schemas.openxmlformats.org/drawingml/2006/main">
+              <a:ext uri="{FF2B5EF4-FFF2-40B4-BE49-F238E27FC236}">
+                <a16:creationId xmlns:a16="http://schemas.microsoft.com/office/drawing/2014/main" id="{24D338DE-63C8-4240-B497-7B16965926C5}"/>
               </a:ext>
             </a:extLst>
           </p:cNvPr>
@@ -6610,10 +6610,10 @@
       </p:sp>
       <p:sp>
         <p:nvSpPr>
-          <p:cNvPr id="2" name="text-2svrulqh2uc">
-            <a:extLst xmlns:a="http://schemas.openxmlformats.org/drawingml/2006/main">
-              <a:ext uri="{FF2B5EF4-FFF2-40B4-BE49-F238E27FC236}">
-                <a16:creationId xmlns:a16="http://schemas.microsoft.com/office/drawing/2014/main" id="{6DC997A7-53FE-4831-B992-A6F93A5064EC}"/>
+          <p:cNvPr id="2" name="text-3vyy36edu0a">
+            <a:extLst xmlns:a="http://schemas.openxmlformats.org/drawingml/2006/main">
+              <a:ext uri="{FF2B5EF4-FFF2-40B4-BE49-F238E27FC236}">
+                <a16:creationId xmlns:a16="http://schemas.microsoft.com/office/drawing/2014/main" id="{D3ADD4F4-D564-4531-8F2D-EB6F17D373F2}"/>
               </a:ext>
             </a:extLst>
           </p:cNvPr>
@@ -6668,10 +6668,10 @@
       </p:sp>
       <p:sp>
         <p:nvSpPr>
-          <p:cNvPr id="3" name="text-h5a1ht08mbn">
-            <a:extLst xmlns:a="http://schemas.openxmlformats.org/drawingml/2006/main">
-              <a:ext uri="{FF2B5EF4-FFF2-40B4-BE49-F238E27FC236}">
-                <a16:creationId xmlns:a16="http://schemas.microsoft.com/office/drawing/2014/main" id="{2390D1C0-8408-424D-B9D1-B3AC848379FF}"/>
+          <p:cNvPr id="3" name="text-27x8raci1ms">
+            <a:extLst xmlns:a="http://schemas.openxmlformats.org/drawingml/2006/main">
+              <a:ext uri="{FF2B5EF4-FFF2-40B4-BE49-F238E27FC236}">
+                <a16:creationId xmlns:a16="http://schemas.microsoft.com/office/drawing/2014/main" id="{2FFA84F1-BC3D-4B61-B405-2D223E14FD53}"/>
               </a:ext>
             </a:extLst>
           </p:cNvPr>
@@ -6726,10 +6726,10 @@
       </p:sp>
       <p:sp>
         <p:nvSpPr>
-          <p:cNvPr id="4" name="text-wog7r3p5kd9">
-            <a:extLst xmlns:a="http://schemas.openxmlformats.org/drawingml/2006/main">
-              <a:ext uri="{FF2B5EF4-FFF2-40B4-BE49-F238E27FC236}">
-                <a16:creationId xmlns:a16="http://schemas.microsoft.com/office/drawing/2014/main" id="{061B527C-8E41-43C8-B02B-B72AF3F6DA84}"/>
+          <p:cNvPr id="4" name="text-2y1klvdas7h">
+            <a:extLst xmlns:a="http://schemas.openxmlformats.org/drawingml/2006/main">
+              <a:ext uri="{FF2B5EF4-FFF2-40B4-BE49-F238E27FC236}">
+                <a16:creationId xmlns:a16="http://schemas.microsoft.com/office/drawing/2014/main" id="{83B29B75-5058-4A21-8F04-4D95965B0E29}"/>
               </a:ext>
             </a:extLst>
           </p:cNvPr>
@@ -6784,10 +6784,10 @@
       </p:sp>
       <p:sp>
         <p:nvSpPr>
-          <p:cNvPr id="5" name="text-i3lh2jgk52">
-            <a:extLst xmlns:a="http://schemas.openxmlformats.org/drawingml/2006/main">
-              <a:ext uri="{FF2B5EF4-FFF2-40B4-BE49-F238E27FC236}">
-                <a16:creationId xmlns:a16="http://schemas.microsoft.com/office/drawing/2014/main" id="{DF22C507-8BF8-4F92-89BB-606CAB7A151D}"/>
+          <p:cNvPr id="5" name="text-fpxqqkf7wr8">
+            <a:extLst xmlns:a="http://schemas.openxmlformats.org/drawingml/2006/main">
+              <a:ext uri="{FF2B5EF4-FFF2-40B4-BE49-F238E27FC236}">
+                <a16:creationId xmlns:a16="http://schemas.microsoft.com/office/drawing/2014/main" id="{15D91390-0384-44AE-A03A-B8781628248F}"/>
               </a:ext>
             </a:extLst>
           </p:cNvPr>
@@ -6842,10 +6842,10 @@
       </p:sp>
       <p:sp>
         <p:nvSpPr>
-          <p:cNvPr id="6" name="text-ku2tlwoiymg">
-            <a:extLst xmlns:a="http://schemas.openxmlformats.org/drawingml/2006/main">
-              <a:ext uri="{FF2B5EF4-FFF2-40B4-BE49-F238E27FC236}">
-                <a16:creationId xmlns:a16="http://schemas.microsoft.com/office/drawing/2014/main" id="{278874EE-34A8-44CD-BD01-C6744EA628D4}"/>
+          <p:cNvPr id="6" name="text-u0lhvivbe4f">
+            <a:extLst xmlns:a="http://schemas.openxmlformats.org/drawingml/2006/main">
+              <a:ext uri="{FF2B5EF4-FFF2-40B4-BE49-F238E27FC236}">
+                <a16:creationId xmlns:a16="http://schemas.microsoft.com/office/drawing/2014/main" id="{DE67C67C-D584-495B-8EC8-53203EB16430}"/>
               </a:ext>
             </a:extLst>
           </p:cNvPr>
@@ -6922,10 +6922,10 @@
       </p:cxnSp>
       <p:sp>
         <p:nvSpPr>
-          <p:cNvPr id="8" name="text-9zj402b95wh">
-            <a:extLst xmlns:a="http://schemas.openxmlformats.org/drawingml/2006/main">
-              <a:ext uri="{FF2B5EF4-FFF2-40B4-BE49-F238E27FC236}">
-                <a16:creationId xmlns:a16="http://schemas.microsoft.com/office/drawing/2014/main" id="{5170DF22-D7B0-405F-A809-B5A230504E66}"/>
+          <p:cNvPr id="8" name="text-7fd0bk02a5">
+            <a:extLst xmlns:a="http://schemas.openxmlformats.org/drawingml/2006/main">
+              <a:ext uri="{FF2B5EF4-FFF2-40B4-BE49-F238E27FC236}">
+                <a16:creationId xmlns:a16="http://schemas.microsoft.com/office/drawing/2014/main" id="{25F22BD3-80D8-4EEB-967E-9E090E7557CB}"/>
               </a:ext>
             </a:extLst>
           </p:cNvPr>
@@ -6980,10 +6980,10 @@
       </p:sp>
       <p:sp>
         <p:nvSpPr>
-          <p:cNvPr id="9" name="text-rxk32hyct2b">
-            <a:extLst xmlns:a="http://schemas.openxmlformats.org/drawingml/2006/main">
-              <a:ext uri="{FF2B5EF4-FFF2-40B4-BE49-F238E27FC236}">
-                <a16:creationId xmlns:a16="http://schemas.microsoft.com/office/drawing/2014/main" id="{2529B5D6-9E31-4EB3-80E1-F8E5E56EB083}"/>
+          <p:cNvPr id="9" name="text-a4iace6f8i6">
+            <a:extLst xmlns:a="http://schemas.openxmlformats.org/drawingml/2006/main">
+              <a:ext uri="{FF2B5EF4-FFF2-40B4-BE49-F238E27FC236}">
+                <a16:creationId xmlns:a16="http://schemas.microsoft.com/office/drawing/2014/main" id="{31436091-B1DC-4707-8DA7-C3BA51C88178}"/>
               </a:ext>
             </a:extLst>
           </p:cNvPr>
@@ -7038,10 +7038,10 @@
       </p:sp>
       <p:sp>
         <p:nvSpPr>
-          <p:cNvPr id="10" name="text-ypkltu30mz">
-            <a:extLst xmlns:a="http://schemas.openxmlformats.org/drawingml/2006/main">
-              <a:ext uri="{FF2B5EF4-FFF2-40B4-BE49-F238E27FC236}">
-                <a16:creationId xmlns:a16="http://schemas.microsoft.com/office/drawing/2014/main" id="{85D5F42A-5745-4E78-B348-5654544CA2BF}"/>
+          <p:cNvPr id="10" name="text-d64gnzvloub">
+            <a:extLst xmlns:a="http://schemas.openxmlformats.org/drawingml/2006/main">
+              <a:ext uri="{FF2B5EF4-FFF2-40B4-BE49-F238E27FC236}">
+                <a16:creationId xmlns:a16="http://schemas.microsoft.com/office/drawing/2014/main" id="{DFB5AADF-3B7A-4545-B1A1-E2B837073AE1}"/>
               </a:ext>
             </a:extLst>
           </p:cNvPr>
@@ -7118,10 +7118,10 @@
       </p:cxnSp>
       <p:sp>
         <p:nvSpPr>
-          <p:cNvPr id="12" name="text-59iw1t0pjd7">
-            <a:extLst xmlns:a="http://schemas.openxmlformats.org/drawingml/2006/main">
-              <a:ext uri="{FF2B5EF4-FFF2-40B4-BE49-F238E27FC236}">
-                <a16:creationId xmlns:a16="http://schemas.microsoft.com/office/drawing/2014/main" id="{D1C55945-605E-463D-99B6-9C0A0D211CB2}"/>
+          <p:cNvPr id="12" name="text-t3pqn9dfs7b">
+            <a:extLst xmlns:a="http://schemas.openxmlformats.org/drawingml/2006/main">
+              <a:ext uri="{FF2B5EF4-FFF2-40B4-BE49-F238E27FC236}">
+                <a16:creationId xmlns:a16="http://schemas.microsoft.com/office/drawing/2014/main" id="{F447F6DD-F3F2-4396-9EC9-A7E7B66EC851}"/>
               </a:ext>
             </a:extLst>
           </p:cNvPr>
@@ -7176,10 +7176,10 @@
       </p:sp>
       <p:sp>
         <p:nvSpPr>
-          <p:cNvPr id="13" name="text-igl3b2awcjl">
-            <a:extLst xmlns:a="http://schemas.openxmlformats.org/drawingml/2006/main">
-              <a:ext uri="{FF2B5EF4-FFF2-40B4-BE49-F238E27FC236}">
-                <a16:creationId xmlns:a16="http://schemas.microsoft.com/office/drawing/2014/main" id="{88E41748-1C10-47D3-B82C-4DD2B490C299}"/>
+          <p:cNvPr id="13" name="text-ksjn65gl71l">
+            <a:extLst xmlns:a="http://schemas.openxmlformats.org/drawingml/2006/main">
+              <a:ext uri="{FF2B5EF4-FFF2-40B4-BE49-F238E27FC236}">
+                <a16:creationId xmlns:a16="http://schemas.microsoft.com/office/drawing/2014/main" id="{9E5360D2-C9B8-4B7D-A052-6CF0C58119DC}"/>
               </a:ext>
             </a:extLst>
           </p:cNvPr>
@@ -7234,10 +7234,10 @@
       </p:sp>
       <p:sp>
         <p:nvSpPr>
-          <p:cNvPr id="14" name="text-b4o899d2syu">
-            <a:extLst xmlns:a="http://schemas.openxmlformats.org/drawingml/2006/main">
-              <a:ext uri="{FF2B5EF4-FFF2-40B4-BE49-F238E27FC236}">
-                <a16:creationId xmlns:a16="http://schemas.microsoft.com/office/drawing/2014/main" id="{C26D49FE-4599-43E1-A8DD-F5EBE45B79EB}"/>
+          <p:cNvPr id="14" name="text-48i9dk5t3vd">
+            <a:extLst xmlns:a="http://schemas.openxmlformats.org/drawingml/2006/main">
+              <a:ext uri="{FF2B5EF4-FFF2-40B4-BE49-F238E27FC236}">
+                <a16:creationId xmlns:a16="http://schemas.microsoft.com/office/drawing/2014/main" id="{3BB23C1C-43EC-4D8B-911C-F9A1768FBA9B}"/>
               </a:ext>
             </a:extLst>
           </p:cNvPr>
@@ -7314,10 +7314,10 @@
       </p:cxnSp>
       <p:sp>
         <p:nvSpPr>
-          <p:cNvPr id="16" name="text-9ca3nh9gclc">
-            <a:extLst xmlns:a="http://schemas.openxmlformats.org/drawingml/2006/main">
-              <a:ext uri="{FF2B5EF4-FFF2-40B4-BE49-F238E27FC236}">
-                <a16:creationId xmlns:a16="http://schemas.microsoft.com/office/drawing/2014/main" id="{0759E8BC-AA2F-443E-8359-9D2B478F962E}"/>
+          <p:cNvPr id="16" name="text-cj7ayd3h6i">
+            <a:extLst xmlns:a="http://schemas.openxmlformats.org/drawingml/2006/main">
+              <a:ext uri="{FF2B5EF4-FFF2-40B4-BE49-F238E27FC236}">
+                <a16:creationId xmlns:a16="http://schemas.microsoft.com/office/drawing/2014/main" id="{150B6AF0-5D90-47BF-876A-94AD05DA3BDA}"/>
               </a:ext>
             </a:extLst>
           </p:cNvPr>
@@ -7372,10 +7372,10 @@
       </p:sp>
       <p:sp>
         <p:nvSpPr>
-          <p:cNvPr id="17" name="text-5zg24cadm7a">
-            <a:extLst xmlns:a="http://schemas.openxmlformats.org/drawingml/2006/main">
-              <a:ext uri="{FF2B5EF4-FFF2-40B4-BE49-F238E27FC236}">
-                <a16:creationId xmlns:a16="http://schemas.microsoft.com/office/drawing/2014/main" id="{AA29A773-9C45-4031-AB59-848D7C88D7A6}"/>
+          <p:cNvPr id="17" name="text-xj22kkvh4d">
+            <a:extLst xmlns:a="http://schemas.openxmlformats.org/drawingml/2006/main">
+              <a:ext uri="{FF2B5EF4-FFF2-40B4-BE49-F238E27FC236}">
+                <a16:creationId xmlns:a16="http://schemas.microsoft.com/office/drawing/2014/main" id="{C1BCCC5B-51B7-4C72-9CAB-C9C153A5F521}"/>
               </a:ext>
             </a:extLst>
           </p:cNvPr>
@@ -7430,10 +7430,10 @@
       </p:sp>
       <p:sp>
         <p:nvSpPr>
-          <p:cNvPr id="18" name="text-qa025tmsj6">
-            <a:extLst xmlns:a="http://schemas.openxmlformats.org/drawingml/2006/main">
-              <a:ext uri="{FF2B5EF4-FFF2-40B4-BE49-F238E27FC236}">
-                <a16:creationId xmlns:a16="http://schemas.microsoft.com/office/drawing/2014/main" id="{CB19A98D-9848-4350-9A17-84A0B8F0E9D4}"/>
+          <p:cNvPr id="18" name="text-flctbipyixc">
+            <a:extLst xmlns:a="http://schemas.openxmlformats.org/drawingml/2006/main">
+              <a:ext uri="{FF2B5EF4-FFF2-40B4-BE49-F238E27FC236}">
+                <a16:creationId xmlns:a16="http://schemas.microsoft.com/office/drawing/2014/main" id="{CDC6637A-CE64-460C-8B38-D56DE87C7345}"/>
               </a:ext>
             </a:extLst>
           </p:cNvPr>
@@ -7510,10 +7510,10 @@
       </p:cxnSp>
       <p:sp>
         <p:nvSpPr>
-          <p:cNvPr id="20" name="text-b0n15ieviw5">
-            <a:extLst xmlns:a="http://schemas.openxmlformats.org/drawingml/2006/main">
-              <a:ext uri="{FF2B5EF4-FFF2-40B4-BE49-F238E27FC236}">
-                <a16:creationId xmlns:a16="http://schemas.microsoft.com/office/drawing/2014/main" id="{8F787432-E13D-4E2F-B8F4-8D7D2BA5AE2E}"/>
+          <p:cNvPr id="20" name="text-1tttc08m4om">
+            <a:extLst xmlns:a="http://schemas.openxmlformats.org/drawingml/2006/main">
+              <a:ext uri="{FF2B5EF4-FFF2-40B4-BE49-F238E27FC236}">
+                <a16:creationId xmlns:a16="http://schemas.microsoft.com/office/drawing/2014/main" id="{DF4B3825-0BA7-4C99-B8CF-FA4E0AEFC413}"/>
               </a:ext>
             </a:extLst>
           </p:cNvPr>
@@ -7569,7 +7569,7 @@
     </p:spTree>
     <p:extLst>
       <p:ext uri="{BB962C8B-B14F-4D97-AF65-F5344CB8AC3E}">
-        <p14:creationId xmlns:p14="http://schemas.microsoft.com/office/powerpoint/2010/main" val="1266273950"/>
+        <p14:creationId xmlns:p14="http://schemas.microsoft.com/office/powerpoint/2010/main" val="1801103638"/>
       </p:ext>
     </p:extLst>
   </p:cSld>
@@ -7597,10 +7597,10 @@
       </p:grpSpPr>
       <p:sp>
         <p:nvSpPr>
-          <p:cNvPr id="24" name="text-chyaykxcsd">
-            <a:extLst xmlns:a="http://schemas.openxmlformats.org/drawingml/2006/main">
-              <a:ext uri="{FF2B5EF4-FFF2-40B4-BE49-F238E27FC236}">
-                <a16:creationId xmlns:a16="http://schemas.microsoft.com/office/drawing/2014/main" id="{308E40C4-4A80-485C-A1A2-C8243F74686B}"/>
+          <p:cNvPr id="24" name="text-1xmmfih4bkb">
+            <a:extLst xmlns:a="http://schemas.openxmlformats.org/drawingml/2006/main">
+              <a:ext uri="{FF2B5EF4-FFF2-40B4-BE49-F238E27FC236}">
+                <a16:creationId xmlns:a16="http://schemas.microsoft.com/office/drawing/2014/main" id="{042F611D-47BE-44DE-B65F-638F2E7B69A5}"/>
               </a:ext>
             </a:extLst>
           </p:cNvPr>
@@ -7655,10 +7655,10 @@
       </p:sp>
       <p:sp>
         <p:nvSpPr>
-          <p:cNvPr id="2" name="text-46ujwvxn0ye">
-            <a:extLst xmlns:a="http://schemas.openxmlformats.org/drawingml/2006/main">
-              <a:ext uri="{FF2B5EF4-FFF2-40B4-BE49-F238E27FC236}">
-                <a16:creationId xmlns:a16="http://schemas.microsoft.com/office/drawing/2014/main" id="{69505470-B654-482E-AFE3-6C06B72EEC28}"/>
+          <p:cNvPr id="2" name="text-ise5gmn6gj">
+            <a:extLst xmlns:a="http://schemas.openxmlformats.org/drawingml/2006/main">
+              <a:ext uri="{FF2B5EF4-FFF2-40B4-BE49-F238E27FC236}">
+                <a16:creationId xmlns:a16="http://schemas.microsoft.com/office/drawing/2014/main" id="{D7AD2B58-2F65-4C5A-B53A-BCD5842EA38F}"/>
               </a:ext>
             </a:extLst>
           </p:cNvPr>
@@ -7713,10 +7713,10 @@
       </p:sp>
       <p:sp>
         <p:nvSpPr>
-          <p:cNvPr id="3" name="text-9urpkv2r73l">
-            <a:extLst xmlns:a="http://schemas.openxmlformats.org/drawingml/2006/main">
-              <a:ext uri="{FF2B5EF4-FFF2-40B4-BE49-F238E27FC236}">
-                <a16:creationId xmlns:a16="http://schemas.microsoft.com/office/drawing/2014/main" id="{1AE46A57-3F5B-4459-A1F4-B431014BE9EB}"/>
+          <p:cNvPr id="3" name="text-qoi7ua0llom">
+            <a:extLst xmlns:a="http://schemas.openxmlformats.org/drawingml/2006/main">
+              <a:ext uri="{FF2B5EF4-FFF2-40B4-BE49-F238E27FC236}">
+                <a16:creationId xmlns:a16="http://schemas.microsoft.com/office/drawing/2014/main" id="{08371C3C-EE3F-4E23-A6BE-E2257F4CA121}"/>
               </a:ext>
             </a:extLst>
           </p:cNvPr>
@@ -7774,7 +7774,7 @@
           <p:cNvPr id="4" name="">
             <a:extLst xmlns:a="http://schemas.openxmlformats.org/drawingml/2006/main">
               <a:ext uri="{FF2B5EF4-FFF2-40B4-BE49-F238E27FC236}">
-                <a16:creationId xmlns:a16="http://schemas.microsoft.com/office/drawing/2014/main" id="{00BE0D71-F48B-4D28-953C-D809BB176ED1}"/>
+                <a16:creationId xmlns:a16="http://schemas.microsoft.com/office/drawing/2014/main" id="{B6E8B376-4A2E-4A99-8947-60371F960CE1}"/>
               </a:ext>
             </a:extLst>
           </p:cNvPr>
@@ -7802,10 +7802,10 @@
       </p:sp>
       <p:sp>
         <p:nvSpPr>
-          <p:cNvPr id="5" name="text-9zfjtbsd52">
-            <a:extLst xmlns:a="http://schemas.openxmlformats.org/drawingml/2006/main">
-              <a:ext uri="{FF2B5EF4-FFF2-40B4-BE49-F238E27FC236}">
-                <a16:creationId xmlns:a16="http://schemas.microsoft.com/office/drawing/2014/main" id="{A6CD62E2-48BD-449F-9E20-42768C582934}"/>
+          <p:cNvPr id="5" name="text-b6w07heyx3">
+            <a:extLst xmlns:a="http://schemas.openxmlformats.org/drawingml/2006/main">
+              <a:ext uri="{FF2B5EF4-FFF2-40B4-BE49-F238E27FC236}">
+                <a16:creationId xmlns:a16="http://schemas.microsoft.com/office/drawing/2014/main" id="{0C34F00B-DBEE-4A9D-90A5-5953A5427680}"/>
               </a:ext>
             </a:extLst>
           </p:cNvPr>
@@ -7860,10 +7860,10 @@
       </p:sp>
       <p:sp>
         <p:nvSpPr>
-          <p:cNvPr id="6" name="text-75cn0lkcavl">
-            <a:extLst xmlns:a="http://schemas.openxmlformats.org/drawingml/2006/main">
-              <a:ext uri="{FF2B5EF4-FFF2-40B4-BE49-F238E27FC236}">
-                <a16:creationId xmlns:a16="http://schemas.microsoft.com/office/drawing/2014/main" id="{A0C72AE6-641F-4069-AE08-83DEC2DC6205}"/>
+          <p:cNvPr id="6" name="text-11o9nsoy37m">
+            <a:extLst xmlns:a="http://schemas.openxmlformats.org/drawingml/2006/main">
+              <a:ext uri="{FF2B5EF4-FFF2-40B4-BE49-F238E27FC236}">
+                <a16:creationId xmlns:a16="http://schemas.microsoft.com/office/drawing/2014/main" id="{66A6ED81-806B-438F-A95A-C0AEAB6E3757}"/>
               </a:ext>
             </a:extLst>
           </p:cNvPr>
@@ -7918,10 +7918,10 @@
       </p:sp>
       <p:sp>
         <p:nvSpPr>
-          <p:cNvPr id="7" name="text-1v80yfpynu5h">
-            <a:extLst xmlns:a="http://schemas.openxmlformats.org/drawingml/2006/main">
-              <a:ext uri="{FF2B5EF4-FFF2-40B4-BE49-F238E27FC236}">
-                <a16:creationId xmlns:a16="http://schemas.microsoft.com/office/drawing/2014/main" id="{C643F5F6-0113-4080-A625-B024239CC5ED}"/>
+          <p:cNvPr id="7" name="text-16otnfmggxf">
+            <a:extLst xmlns:a="http://schemas.openxmlformats.org/drawingml/2006/main">
+              <a:ext uri="{FF2B5EF4-FFF2-40B4-BE49-F238E27FC236}">
+                <a16:creationId xmlns:a16="http://schemas.microsoft.com/office/drawing/2014/main" id="{AB829270-7B50-4B20-B934-8E40EC79707A}"/>
               </a:ext>
             </a:extLst>
           </p:cNvPr>
@@ -7976,10 +7976,10 @@
       </p:sp>
       <p:sp>
         <p:nvSpPr>
-          <p:cNvPr id="8" name="text-f2wffttof85">
-            <a:extLst xmlns:a="http://schemas.openxmlformats.org/drawingml/2006/main">
-              <a:ext uri="{FF2B5EF4-FFF2-40B4-BE49-F238E27FC236}">
-                <a16:creationId xmlns:a16="http://schemas.microsoft.com/office/drawing/2014/main" id="{FBC722FC-D014-48A7-8B9A-F2D99374645E}"/>
+          <p:cNvPr id="8" name="text-yp2e6vjwvd9">
+            <a:extLst xmlns:a="http://schemas.openxmlformats.org/drawingml/2006/main">
+              <a:ext uri="{FF2B5EF4-FFF2-40B4-BE49-F238E27FC236}">
+                <a16:creationId xmlns:a16="http://schemas.microsoft.com/office/drawing/2014/main" id="{3DA74DBA-F1FA-47C3-AECF-D1CA04EDEF8A}"/>
               </a:ext>
             </a:extLst>
           </p:cNvPr>
@@ -8034,10 +8034,10 @@
       </p:sp>
       <p:sp>
         <p:nvSpPr>
-          <p:cNvPr id="9" name="text-cfj67wlpllb">
-            <a:extLst xmlns:a="http://schemas.openxmlformats.org/drawingml/2006/main">
-              <a:ext uri="{FF2B5EF4-FFF2-40B4-BE49-F238E27FC236}">
-                <a16:creationId xmlns:a16="http://schemas.microsoft.com/office/drawing/2014/main" id="{14385C1B-2903-4367-975F-344B44A19661}"/>
+          <p:cNvPr id="9" name="text-ls3jtfhz6y">
+            <a:extLst xmlns:a="http://schemas.openxmlformats.org/drawingml/2006/main">
+              <a:ext uri="{FF2B5EF4-FFF2-40B4-BE49-F238E27FC236}">
+                <a16:creationId xmlns:a16="http://schemas.microsoft.com/office/drawing/2014/main" id="{618C8775-1960-4344-ABE2-B1B8FB8EE325}"/>
               </a:ext>
             </a:extLst>
           </p:cNvPr>
@@ -8114,10 +8114,10 @@
       </p:cxnSp>
       <p:sp>
         <p:nvSpPr>
-          <p:cNvPr id="11" name="text-oicyoyt25k9">
-            <a:extLst xmlns:a="http://schemas.openxmlformats.org/drawingml/2006/main">
-              <a:ext uri="{FF2B5EF4-FFF2-40B4-BE49-F238E27FC236}">
-                <a16:creationId xmlns:a16="http://schemas.microsoft.com/office/drawing/2014/main" id="{AF78F4BA-C1EF-4BCE-AF8F-83694F5F660E}"/>
+          <p:cNvPr id="11" name="text-qphezpm9sta">
+            <a:extLst xmlns:a="http://schemas.openxmlformats.org/drawingml/2006/main">
+              <a:ext uri="{FF2B5EF4-FFF2-40B4-BE49-F238E27FC236}">
+                <a16:creationId xmlns:a16="http://schemas.microsoft.com/office/drawing/2014/main" id="{85E0D1BE-7C8D-4FAF-98D2-3986BCED5A77}"/>
               </a:ext>
             </a:extLst>
           </p:cNvPr>
@@ -8172,10 +8172,10 @@
       </p:sp>
       <p:sp>
         <p:nvSpPr>
-          <p:cNvPr id="12" name="text-lmbb65qbe9t">
-            <a:extLst xmlns:a="http://schemas.openxmlformats.org/drawingml/2006/main">
-              <a:ext uri="{FF2B5EF4-FFF2-40B4-BE49-F238E27FC236}">
-                <a16:creationId xmlns:a16="http://schemas.microsoft.com/office/drawing/2014/main" id="{41ED62DB-08AA-4008-8CAC-ED0850683DE8}"/>
+          <p:cNvPr id="12" name="text-fcd4nxx3y1v">
+            <a:extLst xmlns:a="http://schemas.openxmlformats.org/drawingml/2006/main">
+              <a:ext uri="{FF2B5EF4-FFF2-40B4-BE49-F238E27FC236}">
+                <a16:creationId xmlns:a16="http://schemas.microsoft.com/office/drawing/2014/main" id="{BAFF0C77-55E4-4865-9429-06CC52B7183C}"/>
               </a:ext>
             </a:extLst>
           </p:cNvPr>
@@ -8252,10 +8252,10 @@
       </p:cxnSp>
       <p:sp>
         <p:nvSpPr>
-          <p:cNvPr id="14" name="text-7zyd4fmbxy">
-            <a:extLst xmlns:a="http://schemas.openxmlformats.org/drawingml/2006/main">
-              <a:ext uri="{FF2B5EF4-FFF2-40B4-BE49-F238E27FC236}">
-                <a16:creationId xmlns:a16="http://schemas.microsoft.com/office/drawing/2014/main" id="{E4C3A0A6-EF14-4C96-A02C-289FDF726596}"/>
+          <p:cNvPr id="14" name="text-624kn0hjp77">
+            <a:extLst xmlns:a="http://schemas.openxmlformats.org/drawingml/2006/main">
+              <a:ext uri="{FF2B5EF4-FFF2-40B4-BE49-F238E27FC236}">
+                <a16:creationId xmlns:a16="http://schemas.microsoft.com/office/drawing/2014/main" id="{F5874BF8-E5B6-48DF-99EF-31E825270ECA}"/>
               </a:ext>
             </a:extLst>
           </p:cNvPr>
@@ -8310,10 +8310,10 @@
       </p:sp>
       <p:sp>
         <p:nvSpPr>
-          <p:cNvPr id="15" name="text-v5if8r2msl">
-            <a:extLst xmlns:a="http://schemas.openxmlformats.org/drawingml/2006/main">
-              <a:ext uri="{FF2B5EF4-FFF2-40B4-BE49-F238E27FC236}">
-                <a16:creationId xmlns:a16="http://schemas.microsoft.com/office/drawing/2014/main" id="{489C2833-2D60-4501-B029-0BF86F3B4601}"/>
+          <p:cNvPr id="15" name="text-fqpq0k3dprm">
+            <a:extLst xmlns:a="http://schemas.openxmlformats.org/drawingml/2006/main">
+              <a:ext uri="{FF2B5EF4-FFF2-40B4-BE49-F238E27FC236}">
+                <a16:creationId xmlns:a16="http://schemas.microsoft.com/office/drawing/2014/main" id="{D4DA95BA-15D3-401B-BE9E-FE954E42F678}"/>
               </a:ext>
             </a:extLst>
           </p:cNvPr>
@@ -8390,10 +8390,10 @@
       </p:cxnSp>
       <p:sp>
         <p:nvSpPr>
-          <p:cNvPr id="17" name="text-xq6yfg4yh">
-            <a:extLst xmlns:a="http://schemas.openxmlformats.org/drawingml/2006/main">
-              <a:ext uri="{FF2B5EF4-FFF2-40B4-BE49-F238E27FC236}">
-                <a16:creationId xmlns:a16="http://schemas.microsoft.com/office/drawing/2014/main" id="{87FF4527-164A-4053-9269-52438FB82422}"/>
+          <p:cNvPr id="17" name="text-euas1astodb">
+            <a:extLst xmlns:a="http://schemas.openxmlformats.org/drawingml/2006/main">
+              <a:ext uri="{FF2B5EF4-FFF2-40B4-BE49-F238E27FC236}">
+                <a16:creationId xmlns:a16="http://schemas.microsoft.com/office/drawing/2014/main" id="{4D73AE08-6858-4CAE-AA67-605CCF76984A}"/>
               </a:ext>
             </a:extLst>
           </p:cNvPr>
@@ -8448,10 +8448,10 @@
       </p:sp>
       <p:sp>
         <p:nvSpPr>
-          <p:cNvPr id="18" name="text-wzpi2r214x">
-            <a:extLst xmlns:a="http://schemas.openxmlformats.org/drawingml/2006/main">
-              <a:ext uri="{FF2B5EF4-FFF2-40B4-BE49-F238E27FC236}">
-                <a16:creationId xmlns:a16="http://schemas.microsoft.com/office/drawing/2014/main" id="{858CAE91-0A9B-48CD-B6D4-861C68CAC2C3}"/>
+          <p:cNvPr id="18" name="text-yoahnfxyezk">
+            <a:extLst xmlns:a="http://schemas.openxmlformats.org/drawingml/2006/main">
+              <a:ext uri="{FF2B5EF4-FFF2-40B4-BE49-F238E27FC236}">
+                <a16:creationId xmlns:a16="http://schemas.microsoft.com/office/drawing/2014/main" id="{5E03E319-279F-4342-B229-DCB2A5BEC418}"/>
               </a:ext>
             </a:extLst>
           </p:cNvPr>
@@ -8528,10 +8528,10 @@
       </p:cxnSp>
       <p:sp>
         <p:nvSpPr>
-          <p:cNvPr id="20" name="text-8568zjvkm7k">
-            <a:extLst xmlns:a="http://schemas.openxmlformats.org/drawingml/2006/main">
-              <a:ext uri="{FF2B5EF4-FFF2-40B4-BE49-F238E27FC236}">
-                <a16:creationId xmlns:a16="http://schemas.microsoft.com/office/drawing/2014/main" id="{A181B9E8-02F7-4026-A388-FC50FF84613C}"/>
+          <p:cNvPr id="20" name="text-wn32y5vtd0l">
+            <a:extLst xmlns:a="http://schemas.openxmlformats.org/drawingml/2006/main">
+              <a:ext uri="{FF2B5EF4-FFF2-40B4-BE49-F238E27FC236}">
+                <a16:creationId xmlns:a16="http://schemas.microsoft.com/office/drawing/2014/main" id="{254C1439-7DA8-435F-A66F-F1C889A3C794}"/>
               </a:ext>
             </a:extLst>
           </p:cNvPr>
@@ -8586,10 +8586,10 @@
       </p:sp>
       <p:sp>
         <p:nvSpPr>
-          <p:cNvPr id="21" name="text-bncxhnon7x9">
-            <a:extLst xmlns:a="http://schemas.openxmlformats.org/drawingml/2006/main">
-              <a:ext uri="{FF2B5EF4-FFF2-40B4-BE49-F238E27FC236}">
-                <a16:creationId xmlns:a16="http://schemas.microsoft.com/office/drawing/2014/main" id="{684827C9-E332-4F0A-83E5-BC4E0D6C9326}"/>
+          <p:cNvPr id="21" name="text-nvprm3z3nq">
+            <a:extLst xmlns:a="http://schemas.openxmlformats.org/drawingml/2006/main">
+              <a:ext uri="{FF2B5EF4-FFF2-40B4-BE49-F238E27FC236}">
+                <a16:creationId xmlns:a16="http://schemas.microsoft.com/office/drawing/2014/main" id="{621DA943-67AF-423B-BCA6-65444BEF5AFC}"/>
               </a:ext>
             </a:extLst>
           </p:cNvPr>
@@ -8666,10 +8666,10 @@
       </p:cxnSp>
       <p:sp>
         <p:nvSpPr>
-          <p:cNvPr id="23" name="text-zex9b0239v">
-            <a:extLst xmlns:a="http://schemas.openxmlformats.org/drawingml/2006/main">
-              <a:ext uri="{FF2B5EF4-FFF2-40B4-BE49-F238E27FC236}">
-                <a16:creationId xmlns:a16="http://schemas.microsoft.com/office/drawing/2014/main" id="{BCF7D4FE-011F-4833-BCAC-99C378C47F97}"/>
+          <p:cNvPr id="23" name="text-xk8q9c5ho9o">
+            <a:extLst xmlns:a="http://schemas.openxmlformats.org/drawingml/2006/main">
+              <a:ext uri="{FF2B5EF4-FFF2-40B4-BE49-F238E27FC236}">
+                <a16:creationId xmlns:a16="http://schemas.microsoft.com/office/drawing/2014/main" id="{D39CEB8D-07C8-41F5-A9EF-09BF78521083}"/>
               </a:ext>
             </a:extLst>
           </p:cNvPr>
@@ -8725,7 +8725,7 @@
     </p:spTree>
     <p:extLst>
       <p:ext uri="{BB962C8B-B14F-4D97-AF65-F5344CB8AC3E}">
-        <p14:creationId xmlns:p14="http://schemas.microsoft.com/office/powerpoint/2010/main" val="710128031"/>
+        <p14:creationId xmlns:p14="http://schemas.microsoft.com/office/powerpoint/2010/main" val="563709984"/>
       </p:ext>
     </p:extLst>
   </p:cSld>
@@ -8753,10 +8753,10 @@
       </p:grpSpPr>
       <p:sp>
         <p:nvSpPr>
-          <p:cNvPr id="14" name="text-w6ie65sp0l">
-            <a:extLst xmlns:a="http://schemas.openxmlformats.org/drawingml/2006/main">
-              <a:ext uri="{FF2B5EF4-FFF2-40B4-BE49-F238E27FC236}">
-                <a16:creationId xmlns:a16="http://schemas.microsoft.com/office/drawing/2014/main" id="{93A8314F-DEBC-48BF-8048-49E3B3E31486}"/>
+          <p:cNvPr id="14" name="text-w1rfduzq1k">
+            <a:extLst xmlns:a="http://schemas.openxmlformats.org/drawingml/2006/main">
+              <a:ext uri="{FF2B5EF4-FFF2-40B4-BE49-F238E27FC236}">
+                <a16:creationId xmlns:a16="http://schemas.microsoft.com/office/drawing/2014/main" id="{480103B0-5503-46C8-8C4A-3C6A932E9181}"/>
               </a:ext>
             </a:extLst>
           </p:cNvPr>
@@ -8811,10 +8811,10 @@
       </p:sp>
       <p:sp>
         <p:nvSpPr>
-          <p:cNvPr id="2" name="text-5xt7tcb0ii3">
-            <a:extLst xmlns:a="http://schemas.openxmlformats.org/drawingml/2006/main">
-              <a:ext uri="{FF2B5EF4-FFF2-40B4-BE49-F238E27FC236}">
-                <a16:creationId xmlns:a16="http://schemas.microsoft.com/office/drawing/2014/main" id="{FBC2F8BD-4005-449D-9B6B-C7EBE692F8AD}"/>
+          <p:cNvPr id="2" name="text-miqsq527hb">
+            <a:extLst xmlns:a="http://schemas.openxmlformats.org/drawingml/2006/main">
+              <a:ext uri="{FF2B5EF4-FFF2-40B4-BE49-F238E27FC236}">
+                <a16:creationId xmlns:a16="http://schemas.microsoft.com/office/drawing/2014/main" id="{10844CAE-E9CA-4FE4-AC08-4A6219BD0DFC}"/>
               </a:ext>
             </a:extLst>
           </p:cNvPr>
@@ -8869,10 +8869,10 @@
       </p:sp>
       <p:sp>
         <p:nvSpPr>
-          <p:cNvPr id="3" name="text-15nc8f3fk2o">
-            <a:extLst xmlns:a="http://schemas.openxmlformats.org/drawingml/2006/main">
-              <a:ext uri="{FF2B5EF4-FFF2-40B4-BE49-F238E27FC236}">
-                <a16:creationId xmlns:a16="http://schemas.microsoft.com/office/drawing/2014/main" id="{76A79FDD-4D60-4137-95D4-02E679E27106}"/>
+          <p:cNvPr id="3" name="text-zursb05cev">
+            <a:extLst xmlns:a="http://schemas.openxmlformats.org/drawingml/2006/main">
+              <a:ext uri="{FF2B5EF4-FFF2-40B4-BE49-F238E27FC236}">
+                <a16:creationId xmlns:a16="http://schemas.microsoft.com/office/drawing/2014/main" id="{F41B10BA-24CF-49DC-AD64-BC044DC6E3C6}"/>
               </a:ext>
             </a:extLst>
           </p:cNvPr>
@@ -8927,10 +8927,10 @@
       </p:sp>
       <p:sp>
         <p:nvSpPr>
-          <p:cNvPr id="4" name="text-e3h1fy75rja">
-            <a:extLst xmlns:a="http://schemas.openxmlformats.org/drawingml/2006/main">
-              <a:ext uri="{FF2B5EF4-FFF2-40B4-BE49-F238E27FC236}">
-                <a16:creationId xmlns:a16="http://schemas.microsoft.com/office/drawing/2014/main" id="{39B06AC5-A71E-404C-831E-46BCBC6263FF}"/>
+          <p:cNvPr id="4" name="text-f9teq02tbf">
+            <a:extLst xmlns:a="http://schemas.openxmlformats.org/drawingml/2006/main">
+              <a:ext uri="{FF2B5EF4-FFF2-40B4-BE49-F238E27FC236}">
+                <a16:creationId xmlns:a16="http://schemas.microsoft.com/office/drawing/2014/main" id="{A6AB1B6D-3A0E-4402-B1F4-F699AC035045}"/>
               </a:ext>
             </a:extLst>
           </p:cNvPr>
@@ -8985,10 +8985,10 @@
       </p:sp>
       <p:sp>
         <p:nvSpPr>
-          <p:cNvPr id="5" name="text-ibju2jguqlc">
-            <a:extLst xmlns:a="http://schemas.openxmlformats.org/drawingml/2006/main">
-              <a:ext uri="{FF2B5EF4-FFF2-40B4-BE49-F238E27FC236}">
-                <a16:creationId xmlns:a16="http://schemas.microsoft.com/office/drawing/2014/main" id="{8B2ECAA3-50ED-42FC-98F8-9DA48DCC4143}"/>
+          <p:cNvPr id="5" name="text-lm26q0oglu">
+            <a:extLst xmlns:a="http://schemas.openxmlformats.org/drawingml/2006/main">
+              <a:ext uri="{FF2B5EF4-FFF2-40B4-BE49-F238E27FC236}">
+                <a16:creationId xmlns:a16="http://schemas.microsoft.com/office/drawing/2014/main" id="{351AB475-9551-4A08-8715-2CEE1830B42E}"/>
               </a:ext>
             </a:extLst>
           </p:cNvPr>
@@ -9043,10 +9043,10 @@
       </p:sp>
       <p:sp>
         <p:nvSpPr>
-          <p:cNvPr id="6" name="text-6j3u7uyj1ct">
-            <a:extLst xmlns:a="http://schemas.openxmlformats.org/drawingml/2006/main">
-              <a:ext uri="{FF2B5EF4-FFF2-40B4-BE49-F238E27FC236}">
-                <a16:creationId xmlns:a16="http://schemas.microsoft.com/office/drawing/2014/main" id="{0997A8E8-BE4B-4075-B1CC-4063B5EB3491}"/>
+          <p:cNvPr id="6" name="text-vx18lews839">
+            <a:extLst xmlns:a="http://schemas.openxmlformats.org/drawingml/2006/main">
+              <a:ext uri="{FF2B5EF4-FFF2-40B4-BE49-F238E27FC236}">
+                <a16:creationId xmlns:a16="http://schemas.microsoft.com/office/drawing/2014/main" id="{6167D223-0A8C-49E5-9986-1B70F57661BD}"/>
               </a:ext>
             </a:extLst>
           </p:cNvPr>
@@ -9101,10 +9101,10 @@
       </p:sp>
       <p:sp>
         <p:nvSpPr>
-          <p:cNvPr id="7" name="text-zs3nbgv0yu">
-            <a:extLst xmlns:a="http://schemas.openxmlformats.org/drawingml/2006/main">
-              <a:ext uri="{FF2B5EF4-FFF2-40B4-BE49-F238E27FC236}">
-                <a16:creationId xmlns:a16="http://schemas.microsoft.com/office/drawing/2014/main" id="{13A5E801-4A0A-48A0-961A-0C1CA42F0F13}"/>
+          <p:cNvPr id="7" name="text-gb2h53ycdv7">
+            <a:extLst xmlns:a="http://schemas.openxmlformats.org/drawingml/2006/main">
+              <a:ext uri="{FF2B5EF4-FFF2-40B4-BE49-F238E27FC236}">
+                <a16:creationId xmlns:a16="http://schemas.microsoft.com/office/drawing/2014/main" id="{01A68C77-1AFC-46E9-AEB1-2938723A918F}"/>
               </a:ext>
             </a:extLst>
           </p:cNvPr>
@@ -9159,10 +9159,10 @@
       </p:sp>
       <p:sp>
         <p:nvSpPr>
-          <p:cNvPr id="8" name="text-xqp17d97wvb">
-            <a:extLst xmlns:a="http://schemas.openxmlformats.org/drawingml/2006/main">
-              <a:ext uri="{FF2B5EF4-FFF2-40B4-BE49-F238E27FC236}">
-                <a16:creationId xmlns:a16="http://schemas.microsoft.com/office/drawing/2014/main" id="{30B8DF8E-04B7-4C96-B307-FE2B942D7B0C}"/>
+          <p:cNvPr id="8" name="text-nhc4hvhqk4e">
+            <a:extLst xmlns:a="http://schemas.openxmlformats.org/drawingml/2006/main">
+              <a:ext uri="{FF2B5EF4-FFF2-40B4-BE49-F238E27FC236}">
+                <a16:creationId xmlns:a16="http://schemas.microsoft.com/office/drawing/2014/main" id="{0557BDEB-F2DC-4EA8-9874-41A4BF460E98}"/>
               </a:ext>
             </a:extLst>
           </p:cNvPr>
@@ -9217,10 +9217,10 @@
       </p:sp>
       <p:sp>
         <p:nvSpPr>
-          <p:cNvPr id="9" name="text-bkgald8zqh">
-            <a:extLst xmlns:a="http://schemas.openxmlformats.org/drawingml/2006/main">
-              <a:ext uri="{FF2B5EF4-FFF2-40B4-BE49-F238E27FC236}">
-                <a16:creationId xmlns:a16="http://schemas.microsoft.com/office/drawing/2014/main" id="{2C190361-A8ED-4FD9-909F-873BAB2EC192}"/>
+          <p:cNvPr id="9" name="text-n6yzla36ytq">
+            <a:extLst xmlns:a="http://schemas.openxmlformats.org/drawingml/2006/main">
+              <a:ext uri="{FF2B5EF4-FFF2-40B4-BE49-F238E27FC236}">
+                <a16:creationId xmlns:a16="http://schemas.microsoft.com/office/drawing/2014/main" id="{1C00D584-E31F-468F-94C9-8486A849FB19}"/>
               </a:ext>
             </a:extLst>
           </p:cNvPr>
@@ -9297,10 +9297,10 @@
       </p:cxnSp>
       <p:sp>
         <p:nvSpPr>
-          <p:cNvPr id="11" name="text-rulxfst7eo">
-            <a:extLst xmlns:a="http://schemas.openxmlformats.org/drawingml/2006/main">
-              <a:ext uri="{FF2B5EF4-FFF2-40B4-BE49-F238E27FC236}">
-                <a16:creationId xmlns:a16="http://schemas.microsoft.com/office/drawing/2014/main" id="{4FF0313E-0815-4B85-9146-E93280F69273}"/>
+          <p:cNvPr id="11" name="text-5l82d469f27">
+            <a:extLst xmlns:a="http://schemas.openxmlformats.org/drawingml/2006/main">
+              <a:ext uri="{FF2B5EF4-FFF2-40B4-BE49-F238E27FC236}">
+                <a16:creationId xmlns:a16="http://schemas.microsoft.com/office/drawing/2014/main" id="{B8F109E6-7F91-424B-85A6-093EFDB355A3}"/>
               </a:ext>
             </a:extLst>
           </p:cNvPr>
@@ -9355,10 +9355,10 @@
       </p:sp>
       <p:sp>
         <p:nvSpPr>
-          <p:cNvPr id="12" name="text-d9yt7rpv83b">
-            <a:extLst xmlns:a="http://schemas.openxmlformats.org/drawingml/2006/main">
-              <a:ext uri="{FF2B5EF4-FFF2-40B4-BE49-F238E27FC236}">
-                <a16:creationId xmlns:a16="http://schemas.microsoft.com/office/drawing/2014/main" id="{5CCE92E7-3B72-4D5D-8CD5-F30CAFA7D660}"/>
+          <p:cNvPr id="12" name="text-gwkicymoy3r">
+            <a:extLst xmlns:a="http://schemas.openxmlformats.org/drawingml/2006/main">
+              <a:ext uri="{FF2B5EF4-FFF2-40B4-BE49-F238E27FC236}">
+                <a16:creationId xmlns:a16="http://schemas.microsoft.com/office/drawing/2014/main" id="{052CD5EC-A733-44F8-8032-74D5B34F691A}"/>
               </a:ext>
             </a:extLst>
           </p:cNvPr>
@@ -9413,10 +9413,10 @@
       </p:sp>
       <p:sp>
         <p:nvSpPr>
-          <p:cNvPr id="13" name="text-jfywkv4wkv">
-            <a:extLst xmlns:a="http://schemas.openxmlformats.org/drawingml/2006/main">
-              <a:ext uri="{FF2B5EF4-FFF2-40B4-BE49-F238E27FC236}">
-                <a16:creationId xmlns:a16="http://schemas.microsoft.com/office/drawing/2014/main" id="{D7024093-164E-4AE4-AB7F-39CB0CEB1617}"/>
+          <p:cNvPr id="13" name="text-gwzi04clrk7">
+            <a:extLst xmlns:a="http://schemas.openxmlformats.org/drawingml/2006/main">
+              <a:ext uri="{FF2B5EF4-FFF2-40B4-BE49-F238E27FC236}">
+                <a16:creationId xmlns:a16="http://schemas.microsoft.com/office/drawing/2014/main" id="{FC0B5019-9525-48C8-9074-01B1C36E11FE}"/>
               </a:ext>
             </a:extLst>
           </p:cNvPr>
@@ -9472,7 +9472,7 @@
     </p:spTree>
     <p:extLst>
       <p:ext uri="{BB962C8B-B14F-4D97-AF65-F5344CB8AC3E}">
-        <p14:creationId xmlns:p14="http://schemas.microsoft.com/office/powerpoint/2010/main" val="1424404224"/>
+        <p14:creationId xmlns:p14="http://schemas.microsoft.com/office/powerpoint/2010/main" val="968288819"/>
       </p:ext>
     </p:extLst>
   </p:cSld>
@@ -9500,10 +9500,10 @@
       </p:grpSpPr>
       <p:sp>
         <p:nvSpPr>
-          <p:cNvPr id="19" name="text-2ec1ymb2jgq">
-            <a:extLst xmlns:a="http://schemas.openxmlformats.org/drawingml/2006/main">
-              <a:ext uri="{FF2B5EF4-FFF2-40B4-BE49-F238E27FC236}">
-                <a16:creationId xmlns:a16="http://schemas.microsoft.com/office/drawing/2014/main" id="{3D460D40-A573-40F9-A863-DF526DF648F2}"/>
+          <p:cNvPr id="19" name="text-nbyif5uvq5q">
+            <a:extLst xmlns:a="http://schemas.openxmlformats.org/drawingml/2006/main">
+              <a:ext uri="{FF2B5EF4-FFF2-40B4-BE49-F238E27FC236}">
+                <a16:creationId xmlns:a16="http://schemas.microsoft.com/office/drawing/2014/main" id="{9705A8DF-BBD9-4AAC-81AC-6DC810C395DC}"/>
               </a:ext>
             </a:extLst>
           </p:cNvPr>
@@ -9558,10 +9558,10 @@
       </p:sp>
       <p:sp>
         <p:nvSpPr>
-          <p:cNvPr id="2" name="text-a6rpxlkcdg5">
-            <a:extLst xmlns:a="http://schemas.openxmlformats.org/drawingml/2006/main">
-              <a:ext uri="{FF2B5EF4-FFF2-40B4-BE49-F238E27FC236}">
-                <a16:creationId xmlns:a16="http://schemas.microsoft.com/office/drawing/2014/main" id="{3AA431C1-9C8F-449D-8B34-D18A5D91E002}"/>
+          <p:cNvPr id="2" name="text-g9ibho4q4ob">
+            <a:extLst xmlns:a="http://schemas.openxmlformats.org/drawingml/2006/main">
+              <a:ext uri="{FF2B5EF4-FFF2-40B4-BE49-F238E27FC236}">
+                <a16:creationId xmlns:a16="http://schemas.microsoft.com/office/drawing/2014/main" id="{B791BB88-F586-4A54-8BF2-5D7A76057E74}"/>
               </a:ext>
             </a:extLst>
           </p:cNvPr>
@@ -9616,10 +9616,10 @@
       </p:sp>
       <p:sp>
         <p:nvSpPr>
-          <p:cNvPr id="3" name="text-jn1svoaz24o">
-            <a:extLst xmlns:a="http://schemas.openxmlformats.org/drawingml/2006/main">
-              <a:ext uri="{FF2B5EF4-FFF2-40B4-BE49-F238E27FC236}">
-                <a16:creationId xmlns:a16="http://schemas.microsoft.com/office/drawing/2014/main" id="{30B6FF2F-E44E-4910-A68B-E1544D1207EB}"/>
+          <p:cNvPr id="3" name="text-uzoou5jg8w">
+            <a:extLst xmlns:a="http://schemas.openxmlformats.org/drawingml/2006/main">
+              <a:ext uri="{FF2B5EF4-FFF2-40B4-BE49-F238E27FC236}">
+                <a16:creationId xmlns:a16="http://schemas.microsoft.com/office/drawing/2014/main" id="{673F84D7-0F5F-4B62-8EBE-74C6C73BADD0}"/>
               </a:ext>
             </a:extLst>
           </p:cNvPr>
@@ -9699,7 +9699,7 @@
           <p:cNvPr id="5" name="">
             <a:extLst xmlns:a="http://schemas.openxmlformats.org/drawingml/2006/main">
               <a:ext uri="{FF2B5EF4-FFF2-40B4-BE49-F238E27FC236}">
-                <a16:creationId xmlns:a16="http://schemas.microsoft.com/office/drawing/2014/main" id="{11935DE9-480F-4C9E-9296-E92D34C2BE8C}"/>
+                <a16:creationId xmlns:a16="http://schemas.microsoft.com/office/drawing/2014/main" id="{8308BA78-1CFF-441E-AE08-4ABFF542213B}"/>
               </a:ext>
             </a:extLst>
           </p:cNvPr>
@@ -9729,10 +9729,10 @@
       </p:sp>
       <p:sp>
         <p:nvSpPr>
-          <p:cNvPr id="6" name="text-3n0ivm5avgt">
-            <a:extLst xmlns:a="http://schemas.openxmlformats.org/drawingml/2006/main">
-              <a:ext uri="{FF2B5EF4-FFF2-40B4-BE49-F238E27FC236}">
-                <a16:creationId xmlns:a16="http://schemas.microsoft.com/office/drawing/2014/main" id="{E870E3D7-9796-440C-8725-841CA266A5D1}"/>
+          <p:cNvPr id="6" name="text-qstkpxvgy2g">
+            <a:extLst xmlns:a="http://schemas.openxmlformats.org/drawingml/2006/main">
+              <a:ext uri="{FF2B5EF4-FFF2-40B4-BE49-F238E27FC236}">
+                <a16:creationId xmlns:a16="http://schemas.microsoft.com/office/drawing/2014/main" id="{40007FA6-0005-46CC-A22B-48EE6AEA2F30}"/>
               </a:ext>
             </a:extLst>
           </p:cNvPr>
@@ -9787,10 +9787,10 @@
       </p:sp>
       <p:sp>
         <p:nvSpPr>
-          <p:cNvPr id="7" name="text-wqk7mrnm7de">
-            <a:extLst xmlns:a="http://schemas.openxmlformats.org/drawingml/2006/main">
-              <a:ext uri="{FF2B5EF4-FFF2-40B4-BE49-F238E27FC236}">
-                <a16:creationId xmlns:a16="http://schemas.microsoft.com/office/drawing/2014/main" id="{C44B1E70-1FF8-440C-BA3A-D9AEC4643853}"/>
+          <p:cNvPr id="7" name="text-yrgc035had">
+            <a:extLst xmlns:a="http://schemas.openxmlformats.org/drawingml/2006/main">
+              <a:ext uri="{FF2B5EF4-FFF2-40B4-BE49-F238E27FC236}">
+                <a16:creationId xmlns:a16="http://schemas.microsoft.com/office/drawing/2014/main" id="{BB84DF75-E6E7-4E3B-88FF-4B1DD53740C5}"/>
               </a:ext>
             </a:extLst>
           </p:cNvPr>
@@ -9845,10 +9845,10 @@
       </p:sp>
       <p:sp>
         <p:nvSpPr>
-          <p:cNvPr id="8" name="text-qnqwy7md5f">
-            <a:extLst xmlns:a="http://schemas.openxmlformats.org/drawingml/2006/main">
-              <a:ext uri="{FF2B5EF4-FFF2-40B4-BE49-F238E27FC236}">
-                <a16:creationId xmlns:a16="http://schemas.microsoft.com/office/drawing/2014/main" id="{B8362962-B44A-4147-9359-3429D9BAD7F3}"/>
+          <p:cNvPr id="8" name="text-j96gshl40ce">
+            <a:extLst xmlns:a="http://schemas.openxmlformats.org/drawingml/2006/main">
+              <a:ext uri="{FF2B5EF4-FFF2-40B4-BE49-F238E27FC236}">
+                <a16:creationId xmlns:a16="http://schemas.microsoft.com/office/drawing/2014/main" id="{BC06C210-C311-46E4-83D9-838F82A69D1F}"/>
               </a:ext>
             </a:extLst>
           </p:cNvPr>
@@ -9906,7 +9906,7 @@
           <p:cNvPr id="9" name="">
             <a:extLst xmlns:a="http://schemas.openxmlformats.org/drawingml/2006/main">
               <a:ext uri="{FF2B5EF4-FFF2-40B4-BE49-F238E27FC236}">
-                <a16:creationId xmlns:a16="http://schemas.microsoft.com/office/drawing/2014/main" id="{4AAD396C-5788-4B2A-B7BE-BD899B6514F0}"/>
+                <a16:creationId xmlns:a16="http://schemas.microsoft.com/office/drawing/2014/main" id="{7B5F6B9D-8918-4574-A80D-C37F58D183FB}"/>
               </a:ext>
             </a:extLst>
           </p:cNvPr>
@@ -9936,10 +9936,10 @@
       </p:sp>
       <p:sp>
         <p:nvSpPr>
-          <p:cNvPr id="10" name="text-9j8pcdon6it">
-            <a:extLst xmlns:a="http://schemas.openxmlformats.org/drawingml/2006/main">
-              <a:ext uri="{FF2B5EF4-FFF2-40B4-BE49-F238E27FC236}">
-                <a16:creationId xmlns:a16="http://schemas.microsoft.com/office/drawing/2014/main" id="{94C084FC-A41E-4398-9A89-849B58FE9303}"/>
+          <p:cNvPr id="10" name="text-gytv9tptzya">
+            <a:extLst xmlns:a="http://schemas.openxmlformats.org/drawingml/2006/main">
+              <a:ext uri="{FF2B5EF4-FFF2-40B4-BE49-F238E27FC236}">
+                <a16:creationId xmlns:a16="http://schemas.microsoft.com/office/drawing/2014/main" id="{2CE6B687-47B3-4B2F-9268-4D6D197D7341}"/>
               </a:ext>
             </a:extLst>
           </p:cNvPr>
@@ -9994,10 +9994,10 @@
       </p:sp>
       <p:sp>
         <p:nvSpPr>
-          <p:cNvPr id="11" name="text-nlp9i44g47m">
-            <a:extLst xmlns:a="http://schemas.openxmlformats.org/drawingml/2006/main">
-              <a:ext uri="{FF2B5EF4-FFF2-40B4-BE49-F238E27FC236}">
-                <a16:creationId xmlns:a16="http://schemas.microsoft.com/office/drawing/2014/main" id="{77819624-3E3E-494E-8793-E78BACD8A571}"/>
+          <p:cNvPr id="11" name="text-okkpvsv4uym">
+            <a:extLst xmlns:a="http://schemas.openxmlformats.org/drawingml/2006/main">
+              <a:ext uri="{FF2B5EF4-FFF2-40B4-BE49-F238E27FC236}">
+                <a16:creationId xmlns:a16="http://schemas.microsoft.com/office/drawing/2014/main" id="{59038F40-D0DD-4099-9776-A34299BE0B18}"/>
               </a:ext>
             </a:extLst>
           </p:cNvPr>
@@ -10052,10 +10052,10 @@
       </p:sp>
       <p:sp>
         <p:nvSpPr>
-          <p:cNvPr id="12" name="text-8f68xkcwqvc">
-            <a:extLst xmlns:a="http://schemas.openxmlformats.org/drawingml/2006/main">
-              <a:ext uri="{FF2B5EF4-FFF2-40B4-BE49-F238E27FC236}">
-                <a16:creationId xmlns:a16="http://schemas.microsoft.com/office/drawing/2014/main" id="{4FB109D2-73C8-4F67-B6E8-FBE8288F234F}"/>
+          <p:cNvPr id="12" name="text-0jhwgswe4w15">
+            <a:extLst xmlns:a="http://schemas.openxmlformats.org/drawingml/2006/main">
+              <a:ext uri="{FF2B5EF4-FFF2-40B4-BE49-F238E27FC236}">
+                <a16:creationId xmlns:a16="http://schemas.microsoft.com/office/drawing/2014/main" id="{1ADFC482-1099-4589-B914-7BA01190D4CE}"/>
               </a:ext>
             </a:extLst>
           </p:cNvPr>
@@ -10113,7 +10113,7 @@
           <p:cNvPr id="13" name="">
             <a:extLst xmlns:a="http://schemas.openxmlformats.org/drawingml/2006/main">
               <a:ext uri="{FF2B5EF4-FFF2-40B4-BE49-F238E27FC236}">
-                <a16:creationId xmlns:a16="http://schemas.microsoft.com/office/drawing/2014/main" id="{9A06DDB3-8DB0-41F6-960D-153F5ADDFF9C}"/>
+                <a16:creationId xmlns:a16="http://schemas.microsoft.com/office/drawing/2014/main" id="{459A925A-550A-4BD5-BEE8-B02B91B8D1C0}"/>
               </a:ext>
             </a:extLst>
           </p:cNvPr>
@@ -10143,10 +10143,10 @@
       </p:sp>
       <p:sp>
         <p:nvSpPr>
-          <p:cNvPr id="14" name="text-ir18c43wqqn">
-            <a:extLst xmlns:a="http://schemas.openxmlformats.org/drawingml/2006/main">
-              <a:ext uri="{FF2B5EF4-FFF2-40B4-BE49-F238E27FC236}">
-                <a16:creationId xmlns:a16="http://schemas.microsoft.com/office/drawing/2014/main" id="{76D2B4BE-A65D-4BA3-9696-7B5C8C18D4BF}"/>
+          <p:cNvPr id="14" name="text-waaz8blc7hq">
+            <a:extLst xmlns:a="http://schemas.openxmlformats.org/drawingml/2006/main">
+              <a:ext uri="{FF2B5EF4-FFF2-40B4-BE49-F238E27FC236}">
+                <a16:creationId xmlns:a16="http://schemas.microsoft.com/office/drawing/2014/main" id="{C869DF40-25D9-4E9D-8496-5F59BEBD741B}"/>
               </a:ext>
             </a:extLst>
           </p:cNvPr>
@@ -10201,10 +10201,10 @@
       </p:sp>
       <p:sp>
         <p:nvSpPr>
-          <p:cNvPr id="15" name="text-0kr8vx725p1m">
-            <a:extLst xmlns:a="http://schemas.openxmlformats.org/drawingml/2006/main">
-              <a:ext uri="{FF2B5EF4-FFF2-40B4-BE49-F238E27FC236}">
-                <a16:creationId xmlns:a16="http://schemas.microsoft.com/office/drawing/2014/main" id="{1B91142D-A7C6-4FD7-9586-1A06CEAF9530}"/>
+          <p:cNvPr id="15" name="text-twvqcj0i5ag">
+            <a:extLst xmlns:a="http://schemas.openxmlformats.org/drawingml/2006/main">
+              <a:ext uri="{FF2B5EF4-FFF2-40B4-BE49-F238E27FC236}">
+                <a16:creationId xmlns:a16="http://schemas.microsoft.com/office/drawing/2014/main" id="{C9A44217-DE1D-4EFF-A5C5-615D93C5CF71}"/>
               </a:ext>
             </a:extLst>
           </p:cNvPr>
@@ -10259,10 +10259,10 @@
       </p:sp>
       <p:sp>
         <p:nvSpPr>
-          <p:cNvPr id="16" name="text-20sv4mars1y">
-            <a:extLst xmlns:a="http://schemas.openxmlformats.org/drawingml/2006/main">
-              <a:ext uri="{FF2B5EF4-FFF2-40B4-BE49-F238E27FC236}">
-                <a16:creationId xmlns:a16="http://schemas.microsoft.com/office/drawing/2014/main" id="{D2B1EB1D-CA64-478D-8C1D-3FA5CFB8EC01}"/>
+          <p:cNvPr id="16" name="text-o75q4cgmh3i">
+            <a:extLst xmlns:a="http://schemas.openxmlformats.org/drawingml/2006/main">
+              <a:ext uri="{FF2B5EF4-FFF2-40B4-BE49-F238E27FC236}">
+                <a16:creationId xmlns:a16="http://schemas.microsoft.com/office/drawing/2014/main" id="{21B5F3A7-6462-4388-B8A4-AD560E00BA99}"/>
               </a:ext>
             </a:extLst>
           </p:cNvPr>
@@ -10320,7 +10320,7 @@
           <p:cNvPr id="17" name="">
             <a:extLst xmlns:a="http://schemas.openxmlformats.org/drawingml/2006/main">
               <a:ext uri="{FF2B5EF4-FFF2-40B4-BE49-F238E27FC236}">
-                <a16:creationId xmlns:a16="http://schemas.microsoft.com/office/drawing/2014/main" id="{2DA24125-8EB6-405C-A43E-92E3282733A9}"/>
+                <a16:creationId xmlns:a16="http://schemas.microsoft.com/office/drawing/2014/main" id="{B78A6FED-72EA-4134-8D40-00AADABF13D6}"/>
               </a:ext>
             </a:extLst>
           </p:cNvPr>
@@ -10348,10 +10348,10 @@
       </p:sp>
       <p:sp>
         <p:nvSpPr>
-          <p:cNvPr id="18" name="text-ftx2ynpwtj6">
-            <a:extLst xmlns:a="http://schemas.openxmlformats.org/drawingml/2006/main">
-              <a:ext uri="{FF2B5EF4-FFF2-40B4-BE49-F238E27FC236}">
-                <a16:creationId xmlns:a16="http://schemas.microsoft.com/office/drawing/2014/main" id="{0C2344AD-5303-4161-8D8B-109FEB2D8819}"/>
+          <p:cNvPr id="18" name="text-67jumy7i91j">
+            <a:extLst xmlns:a="http://schemas.openxmlformats.org/drawingml/2006/main">
+              <a:ext uri="{FF2B5EF4-FFF2-40B4-BE49-F238E27FC236}">
+                <a16:creationId xmlns:a16="http://schemas.microsoft.com/office/drawing/2014/main" id="{3A2B44DC-D6E5-40C9-AA5B-38DA97110577}"/>
               </a:ext>
             </a:extLst>
           </p:cNvPr>
@@ -10407,7 +10407,7 @@
     </p:spTree>
     <p:extLst>
       <p:ext uri="{BB962C8B-B14F-4D97-AF65-F5344CB8AC3E}">
-        <p14:creationId xmlns:p14="http://schemas.microsoft.com/office/powerpoint/2010/main" val="621448349"/>
+        <p14:creationId xmlns:p14="http://schemas.microsoft.com/office/powerpoint/2010/main" val="2111602426"/>
       </p:ext>
     </p:extLst>
   </p:cSld>

</xml_diff>

<commit_message>
Tighten project copy and artifact labels
</commit_message>
<xml_diff>
--- a/deck/coca-cola-india-occasion-to-habit-case.pptx
+++ b/deck/coca-cola-india-occasion-to-habit-case.pptx
@@ -2,22 +2,22 @@
 <file path=ppt/presentation.xml><?xml version="1.0" encoding="utf-8"?>
 <p:presentation xmlns:p="http://schemas.openxmlformats.org/presentationml/2006/main">
   <p:sldMasterIdLst>
-    <p:sldMasterId xmlns:r="http://schemas.openxmlformats.org/officeDocument/2006/relationships" id="2147483648" r:id="R6fc4f2c356e446a2"/>
+    <p:sldMasterId xmlns:r="http://schemas.openxmlformats.org/officeDocument/2006/relationships" id="2147483648" r:id="Rd9f849e072504976"/>
   </p:sldMasterIdLst>
   <p:notesMasterIdLst>
-    <p:notesMasterId xmlns:r="http://schemas.openxmlformats.org/officeDocument/2006/relationships" r:id="Rdcae89da6a434131"/>
+    <p:notesMasterId xmlns:r="http://schemas.openxmlformats.org/officeDocument/2006/relationships" r:id="Rba1e6ed2787f4000"/>
   </p:notesMasterIdLst>
   <p:sldIdLst>
-    <p:sldId xmlns:r="http://schemas.openxmlformats.org/officeDocument/2006/relationships" id="256" r:id="R6734e99c1f664686"/>
-    <p:sldId xmlns:r="http://schemas.openxmlformats.org/officeDocument/2006/relationships" id="257" r:id="Rc40935bc9f004ff8"/>
-    <p:sldId xmlns:r="http://schemas.openxmlformats.org/officeDocument/2006/relationships" id="258" r:id="R5eaedc987e944ccb"/>
-    <p:sldId xmlns:r="http://schemas.openxmlformats.org/officeDocument/2006/relationships" id="259" r:id="R1cc8f135edb7410a"/>
-    <p:sldId xmlns:r="http://schemas.openxmlformats.org/officeDocument/2006/relationships" id="260" r:id="R8c8071ba953c4e2c"/>
-    <p:sldId xmlns:r="http://schemas.openxmlformats.org/officeDocument/2006/relationships" id="261" r:id="R611fd980da934449"/>
-    <p:sldId xmlns:r="http://schemas.openxmlformats.org/officeDocument/2006/relationships" id="262" r:id="Rd004dd8160414786"/>
-    <p:sldId xmlns:r="http://schemas.openxmlformats.org/officeDocument/2006/relationships" id="263" r:id="R9eef925a46644ea7"/>
-    <p:sldId xmlns:r="http://schemas.openxmlformats.org/officeDocument/2006/relationships" id="264" r:id="Ra6582bad71394e3f"/>
-    <p:sldId xmlns:r="http://schemas.openxmlformats.org/officeDocument/2006/relationships" id="265" r:id="R4442db7aecd247dd"/>
+    <p:sldId xmlns:r="http://schemas.openxmlformats.org/officeDocument/2006/relationships" id="256" r:id="R8227a87808f04c4e"/>
+    <p:sldId xmlns:r="http://schemas.openxmlformats.org/officeDocument/2006/relationships" id="257" r:id="Rcbbe3e1c0ada45f5"/>
+    <p:sldId xmlns:r="http://schemas.openxmlformats.org/officeDocument/2006/relationships" id="258" r:id="Rdc899b19d514429e"/>
+    <p:sldId xmlns:r="http://schemas.openxmlformats.org/officeDocument/2006/relationships" id="259" r:id="R9a1f0ed58e904d32"/>
+    <p:sldId xmlns:r="http://schemas.openxmlformats.org/officeDocument/2006/relationships" id="260" r:id="Rf35e1c666f4c4794"/>
+    <p:sldId xmlns:r="http://schemas.openxmlformats.org/officeDocument/2006/relationships" id="261" r:id="Rd8c949f97b0f4da6"/>
+    <p:sldId xmlns:r="http://schemas.openxmlformats.org/officeDocument/2006/relationships" id="262" r:id="Rbc601a0b0a5849e5"/>
+    <p:sldId xmlns:r="http://schemas.openxmlformats.org/officeDocument/2006/relationships" id="263" r:id="R7e1dd57d131040b9"/>
+    <p:sldId xmlns:r="http://schemas.openxmlformats.org/officeDocument/2006/relationships" id="264" r:id="Ra94a24bd2c3c4db3"/>
+    <p:sldId xmlns:r="http://schemas.openxmlformats.org/officeDocument/2006/relationships" id="265" r:id="R2c4efa2ae7f14355"/>
   </p:sldIdLst>
   <p:sldSz cx="12192000" cy="6858000"/>
   <p:notesSz cx="6858000" cy="9144000"/>
@@ -464,16 +464,6 @@
               <a:t>[/Sources]</a:t>
             </a:r>
           </a:p>
-          <a:p xmlns:a="http://schemas.openxmlformats.org/drawingml/2006/main">
-            <a:r>
-              <a:t/>
-            </a:r>
-          </a:p>
-          <a:p xmlns:a="http://schemas.openxmlformats.org/drawingml/2006/main">
-            <a:r>
-              <a:t>Independent public-source case. I did not work for Coca-Cola.</a:t>
-            </a:r>
-          </a:p>
         </p:txBody>
       </p:sp>
       <p:sp>
@@ -1334,7 +1324,7 @@
   </p:cSld>
   <p:clrMap bg1="lt1" tx1="dk1" bg2="lt2" tx2="dk2" accent1="accent1" accent2="accent2" accent3="accent3" accent4="accent4" accent5="accent5" accent6="accent6" hlink="hlink" folHlink="folHlink"/>
   <p:sldLayoutIdLst>
-    <p:sldLayoutId xmlns:r="http://schemas.openxmlformats.org/officeDocument/2006/relationships" id="2147483649" r:id="R7ddb115d39dc4705"/>
+    <p:sldLayoutId xmlns:r="http://schemas.openxmlformats.org/officeDocument/2006/relationships" id="2147483649" r:id="Rc6398873cb76492f"/>
   </p:sldLayoutIdLst>
   <p:txStyles>
     <p:titleStyle>
@@ -1885,7 +1875,7 @@
           <p:cNvPr id="9" name="">
             <a:extLst xmlns:a="http://schemas.openxmlformats.org/drawingml/2006/main">
               <a:ext uri="{FF2B5EF4-FFF2-40B4-BE49-F238E27FC236}">
-                <a16:creationId xmlns:a16="http://schemas.microsoft.com/office/drawing/2014/main" id="{B8DD5103-567E-4D07-84CD-D627220A7146}"/>
+                <a16:creationId xmlns:a16="http://schemas.microsoft.com/office/drawing/2014/main" id="{4C1DBC87-D38B-472B-9FAD-895F72CD07DB}"/>
               </a:ext>
             </a:extLst>
           </p:cNvPr>
@@ -1913,10 +1903,10 @@
       </p:sp>
       <p:sp>
         <p:nvSpPr>
-          <p:cNvPr id="2" name="text-yr1cbs6yp5">
-            <a:extLst xmlns:a="http://schemas.openxmlformats.org/drawingml/2006/main">
-              <a:ext uri="{FF2B5EF4-FFF2-40B4-BE49-F238E27FC236}">
-                <a16:creationId xmlns:a16="http://schemas.microsoft.com/office/drawing/2014/main" id="{7C74B9AD-F080-43ED-B9FD-2197411328C2}"/>
+          <p:cNvPr id="2" name="text-qy10ypf44vq">
+            <a:extLst xmlns:a="http://schemas.openxmlformats.org/drawingml/2006/main">
+              <a:ext uri="{FF2B5EF4-FFF2-40B4-BE49-F238E27FC236}">
+                <a16:creationId xmlns:a16="http://schemas.microsoft.com/office/drawing/2014/main" id="{9F17F06B-7D9C-4A7E-AF48-95EC1ADE6E71}"/>
               </a:ext>
             </a:extLst>
           </p:cNvPr>
@@ -1928,7 +1918,7 @@
         <p:spPr>
           <a:xfrm xmlns:a="http://schemas.openxmlformats.org/drawingml/2006/main">
             <a:off x="571500" y="514350"/>
-            <a:ext cx="4953000" cy="228600"/>
+            <a:ext cx="5905500" cy="228600"/>
           </a:xfrm>
           <a:prstGeom xmlns:a="http://schemas.openxmlformats.org/drawingml/2006/main" prst="rect">
             <a:avLst/>
@@ -1964,17 +1954,17 @@
                 <a:ea typeface="Arial"/>
                 <a:cs typeface="Arial"/>
               </a:rPr>
-              <a:t>INDEPENDENT PUBLIC-SOURCE CASE</a:t>
-            </a:r>
-          </a:p>
-        </p:txBody>
-      </p:sp>
-      <p:sp>
-        <p:nvSpPr>
-          <p:cNvPr id="3" name="text-bjrd2pc70t9">
-            <a:extLst xmlns:a="http://schemas.openxmlformats.org/drawingml/2006/main">
-              <a:ext uri="{FF2B5EF4-FFF2-40B4-BE49-F238E27FC236}">
-                <a16:creationId xmlns:a16="http://schemas.microsoft.com/office/drawing/2014/main" id="{63CF8678-BF47-4E9A-968A-A0C403ACB594}"/>
+              <a:t>COCA-COLA INDIA CONSUMER GROWTH CASE</a:t>
+            </a:r>
+          </a:p>
+        </p:txBody>
+      </p:sp>
+      <p:sp>
+        <p:nvSpPr>
+          <p:cNvPr id="3" name="text-y8xqzftls7d">
+            <a:extLst xmlns:a="http://schemas.openxmlformats.org/drawingml/2006/main">
+              <a:ext uri="{FF2B5EF4-FFF2-40B4-BE49-F238E27FC236}">
+                <a16:creationId xmlns:a16="http://schemas.microsoft.com/office/drawing/2014/main" id="{1B55D65C-D7DD-4075-B904-C4B6D225894A}"/>
               </a:ext>
             </a:extLst>
           </p:cNvPr>
@@ -2029,10 +2019,10 @@
       </p:sp>
       <p:sp>
         <p:nvSpPr>
-          <p:cNvPr id="4" name="text-znpnb3eq3on">
-            <a:extLst xmlns:a="http://schemas.openxmlformats.org/drawingml/2006/main">
-              <a:ext uri="{FF2B5EF4-FFF2-40B4-BE49-F238E27FC236}">
-                <a16:creationId xmlns:a16="http://schemas.microsoft.com/office/drawing/2014/main" id="{4A2FDC17-7190-49CD-B748-647FDE4616C5}"/>
+          <p:cNvPr id="4" name="text-3uwqikrkxqb">
+            <a:extLst xmlns:a="http://schemas.openxmlformats.org/drawingml/2006/main">
+              <a:ext uri="{FF2B5EF4-FFF2-40B4-BE49-F238E27FC236}">
+                <a16:creationId xmlns:a16="http://schemas.microsoft.com/office/drawing/2014/main" id="{180993D8-209F-4CB8-8973-0B822ACF5284}"/>
               </a:ext>
             </a:extLst>
           </p:cNvPr>
@@ -2080,7 +2070,7 @@
                 <a:ea typeface="Arial"/>
                 <a:cs typeface="Arial"/>
               </a:rPr>
-              <a:t>A consumer-growth strategy built around personalization, affordability and measurable repeat</a:t>
+              <a:t>A three-cell outlet test for personalization, repeat purchase and unit economics</a:t>
             </a:r>
           </a:p>
         </p:txBody>
@@ -2090,7 +2080,7 @@
           <p:cNvPr id="5" name="">
             <a:extLst xmlns:a="http://schemas.openxmlformats.org/drawingml/2006/main">
               <a:ext uri="{FF2B5EF4-FFF2-40B4-BE49-F238E27FC236}">
-                <a16:creationId xmlns:a16="http://schemas.microsoft.com/office/drawing/2014/main" id="{529F6134-D5FC-4E5F-BDA8-4CDBB2964155}"/>
+                <a16:creationId xmlns:a16="http://schemas.microsoft.com/office/drawing/2014/main" id="{B7B6F306-DB9D-486F-9C91-38C1986EA68A}"/>
               </a:ext>
             </a:extLst>
           </p:cNvPr>
@@ -2118,10 +2108,10 @@
       </p:sp>
       <p:sp>
         <p:nvSpPr>
-          <p:cNvPr id="6" name="text-038921vgmvf">
-            <a:extLst xmlns:a="http://schemas.openxmlformats.org/drawingml/2006/main">
-              <a:ext uri="{FF2B5EF4-FFF2-40B4-BE49-F238E27FC236}">
-                <a16:creationId xmlns:a16="http://schemas.microsoft.com/office/drawing/2014/main" id="{F6168E8F-2C98-45F5-AEDB-B8936DC105A2}"/>
+          <p:cNvPr id="6" name="text-n6lufenej8">
+            <a:extLst xmlns:a="http://schemas.openxmlformats.org/drawingml/2006/main">
+              <a:ext uri="{FF2B5EF4-FFF2-40B4-BE49-F238E27FC236}">
+                <a16:creationId xmlns:a16="http://schemas.microsoft.com/office/drawing/2014/main" id="{43B40331-E187-4854-BE9A-B829594CEFF8}"/>
               </a:ext>
             </a:extLst>
           </p:cNvPr>
@@ -2176,10 +2166,10 @@
       </p:sp>
       <p:sp>
         <p:nvSpPr>
-          <p:cNvPr id="7" name="text-cjjnys3ryo5">
-            <a:extLst xmlns:a="http://schemas.openxmlformats.org/drawingml/2006/main">
-              <a:ext uri="{FF2B5EF4-FFF2-40B4-BE49-F238E27FC236}">
-                <a16:creationId xmlns:a16="http://schemas.microsoft.com/office/drawing/2014/main" id="{3F0290BA-7F79-4E70-A772-EBC116D5C000}"/>
+          <p:cNvPr id="7" name="text-6zyl7jjt2u7">
+            <a:extLst xmlns:a="http://schemas.openxmlformats.org/drawingml/2006/main">
+              <a:ext uri="{FF2B5EF4-FFF2-40B4-BE49-F238E27FC236}">
+                <a16:creationId xmlns:a16="http://schemas.microsoft.com/office/drawing/2014/main" id="{12633BBD-7B5B-4F58-BAC2-A7EA1E38DF3B}"/>
               </a:ext>
             </a:extLst>
           </p:cNvPr>
@@ -2234,10 +2224,10 @@
       </p:sp>
       <p:sp>
         <p:nvSpPr>
-          <p:cNvPr id="8" name="text-abnlh0hokcj">
-            <a:extLst xmlns:a="http://schemas.openxmlformats.org/drawingml/2006/main">
-              <a:ext uri="{FF2B5EF4-FFF2-40B4-BE49-F238E27FC236}">
-                <a16:creationId xmlns:a16="http://schemas.microsoft.com/office/drawing/2014/main" id="{93524D25-558A-48F1-9A12-0F66C8BE84D1}"/>
+          <p:cNvPr id="8" name="text-35synjic5z2">
+            <a:extLst xmlns:a="http://schemas.openxmlformats.org/drawingml/2006/main">
+              <a:ext uri="{FF2B5EF4-FFF2-40B4-BE49-F238E27FC236}">
+                <a16:creationId xmlns:a16="http://schemas.microsoft.com/office/drawing/2014/main" id="{043F17E0-0EDE-4468-9DDD-A501D5A2D457}"/>
               </a:ext>
             </a:extLst>
           </p:cNvPr>
@@ -2293,7 +2283,7 @@
     </p:spTree>
     <p:extLst>
       <p:ext uri="{BB962C8B-B14F-4D97-AF65-F5344CB8AC3E}">
-        <p14:creationId xmlns:p14="http://schemas.microsoft.com/office/powerpoint/2010/main" val="258964886"/>
+        <p14:creationId xmlns:p14="http://schemas.microsoft.com/office/powerpoint/2010/main" val="1332479318"/>
       </p:ext>
     </p:extLst>
   </p:cSld>
@@ -2321,10 +2311,10 @@
       </p:grpSpPr>
       <p:sp>
         <p:nvSpPr>
-          <p:cNvPr id="6" name="text-dcj1z8vf8h">
-            <a:extLst xmlns:a="http://schemas.openxmlformats.org/drawingml/2006/main">
-              <a:ext uri="{FF2B5EF4-FFF2-40B4-BE49-F238E27FC236}">
-                <a16:creationId xmlns:a16="http://schemas.microsoft.com/office/drawing/2014/main" id="{6310D907-65BC-44FD-9172-8F829F3A4E8D}"/>
+          <p:cNvPr id="6" name="text-828hxhxomcd">
+            <a:extLst xmlns:a="http://schemas.openxmlformats.org/drawingml/2006/main">
+              <a:ext uri="{FF2B5EF4-FFF2-40B4-BE49-F238E27FC236}">
+                <a16:creationId xmlns:a16="http://schemas.microsoft.com/office/drawing/2014/main" id="{7E510784-B585-46EA-8FFA-54F99D647BCB}"/>
               </a:ext>
             </a:extLst>
           </p:cNvPr>
@@ -2379,10 +2369,10 @@
       </p:sp>
       <p:sp>
         <p:nvSpPr>
-          <p:cNvPr id="2" name="text-qpr0i83amca">
-            <a:extLst xmlns:a="http://schemas.openxmlformats.org/drawingml/2006/main">
-              <a:ext uri="{FF2B5EF4-FFF2-40B4-BE49-F238E27FC236}">
-                <a16:creationId xmlns:a16="http://schemas.microsoft.com/office/drawing/2014/main" id="{E32A8604-328B-44ED-8B4F-F9D6B5571EB5}"/>
+          <p:cNvPr id="2" name="text-lq01gddf6le">
+            <a:extLst xmlns:a="http://schemas.openxmlformats.org/drawingml/2006/main">
+              <a:ext uri="{FF2B5EF4-FFF2-40B4-BE49-F238E27FC236}">
+                <a16:creationId xmlns:a16="http://schemas.microsoft.com/office/drawing/2014/main" id="{7EB74461-9B3A-485F-895D-7CEB0AC425BD}"/>
               </a:ext>
             </a:extLst>
           </p:cNvPr>
@@ -2394,25 +2384,25 @@
         <p:spPr>
           <a:xfrm xmlns:a="http://schemas.openxmlformats.org/drawingml/2006/main">
             <a:off x="571500" y="1428750"/>
-            <a:ext cx="8572500" cy="904875"/>
-          </a:xfrm>
-          <a:prstGeom xmlns:a="http://schemas.openxmlformats.org/drawingml/2006/main" prst="rect">
-            <a:avLst/>
-          </a:prstGeom>
-          <a:noFill xmlns:a="http://schemas.openxmlformats.org/drawingml/2006/main"/>
-          <a:ln xmlns:a="http://schemas.openxmlformats.org/drawingml/2006/main" w="0">
-            <a:noFill/>
-            <a:prstDash val="solid"/>
-          </a:ln>
-        </p:spPr>
-        <p:txBody>
-          <a:bodyPr xmlns:a="http://schemas.openxmlformats.org/drawingml/2006/main" anchor="t">
-            <a:normAutofit fontScale="100000"/>
-          </a:bodyPr>
-          <a:lstStyle xmlns:a="http://schemas.openxmlformats.org/drawingml/2006/main"/>
-          <a:p xmlns:a="http://schemas.openxmlformats.org/drawingml/2006/main">
-            <a:pPr algn="l">
-              <a:defRPr sz="3900" b="1">
+            <a:ext cx="9525000" cy="1047750"/>
+          </a:xfrm>
+          <a:prstGeom xmlns:a="http://schemas.openxmlformats.org/drawingml/2006/main" prst="rect">
+            <a:avLst/>
+          </a:prstGeom>
+          <a:noFill xmlns:a="http://schemas.openxmlformats.org/drawingml/2006/main"/>
+          <a:ln xmlns:a="http://schemas.openxmlformats.org/drawingml/2006/main" w="0">
+            <a:noFill/>
+            <a:prstDash val="solid"/>
+          </a:ln>
+        </p:spPr>
+        <p:txBody>
+          <a:bodyPr xmlns:a="http://schemas.openxmlformats.org/drawingml/2006/main" anchor="t">
+            <a:normAutofit fontScale="85374"/>
+          </a:bodyPr>
+          <a:lstStyle xmlns:a="http://schemas.openxmlformats.org/drawingml/2006/main"/>
+          <a:p xmlns:a="http://schemas.openxmlformats.org/drawingml/2006/main">
+            <a:pPr algn="l">
+              <a:defRPr sz="3675" b="1">
                 <a:solidFill>
                   <a:srgbClr val="FFFFFF"/>
                 </a:solidFill>
@@ -2422,7 +2412,7 @@
               </a:defRPr>
             </a:pPr>
             <a:r>
-              <a:rPr sz="3900" b="1">
+              <a:rPr sz="3675" b="1">
                 <a:solidFill>
                   <a:srgbClr val="FFFFFF"/>
                 </a:solidFill>
@@ -2430,17 +2420,17 @@
                 <a:ea typeface="Arial"/>
                 <a:cs typeface="Arial"/>
               </a:rPr>
-              <a:t>Build an occasion-to-habit engine</a:t>
-            </a:r>
-          </a:p>
-        </p:txBody>
-      </p:sp>
-      <p:sp>
-        <p:nvSpPr>
-          <p:cNvPr id="3" name="text-ox27ive7n">
-            <a:extLst xmlns:a="http://schemas.openxmlformats.org/drawingml/2006/main">
-              <a:ext uri="{FF2B5EF4-FFF2-40B4-BE49-F238E27FC236}">
-                <a16:creationId xmlns:a16="http://schemas.microsoft.com/office/drawing/2014/main" id="{E5A7BE1F-7510-44BC-BDC7-4FC8BF215DD9}"/>
+              <a:t>Test one occasion, then scale on repeat and margin</a:t>
+            </a:r>
+          </a:p>
+        </p:txBody>
+      </p:sp>
+      <p:sp>
+        <p:nvSpPr>
+          <p:cNvPr id="3" name="text-0l9yfiqn3tol">
+            <a:extLst xmlns:a="http://schemas.openxmlformats.org/drawingml/2006/main">
+              <a:ext uri="{FF2B5EF4-FFF2-40B4-BE49-F238E27FC236}">
+                <a16:creationId xmlns:a16="http://schemas.microsoft.com/office/drawing/2014/main" id="{79E8A5CF-E4E6-493B-B254-2475CCDCCC09}"/>
               </a:ext>
             </a:extLst>
           </p:cNvPr>
@@ -2573,10 +2563,10 @@
       </p:cxnSp>
       <p:sp>
         <p:nvSpPr>
-          <p:cNvPr id="5" name="text-ggn2dhypeas">
-            <a:extLst xmlns:a="http://schemas.openxmlformats.org/drawingml/2006/main">
-              <a:ext uri="{FF2B5EF4-FFF2-40B4-BE49-F238E27FC236}">
-                <a16:creationId xmlns:a16="http://schemas.microsoft.com/office/drawing/2014/main" id="{D326EC26-6E92-4DB3-B538-7433F20CCFDA}"/>
+          <p:cNvPr id="5" name="text-7w5uhxsf7fl">
+            <a:extLst xmlns:a="http://schemas.openxmlformats.org/drawingml/2006/main">
+              <a:ext uri="{FF2B5EF4-FFF2-40B4-BE49-F238E27FC236}">
+                <a16:creationId xmlns:a16="http://schemas.microsoft.com/office/drawing/2014/main" id="{2BD6EE81-E176-4DD4-8915-77CA70382CA8}"/>
               </a:ext>
             </a:extLst>
           </p:cNvPr>
@@ -2624,7 +2614,7 @@
                 <a:ea typeface="Arial"/>
                 <a:cs typeface="Arial"/>
               </a:rPr>
-              <a:t>Independent public-source case study by Keshav Kapoor. I did not work for Coca-Cola.</a:t>
+              <a:t>Keshav Kapoor | Independent public-source case | 2026</a:t>
             </a:r>
           </a:p>
         </p:txBody>
@@ -2632,7 +2622,7 @@
     </p:spTree>
     <p:extLst>
       <p:ext uri="{BB962C8B-B14F-4D97-AF65-F5344CB8AC3E}">
-        <p14:creationId xmlns:p14="http://schemas.microsoft.com/office/powerpoint/2010/main" val="1226363921"/>
+        <p14:creationId xmlns:p14="http://schemas.microsoft.com/office/powerpoint/2010/main" val="633181783"/>
       </p:ext>
     </p:extLst>
   </p:cSld>
@@ -2660,10 +2650,10 @@
       </p:grpSpPr>
       <p:sp>
         <p:nvSpPr>
-          <p:cNvPr id="10" name="text-310vsc4udve">
-            <a:extLst xmlns:a="http://schemas.openxmlformats.org/drawingml/2006/main">
-              <a:ext uri="{FF2B5EF4-FFF2-40B4-BE49-F238E27FC236}">
-                <a16:creationId xmlns:a16="http://schemas.microsoft.com/office/drawing/2014/main" id="{A43D153D-A40C-4777-BEE9-244C5AF28284}"/>
+          <p:cNvPr id="10" name="text-dr04fsssa2k">
+            <a:extLst xmlns:a="http://schemas.openxmlformats.org/drawingml/2006/main">
+              <a:ext uri="{FF2B5EF4-FFF2-40B4-BE49-F238E27FC236}">
+                <a16:creationId xmlns:a16="http://schemas.microsoft.com/office/drawing/2014/main" id="{14C43424-966C-4D10-A78B-008D6F568972}"/>
               </a:ext>
             </a:extLst>
           </p:cNvPr>
@@ -2718,10 +2708,10 @@
       </p:sp>
       <p:sp>
         <p:nvSpPr>
-          <p:cNvPr id="2" name="text-26ziq8fyjjh">
-            <a:extLst xmlns:a="http://schemas.openxmlformats.org/drawingml/2006/main">
-              <a:ext uri="{FF2B5EF4-FFF2-40B4-BE49-F238E27FC236}">
-                <a16:creationId xmlns:a16="http://schemas.microsoft.com/office/drawing/2014/main" id="{3C70B14A-DE60-4D64-87D1-D12D2AF95829}"/>
+          <p:cNvPr id="2" name="text-s6e2pjt0vq">
+            <a:extLst xmlns:a="http://schemas.openxmlformats.org/drawingml/2006/main">
+              <a:ext uri="{FF2B5EF4-FFF2-40B4-BE49-F238E27FC236}">
+                <a16:creationId xmlns:a16="http://schemas.microsoft.com/office/drawing/2014/main" id="{B4EA8C15-A393-45EB-A489-CCF943B540F0}"/>
               </a:ext>
             </a:extLst>
           </p:cNvPr>
@@ -2769,17 +2759,17 @@
                 <a:ea typeface="Arial"/>
                 <a:cs typeface="Arial"/>
               </a:rPr>
-              <a:t>The growth opportunity is not one more campaign</a:t>
-            </a:r>
-          </a:p>
-        </p:txBody>
-      </p:sp>
-      <p:sp>
-        <p:nvSpPr>
-          <p:cNvPr id="3" name="text-cscz67vlyva">
-            <a:extLst xmlns:a="http://schemas.openxmlformats.org/drawingml/2006/main">
-              <a:ext uri="{FF2B5EF4-FFF2-40B4-BE49-F238E27FC236}">
-                <a16:creationId xmlns:a16="http://schemas.microsoft.com/office/drawing/2014/main" id="{298BEBB1-DF87-4639-8006-27706F947B8A}"/>
+              <a:t>Turn one high-reach occasion into a second purchase</a:t>
+            </a:r>
+          </a:p>
+        </p:txBody>
+      </p:sp>
+      <p:sp>
+        <p:nvSpPr>
+          <p:cNvPr id="3" name="text-e48mvaysld">
+            <a:extLst xmlns:a="http://schemas.openxmlformats.org/drawingml/2006/main">
+              <a:ext uri="{FF2B5EF4-FFF2-40B4-BE49-F238E27FC236}">
+                <a16:creationId xmlns:a16="http://schemas.microsoft.com/office/drawing/2014/main" id="{2C8D6C98-9A5A-4190-8FC9-7CD0290C694D}"/>
               </a:ext>
             </a:extLst>
           </p:cNvPr>
@@ -2834,10 +2824,10 @@
       </p:sp>
       <p:sp>
         <p:nvSpPr>
-          <p:cNvPr id="4" name="text-qsjbvihe80g">
-            <a:extLst xmlns:a="http://schemas.openxmlformats.org/drawingml/2006/main">
-              <a:ext uri="{FF2B5EF4-FFF2-40B4-BE49-F238E27FC236}">
-                <a16:creationId xmlns:a16="http://schemas.microsoft.com/office/drawing/2014/main" id="{52602DA3-FD6D-46E0-B49D-39B3639924A7}"/>
+          <p:cNvPr id="4" name="text-bul4qxzh2">
+            <a:extLst xmlns:a="http://schemas.openxmlformats.org/drawingml/2006/main">
+              <a:ext uri="{FF2B5EF4-FFF2-40B4-BE49-F238E27FC236}">
+                <a16:creationId xmlns:a16="http://schemas.microsoft.com/office/drawing/2014/main" id="{EA57FD1D-F52B-4A65-8409-F58EFDBDF19D}"/>
               </a:ext>
             </a:extLst>
           </p:cNvPr>
@@ -2849,7 +2839,65 @@
         <p:spPr>
           <a:xfrm xmlns:a="http://schemas.openxmlformats.org/drawingml/2006/main">
             <a:off x="514350" y="1762125"/>
-            <a:ext cx="7239000" cy="762000"/>
+            <a:ext cx="7239000" cy="952500"/>
+          </a:xfrm>
+          <a:prstGeom xmlns:a="http://schemas.openxmlformats.org/drawingml/2006/main" prst="rect">
+            <a:avLst/>
+          </a:prstGeom>
+          <a:noFill xmlns:a="http://schemas.openxmlformats.org/drawingml/2006/main"/>
+          <a:ln xmlns:a="http://schemas.openxmlformats.org/drawingml/2006/main" w="0">
+            <a:noFill/>
+            <a:prstDash val="solid"/>
+          </a:ln>
+        </p:spPr>
+        <p:txBody>
+          <a:bodyPr xmlns:a="http://schemas.openxmlformats.org/drawingml/2006/main" anchor="t">
+            <a:normAutofit fontScale="89682"/>
+          </a:bodyPr>
+          <a:lstStyle xmlns:a="http://schemas.openxmlformats.org/drawingml/2006/main"/>
+          <a:p xmlns:a="http://schemas.openxmlformats.org/drawingml/2006/main">
+            <a:pPr algn="l">
+              <a:defRPr sz="3150" b="1">
+                <a:solidFill>
+                  <a:srgbClr val="E41E2B"/>
+                </a:solidFill>
+                <a:latin typeface="Arial"/>
+                <a:ea typeface="Arial"/>
+                <a:cs typeface="Arial"/>
+              </a:defRPr>
+            </a:pPr>
+            <a:r>
+              <a:rPr sz="3150" b="1">
+                <a:solidFill>
+                  <a:srgbClr val="E41E2B"/>
+                </a:solidFill>
+                <a:latin typeface="Arial"/>
+                <a:ea typeface="Arial"/>
+                <a:cs typeface="Arial"/>
+              </a:rPr>
+              <a:t>Link the first shared drink to a clear return occasion.</a:t>
+            </a:r>
+          </a:p>
+        </p:txBody>
+      </p:sp>
+      <p:sp>
+        <p:nvSpPr>
+          <p:cNvPr id="5" name="text-wxzq63jksq">
+            <a:extLst xmlns:a="http://schemas.openxmlformats.org/drawingml/2006/main">
+              <a:ext uri="{FF2B5EF4-FFF2-40B4-BE49-F238E27FC236}">
+                <a16:creationId xmlns:a16="http://schemas.microsoft.com/office/drawing/2014/main" id="{9ED57FB4-A994-4F71-ACDB-5494E8B252DA}"/>
+              </a:ext>
+            </a:extLst>
+          </p:cNvPr>
+          <p:cNvSpPr>
+            <a:spLocks xmlns:a="http://schemas.openxmlformats.org/drawingml/2006/main" noGrp="1"/>
+          </p:cNvSpPr>
+          <p:nvPr/>
+        </p:nvSpPr>
+        <p:spPr>
+          <a:xfrm xmlns:a="http://schemas.openxmlformats.org/drawingml/2006/main">
+            <a:off x="514350" y="3000375"/>
+            <a:ext cx="6810375" cy="1381125"/>
           </a:xfrm>
           <a:prstGeom xmlns:a="http://schemas.openxmlformats.org/drawingml/2006/main" prst="rect">
             <a:avLst/>
@@ -2867,64 +2915,6 @@
           <a:lstStyle xmlns:a="http://schemas.openxmlformats.org/drawingml/2006/main"/>
           <a:p xmlns:a="http://schemas.openxmlformats.org/drawingml/2006/main">
             <a:pPr algn="l">
-              <a:defRPr sz="3450" b="1">
-                <a:solidFill>
-                  <a:srgbClr val="E41E2B"/>
-                </a:solidFill>
-                <a:latin typeface="Arial"/>
-                <a:ea typeface="Arial"/>
-                <a:cs typeface="Arial"/>
-              </a:defRPr>
-            </a:pPr>
-            <a:r>
-              <a:rPr sz="3450" b="1">
-                <a:solidFill>
-                  <a:srgbClr val="E41E2B"/>
-                </a:solidFill>
-                <a:latin typeface="Arial"/>
-                <a:ea typeface="Arial"/>
-                <a:cs typeface="Arial"/>
-              </a:rPr>
-              <a:t>It is an occasion-to-habit system.</a:t>
-            </a:r>
-          </a:p>
-        </p:txBody>
-      </p:sp>
-      <p:sp>
-        <p:nvSpPr>
-          <p:cNvPr id="5" name="text-gbc81knm0iv">
-            <a:extLst xmlns:a="http://schemas.openxmlformats.org/drawingml/2006/main">
-              <a:ext uri="{FF2B5EF4-FFF2-40B4-BE49-F238E27FC236}">
-                <a16:creationId xmlns:a16="http://schemas.microsoft.com/office/drawing/2014/main" id="{B9D57A50-BB96-4FFC-898D-02310647FBF8}"/>
-              </a:ext>
-            </a:extLst>
-          </p:cNvPr>
-          <p:cNvSpPr>
-            <a:spLocks xmlns:a="http://schemas.openxmlformats.org/drawingml/2006/main" noGrp="1"/>
-          </p:cNvSpPr>
-          <p:nvPr/>
-        </p:nvSpPr>
-        <p:spPr>
-          <a:xfrm xmlns:a="http://schemas.openxmlformats.org/drawingml/2006/main">
-            <a:off x="514350" y="2800350"/>
-            <a:ext cx="6810375" cy="1619250"/>
-          </a:xfrm>
-          <a:prstGeom xmlns:a="http://schemas.openxmlformats.org/drawingml/2006/main" prst="rect">
-            <a:avLst/>
-          </a:prstGeom>
-          <a:noFill xmlns:a="http://schemas.openxmlformats.org/drawingml/2006/main"/>
-          <a:ln xmlns:a="http://schemas.openxmlformats.org/drawingml/2006/main" w="0">
-            <a:noFill/>
-            <a:prstDash val="solid"/>
-          </a:ln>
-        </p:spPr>
-        <p:txBody>
-          <a:bodyPr xmlns:a="http://schemas.openxmlformats.org/drawingml/2006/main" anchor="t">
-            <a:normAutofit fontScale="100000"/>
-          </a:bodyPr>
-          <a:lstStyle xmlns:a="http://schemas.openxmlformats.org/drawingml/2006/main"/>
-          <a:p xmlns:a="http://schemas.openxmlformats.org/drawingml/2006/main">
-            <a:pPr algn="l">
               <a:defRPr sz="1950" b="0">
                 <a:solidFill>
                   <a:srgbClr val="111111"/>
@@ -2943,7 +2933,7 @@
                 <a:ea typeface="Arial"/>
                 <a:cs typeface="Arial"/>
               </a:rPr>
-              <a:t>Use the reach of a festival, campus moment or group celebration to create trial. Then give the shared drink a clear second occasion, an available pack and a reason to return.</a:t>
+              <a:t>A festival, campus moment or group celebration can create trial. Repeat depends on a second occasion, an available pack and a simple reason to return.</a:t>
             </a:r>
           </a:p>
         </p:txBody>
@@ -2953,7 +2943,7 @@
           <p:cNvPr id="6" name="">
             <a:extLst xmlns:a="http://schemas.openxmlformats.org/drawingml/2006/main">
               <a:ext uri="{FF2B5EF4-FFF2-40B4-BE49-F238E27FC236}">
-                <a16:creationId xmlns:a16="http://schemas.microsoft.com/office/drawing/2014/main" id="{81324CF8-9EC6-4F05-81B2-8317E2E72817}"/>
+                <a16:creationId xmlns:a16="http://schemas.microsoft.com/office/drawing/2014/main" id="{4228688B-8484-4F19-9B48-32829AAE1AD0}"/>
               </a:ext>
             </a:extLst>
           </p:cNvPr>
@@ -2981,10 +2971,10 @@
       </p:sp>
       <p:sp>
         <p:nvSpPr>
-          <p:cNvPr id="7" name="text-m4vlac7uxol">
-            <a:extLst xmlns:a="http://schemas.openxmlformats.org/drawingml/2006/main">
-              <a:ext uri="{FF2B5EF4-FFF2-40B4-BE49-F238E27FC236}">
-                <a16:creationId xmlns:a16="http://schemas.microsoft.com/office/drawing/2014/main" id="{75020A4E-19C8-45A1-9CEC-9AFF714D4863}"/>
+          <p:cNvPr id="7" name="text-i0yh8y5q5x">
+            <a:extLst xmlns:a="http://schemas.openxmlformats.org/drawingml/2006/main">
+              <a:ext uri="{FF2B5EF4-FFF2-40B4-BE49-F238E27FC236}">
+                <a16:creationId xmlns:a16="http://schemas.microsoft.com/office/drawing/2014/main" id="{F1383016-E4F0-4D82-A931-A34B7435797D}"/>
               </a:ext>
             </a:extLst>
           </p:cNvPr>
@@ -3039,10 +3029,10 @@
       </p:sp>
       <p:sp>
         <p:nvSpPr>
-          <p:cNvPr id="8" name="text-uubdf3qekzn">
-            <a:extLst xmlns:a="http://schemas.openxmlformats.org/drawingml/2006/main">
-              <a:ext uri="{FF2B5EF4-FFF2-40B4-BE49-F238E27FC236}">
-                <a16:creationId xmlns:a16="http://schemas.microsoft.com/office/drawing/2014/main" id="{B7B859CE-E1B2-4384-BC8F-0FA41411C7D3}"/>
+          <p:cNvPr id="8" name="text-smdvvcads9s">
+            <a:extLst xmlns:a="http://schemas.openxmlformats.org/drawingml/2006/main">
+              <a:ext uri="{FF2B5EF4-FFF2-40B4-BE49-F238E27FC236}">
+                <a16:creationId xmlns:a16="http://schemas.microsoft.com/office/drawing/2014/main" id="{0087E9DF-8874-4488-A717-FA8249477BD5}"/>
               </a:ext>
             </a:extLst>
           </p:cNvPr>
@@ -3181,10 +3171,10 @@
       </p:sp>
       <p:sp>
         <p:nvSpPr>
-          <p:cNvPr id="9" name="text-rpq868axokg">
-            <a:extLst xmlns:a="http://schemas.openxmlformats.org/drawingml/2006/main">
-              <a:ext uri="{FF2B5EF4-FFF2-40B4-BE49-F238E27FC236}">
-                <a16:creationId xmlns:a16="http://schemas.microsoft.com/office/drawing/2014/main" id="{DD5E93F8-8B80-4000-93F3-65D7BDEEF5AB}"/>
+          <p:cNvPr id="9" name="text-jshwpl6338">
+            <a:extLst xmlns:a="http://schemas.openxmlformats.org/drawingml/2006/main">
+              <a:ext uri="{FF2B5EF4-FFF2-40B4-BE49-F238E27FC236}">
+                <a16:creationId xmlns:a16="http://schemas.microsoft.com/office/drawing/2014/main" id="{8BBBB69E-F655-46CC-AEC4-C26E343B7AC1}"/>
               </a:ext>
             </a:extLst>
           </p:cNvPr>
@@ -3232,7 +3222,7 @@
                 <a:ea typeface="Arial"/>
                 <a:cs typeface="Arial"/>
               </a:rPr>
-              <a:t>This is a testable growth loop, not a claim about Coca-Cola's internal strategy.</a:t>
+              <a:t>The outlet test measures whether the second occasion changes purchases.</a:t>
             </a:r>
           </a:p>
         </p:txBody>
@@ -3240,7 +3230,7 @@
     </p:spTree>
     <p:extLst>
       <p:ext uri="{BB962C8B-B14F-4D97-AF65-F5344CB8AC3E}">
-        <p14:creationId xmlns:p14="http://schemas.microsoft.com/office/powerpoint/2010/main" val="550934353"/>
+        <p14:creationId xmlns:p14="http://schemas.microsoft.com/office/powerpoint/2010/main" val="167758644"/>
       </p:ext>
     </p:extLst>
   </p:cSld>
@@ -3268,10 +3258,10 @@
       </p:grpSpPr>
       <p:sp>
         <p:nvSpPr>
-          <p:cNvPr id="19" name="text-escdsn7o41v">
-            <a:extLst xmlns:a="http://schemas.openxmlformats.org/drawingml/2006/main">
-              <a:ext uri="{FF2B5EF4-FFF2-40B4-BE49-F238E27FC236}">
-                <a16:creationId xmlns:a16="http://schemas.microsoft.com/office/drawing/2014/main" id="{6A067A50-C5C9-44EE-9AC1-6E61802BAB40}"/>
+          <p:cNvPr id="19" name="text-9kythcwyd6v">
+            <a:extLst xmlns:a="http://schemas.openxmlformats.org/drawingml/2006/main">
+              <a:ext uri="{FF2B5EF4-FFF2-40B4-BE49-F238E27FC236}">
+                <a16:creationId xmlns:a16="http://schemas.microsoft.com/office/drawing/2014/main" id="{34D9F9B1-615D-48C3-90BB-5B9FA679FCB2}"/>
               </a:ext>
             </a:extLst>
           </p:cNvPr>
@@ -3326,10 +3316,10 @@
       </p:sp>
       <p:sp>
         <p:nvSpPr>
-          <p:cNvPr id="2" name="text-w7ap99c6rye">
-            <a:extLst xmlns:a="http://schemas.openxmlformats.org/drawingml/2006/main">
-              <a:ext uri="{FF2B5EF4-FFF2-40B4-BE49-F238E27FC236}">
-                <a16:creationId xmlns:a16="http://schemas.microsoft.com/office/drawing/2014/main" id="{3D14E118-E6F6-4693-B046-C119FB3A67B7}"/>
+          <p:cNvPr id="2" name="text-0cn6t7wflssi">
+            <a:extLst xmlns:a="http://schemas.openxmlformats.org/drawingml/2006/main">
+              <a:ext uri="{FF2B5EF4-FFF2-40B4-BE49-F238E27FC236}">
+                <a16:creationId xmlns:a16="http://schemas.microsoft.com/office/drawing/2014/main" id="{C602E350-B94F-469E-8389-FC941FC6AA5B}"/>
               </a:ext>
             </a:extLst>
           </p:cNvPr>
@@ -3377,17 +3367,17 @@
                 <a:ea typeface="Arial"/>
                 <a:cs typeface="Arial"/>
               </a:rPr>
-              <a:t>The public signal is a spike, not yet proof of a habit</a:t>
-            </a:r>
-          </a:p>
-        </p:txBody>
-      </p:sp>
-      <p:sp>
-        <p:nvSpPr>
-          <p:cNvPr id="3" name="text-2n41copztfc">
-            <a:extLst xmlns:a="http://schemas.openxmlformats.org/drawingml/2006/main">
-              <a:ext uri="{FF2B5EF4-FFF2-40B4-BE49-F238E27FC236}">
-                <a16:creationId xmlns:a16="http://schemas.microsoft.com/office/drawing/2014/main" id="{396E4CC5-9082-432B-8882-732C0BCFED75}"/>
+              <a:t>The public evidence raises a repeat-purchase question</a:t>
+            </a:r>
+          </a:p>
+        </p:txBody>
+      </p:sp>
+      <p:sp>
+        <p:nvSpPr>
+          <p:cNvPr id="3" name="text-rmwuldxl6fe">
+            <a:extLst xmlns:a="http://schemas.openxmlformats.org/drawingml/2006/main">
+              <a:ext uri="{FF2B5EF4-FFF2-40B4-BE49-F238E27FC236}">
+                <a16:creationId xmlns:a16="http://schemas.microsoft.com/office/drawing/2014/main" id="{51BC3DDF-04B9-4858-8177-B134E862107D}"/>
               </a:ext>
             </a:extLst>
           </p:cNvPr>
@@ -3467,7 +3457,7 @@
           <p:cNvPr id="5" name="">
             <a:extLst xmlns:a="http://schemas.openxmlformats.org/drawingml/2006/main">
               <a:ext uri="{FF2B5EF4-FFF2-40B4-BE49-F238E27FC236}">
-                <a16:creationId xmlns:a16="http://schemas.microsoft.com/office/drawing/2014/main" id="{A60E0378-4BB8-45D7-9AD5-F0995C873DE4}"/>
+                <a16:creationId xmlns:a16="http://schemas.microsoft.com/office/drawing/2014/main" id="{BF381F2B-A138-4FCA-9A0E-E7D524A5F158}"/>
               </a:ext>
             </a:extLst>
           </p:cNvPr>
@@ -3497,10 +3487,10 @@
       </p:sp>
       <p:sp>
         <p:nvSpPr>
-          <p:cNvPr id="6" name="text-q5sopl50v6">
-            <a:extLst xmlns:a="http://schemas.openxmlformats.org/drawingml/2006/main">
-              <a:ext uri="{FF2B5EF4-FFF2-40B4-BE49-F238E27FC236}">
-                <a16:creationId xmlns:a16="http://schemas.microsoft.com/office/drawing/2014/main" id="{2294FE50-05DD-4E68-902B-962241E12348}"/>
+          <p:cNvPr id="6" name="text-yct3x1isab">
+            <a:extLst xmlns:a="http://schemas.openxmlformats.org/drawingml/2006/main">
+              <a:ext uri="{FF2B5EF4-FFF2-40B4-BE49-F238E27FC236}">
+                <a16:creationId xmlns:a16="http://schemas.microsoft.com/office/drawing/2014/main" id="{F9624EA2-B36E-490B-94BE-37DA102E6DBC}"/>
               </a:ext>
             </a:extLst>
           </p:cNvPr>
@@ -3555,10 +3545,10 @@
       </p:sp>
       <p:sp>
         <p:nvSpPr>
-          <p:cNvPr id="7" name="text-pdf1e2stfup">
-            <a:extLst xmlns:a="http://schemas.openxmlformats.org/drawingml/2006/main">
-              <a:ext uri="{FF2B5EF4-FFF2-40B4-BE49-F238E27FC236}">
-                <a16:creationId xmlns:a16="http://schemas.microsoft.com/office/drawing/2014/main" id="{BD90B5C0-50F7-4F81-BD3D-AC67C5057E18}"/>
+          <p:cNvPr id="7" name="text-qnfcbwtl2be">
+            <a:extLst xmlns:a="http://schemas.openxmlformats.org/drawingml/2006/main">
+              <a:ext uri="{FF2B5EF4-FFF2-40B4-BE49-F238E27FC236}">
+                <a16:creationId xmlns:a16="http://schemas.microsoft.com/office/drawing/2014/main" id="{2381C8A5-902F-4F7A-AEE0-73531BC41AE3}"/>
               </a:ext>
             </a:extLst>
           </p:cNvPr>
@@ -3613,10 +3603,10 @@
       </p:sp>
       <p:sp>
         <p:nvSpPr>
-          <p:cNvPr id="8" name="text-7ls38ii1sjr">
-            <a:extLst xmlns:a="http://schemas.openxmlformats.org/drawingml/2006/main">
-              <a:ext uri="{FF2B5EF4-FFF2-40B4-BE49-F238E27FC236}">
-                <a16:creationId xmlns:a16="http://schemas.microsoft.com/office/drawing/2014/main" id="{CACEA017-C29F-4C73-99C4-EC181BA18C37}"/>
+          <p:cNvPr id="8" name="text-8w6fpgqeuql">
+            <a:extLst xmlns:a="http://schemas.openxmlformats.org/drawingml/2006/main">
+              <a:ext uri="{FF2B5EF4-FFF2-40B4-BE49-F238E27FC236}">
+                <a16:creationId xmlns:a16="http://schemas.microsoft.com/office/drawing/2014/main" id="{B3845B94-355D-45C4-883C-A68DF37A6E33}"/>
               </a:ext>
             </a:extLst>
           </p:cNvPr>
@@ -3674,7 +3664,7 @@
           <p:cNvPr id="9" name="">
             <a:extLst xmlns:a="http://schemas.openxmlformats.org/drawingml/2006/main">
               <a:ext uri="{FF2B5EF4-FFF2-40B4-BE49-F238E27FC236}">
-                <a16:creationId xmlns:a16="http://schemas.microsoft.com/office/drawing/2014/main" id="{45545A3D-ABF7-44EC-97F1-EC24E3F5428C}"/>
+                <a16:creationId xmlns:a16="http://schemas.microsoft.com/office/drawing/2014/main" id="{725FE021-BEA8-4129-B886-FB30618EB56F}"/>
               </a:ext>
             </a:extLst>
           </p:cNvPr>
@@ -3704,10 +3694,10 @@
       </p:sp>
       <p:sp>
         <p:nvSpPr>
-          <p:cNvPr id="10" name="text-sll3mrl8ueh">
-            <a:extLst xmlns:a="http://schemas.openxmlformats.org/drawingml/2006/main">
-              <a:ext uri="{FF2B5EF4-FFF2-40B4-BE49-F238E27FC236}">
-                <a16:creationId xmlns:a16="http://schemas.microsoft.com/office/drawing/2014/main" id="{0AF6C92D-18D5-40EE-9F87-BCCE7BB55D4D}"/>
+          <p:cNvPr id="10" name="text-m8ngcv71pm7">
+            <a:extLst xmlns:a="http://schemas.openxmlformats.org/drawingml/2006/main">
+              <a:ext uri="{FF2B5EF4-FFF2-40B4-BE49-F238E27FC236}">
+                <a16:creationId xmlns:a16="http://schemas.microsoft.com/office/drawing/2014/main" id="{449D251E-D1BF-49BE-98AA-F9E95FBB8D33}"/>
               </a:ext>
             </a:extLst>
           </p:cNvPr>
@@ -3762,10 +3752,10 @@
       </p:sp>
       <p:sp>
         <p:nvSpPr>
-          <p:cNvPr id="11" name="text-p161q3ichnh">
-            <a:extLst xmlns:a="http://schemas.openxmlformats.org/drawingml/2006/main">
-              <a:ext uri="{FF2B5EF4-FFF2-40B4-BE49-F238E27FC236}">
-                <a16:creationId xmlns:a16="http://schemas.microsoft.com/office/drawing/2014/main" id="{624A9278-AF03-4AC0-B9B5-B9BF38BD885B}"/>
+          <p:cNvPr id="11" name="text-sbud0k7odim">
+            <a:extLst xmlns:a="http://schemas.openxmlformats.org/drawingml/2006/main">
+              <a:ext uri="{FF2B5EF4-FFF2-40B4-BE49-F238E27FC236}">
+                <a16:creationId xmlns:a16="http://schemas.microsoft.com/office/drawing/2014/main" id="{F7648BDC-71CE-4C19-8F8E-B5167E872FA4}"/>
               </a:ext>
             </a:extLst>
           </p:cNvPr>
@@ -3820,10 +3810,10 @@
       </p:sp>
       <p:sp>
         <p:nvSpPr>
-          <p:cNvPr id="12" name="text-d78w3za2a9r">
-            <a:extLst xmlns:a="http://schemas.openxmlformats.org/drawingml/2006/main">
-              <a:ext uri="{FF2B5EF4-FFF2-40B4-BE49-F238E27FC236}">
-                <a16:creationId xmlns:a16="http://schemas.microsoft.com/office/drawing/2014/main" id="{34209E3D-8897-4F3A-AABE-F1A4BBFE0ACF}"/>
+          <p:cNvPr id="12" name="text-ojgoku1mnkc">
+            <a:extLst xmlns:a="http://schemas.openxmlformats.org/drawingml/2006/main">
+              <a:ext uri="{FF2B5EF4-FFF2-40B4-BE49-F238E27FC236}">
+                <a16:creationId xmlns:a16="http://schemas.microsoft.com/office/drawing/2014/main" id="{EF4EB0CE-0562-4587-9E05-DBC1E748A097}"/>
               </a:ext>
             </a:extLst>
           </p:cNvPr>
@@ -3881,7 +3871,7 @@
           <p:cNvPr id="13" name="">
             <a:extLst xmlns:a="http://schemas.openxmlformats.org/drawingml/2006/main">
               <a:ext uri="{FF2B5EF4-FFF2-40B4-BE49-F238E27FC236}">
-                <a16:creationId xmlns:a16="http://schemas.microsoft.com/office/drawing/2014/main" id="{3F532D35-A024-452C-94D0-DCF2764EE61A}"/>
+                <a16:creationId xmlns:a16="http://schemas.microsoft.com/office/drawing/2014/main" id="{D8498971-438C-4BB5-BEFD-DA4AE28C1D95}"/>
               </a:ext>
             </a:extLst>
           </p:cNvPr>
@@ -3911,10 +3901,10 @@
       </p:sp>
       <p:sp>
         <p:nvSpPr>
-          <p:cNvPr id="14" name="text-ozfee51672">
-            <a:extLst xmlns:a="http://schemas.openxmlformats.org/drawingml/2006/main">
-              <a:ext uri="{FF2B5EF4-FFF2-40B4-BE49-F238E27FC236}">
-                <a16:creationId xmlns:a16="http://schemas.microsoft.com/office/drawing/2014/main" id="{46CB2C3C-397C-4984-A160-1DB5BC198FD9}"/>
+          <p:cNvPr id="14" name="text-7gv62nbhni5">
+            <a:extLst xmlns:a="http://schemas.openxmlformats.org/drawingml/2006/main">
+              <a:ext uri="{FF2B5EF4-FFF2-40B4-BE49-F238E27FC236}">
+                <a16:creationId xmlns:a16="http://schemas.microsoft.com/office/drawing/2014/main" id="{1E7DB770-ACD7-479B-AD9F-DAE43171CD96}"/>
               </a:ext>
             </a:extLst>
           </p:cNvPr>
@@ -3969,10 +3959,10 @@
       </p:sp>
       <p:sp>
         <p:nvSpPr>
-          <p:cNvPr id="15" name="text-f0sp7c540wd">
-            <a:extLst xmlns:a="http://schemas.openxmlformats.org/drawingml/2006/main">
-              <a:ext uri="{FF2B5EF4-FFF2-40B4-BE49-F238E27FC236}">
-                <a16:creationId xmlns:a16="http://schemas.microsoft.com/office/drawing/2014/main" id="{F8378179-75B3-43D4-9034-7A0142718EA7}"/>
+          <p:cNvPr id="15" name="text-vyx5mma1mah">
+            <a:extLst xmlns:a="http://schemas.openxmlformats.org/drawingml/2006/main">
+              <a:ext uri="{FF2B5EF4-FFF2-40B4-BE49-F238E27FC236}">
+                <a16:creationId xmlns:a16="http://schemas.microsoft.com/office/drawing/2014/main" id="{6CE8B275-D637-4280-A9D4-306C55BABCCB}"/>
               </a:ext>
             </a:extLst>
           </p:cNvPr>
@@ -4027,10 +4017,10 @@
       </p:sp>
       <p:sp>
         <p:nvSpPr>
-          <p:cNvPr id="16" name="text-psk2s7jgnj">
-            <a:extLst xmlns:a="http://schemas.openxmlformats.org/drawingml/2006/main">
-              <a:ext uri="{FF2B5EF4-FFF2-40B4-BE49-F238E27FC236}">
-                <a16:creationId xmlns:a16="http://schemas.microsoft.com/office/drawing/2014/main" id="{D406363D-AE2E-43F0-96AE-A446FD12243E}"/>
+          <p:cNvPr id="16" name="text-pldeo9or1m">
+            <a:extLst xmlns:a="http://schemas.openxmlformats.org/drawingml/2006/main">
+              <a:ext uri="{FF2B5EF4-FFF2-40B4-BE49-F238E27FC236}">
+                <a16:creationId xmlns:a16="http://schemas.microsoft.com/office/drawing/2014/main" id="{848343A1-1773-4BBE-9F29-F107A2A4744F}"/>
               </a:ext>
             </a:extLst>
           </p:cNvPr>
@@ -4085,10 +4075,10 @@
       </p:sp>
       <p:sp>
         <p:nvSpPr>
-          <p:cNvPr id="17" name="text-8u1zacv3mdu">
-            <a:extLst xmlns:a="http://schemas.openxmlformats.org/drawingml/2006/main">
-              <a:ext uri="{FF2B5EF4-FFF2-40B4-BE49-F238E27FC236}">
-                <a16:creationId xmlns:a16="http://schemas.microsoft.com/office/drawing/2014/main" id="{FCAAB0DC-FEAC-4FFE-8662-EA8BA19F2B5F}"/>
+          <p:cNvPr id="17" name="text-45o91h40k6s">
+            <a:extLst xmlns:a="http://schemas.openxmlformats.org/drawingml/2006/main">
+              <a:ext uri="{FF2B5EF4-FFF2-40B4-BE49-F238E27FC236}">
+                <a16:creationId xmlns:a16="http://schemas.microsoft.com/office/drawing/2014/main" id="{89A965EC-E012-4CB0-8816-EC28A078DCBB}"/>
               </a:ext>
             </a:extLst>
           </p:cNvPr>
@@ -4143,10 +4133,10 @@
       </p:sp>
       <p:sp>
         <p:nvSpPr>
-          <p:cNvPr id="18" name="text-6pifyduj5ug">
-            <a:extLst xmlns:a="http://schemas.openxmlformats.org/drawingml/2006/main">
-              <a:ext uri="{FF2B5EF4-FFF2-40B4-BE49-F238E27FC236}">
-                <a16:creationId xmlns:a16="http://schemas.microsoft.com/office/drawing/2014/main" id="{58CC8799-0B81-4989-B18E-BEE9A6EC8956}"/>
+          <p:cNvPr id="18" name="text-elvx9kgy9vf">
+            <a:extLst xmlns:a="http://schemas.openxmlformats.org/drawingml/2006/main">
+              <a:ext uri="{FF2B5EF4-FFF2-40B4-BE49-F238E27FC236}">
+                <a16:creationId xmlns:a16="http://schemas.microsoft.com/office/drawing/2014/main" id="{091E96E5-1363-408E-AEAA-B11FD7CE35AF}"/>
               </a:ext>
             </a:extLst>
           </p:cNvPr>
@@ -4194,7 +4184,7 @@
                 <a:ea typeface="Arial"/>
                 <a:cs typeface="Arial"/>
               </a:rPr>
-              <a:t>The activation clearly created reach. The full-year number makes repeat the more valuable question. These periods are not directly comparable, so the answer needs an experiment, not a confident story.</a:t>
+              <a:t>The activation created reach. The full-year result makes repeat worth testing. Because the reporting periods differ, the conclusion should come from an outlet experiment.</a:t>
             </a:r>
           </a:p>
         </p:txBody>
@@ -4202,7 +4192,7 @@
     </p:spTree>
     <p:extLst>
       <p:ext uri="{BB962C8B-B14F-4D97-AF65-F5344CB8AC3E}">
-        <p14:creationId xmlns:p14="http://schemas.microsoft.com/office/powerpoint/2010/main" val="1949343537"/>
+        <p14:creationId xmlns:p14="http://schemas.microsoft.com/office/powerpoint/2010/main" val="1910872584"/>
       </p:ext>
     </p:extLst>
   </p:cSld>
@@ -4230,10 +4220,10 @@
       </p:grpSpPr>
       <p:sp>
         <p:nvSpPr>
-          <p:cNvPr id="18" name="text-2wfp9kmp675">
-            <a:extLst xmlns:a="http://schemas.openxmlformats.org/drawingml/2006/main">
-              <a:ext uri="{FF2B5EF4-FFF2-40B4-BE49-F238E27FC236}">
-                <a16:creationId xmlns:a16="http://schemas.microsoft.com/office/drawing/2014/main" id="{0D3ED4E2-1B2E-44D3-882C-017BEFB251A8}"/>
+          <p:cNvPr id="18" name="text-7euz96o24kx">
+            <a:extLst xmlns:a="http://schemas.openxmlformats.org/drawingml/2006/main">
+              <a:ext uri="{FF2B5EF4-FFF2-40B4-BE49-F238E27FC236}">
+                <a16:creationId xmlns:a16="http://schemas.microsoft.com/office/drawing/2014/main" id="{619A8001-BE4F-4F2D-B14F-F2D2DDB09CE6}"/>
               </a:ext>
             </a:extLst>
           </p:cNvPr>
@@ -4288,10 +4278,10 @@
       </p:sp>
       <p:sp>
         <p:nvSpPr>
-          <p:cNvPr id="2" name="text-m95ktetsjzm">
-            <a:extLst xmlns:a="http://schemas.openxmlformats.org/drawingml/2006/main">
-              <a:ext uri="{FF2B5EF4-FFF2-40B4-BE49-F238E27FC236}">
-                <a16:creationId xmlns:a16="http://schemas.microsoft.com/office/drawing/2014/main" id="{22E78715-6464-4F86-A746-76B8D7DFD9C8}"/>
+          <p:cNvPr id="2" name="text-5o9opy08usi">
+            <a:extLst xmlns:a="http://schemas.openxmlformats.org/drawingml/2006/main">
+              <a:ext uri="{FF2B5EF4-FFF2-40B4-BE49-F238E27FC236}">
+                <a16:creationId xmlns:a16="http://schemas.microsoft.com/office/drawing/2014/main" id="{5E13E78A-FC71-4228-AF77-57ED19502925}"/>
               </a:ext>
             </a:extLst>
           </p:cNvPr>
@@ -4316,7 +4306,7 @@
         </p:spPr>
         <p:txBody>
           <a:bodyPr xmlns:a="http://schemas.openxmlformats.org/drawingml/2006/main" anchor="t">
-            <a:normAutofit fontScale="95049"/>
+            <a:normAutofit fontScale="100000"/>
           </a:bodyPr>
           <a:lstStyle xmlns:a="http://schemas.openxmlformats.org/drawingml/2006/main"/>
           <a:p xmlns:a="http://schemas.openxmlformats.org/drawingml/2006/main">
@@ -4339,17 +4329,17 @@
                 <a:ea typeface="Arial"/>
                 <a:cs typeface="Arial"/>
               </a:rPr>
-              <a:t>Personalization works when the pack feels personal and shareable</a:t>
-            </a:r>
-          </a:p>
-        </p:txBody>
-      </p:sp>
-      <p:sp>
-        <p:nvSpPr>
-          <p:cNvPr id="3" name="text-ao2orhw5hwb">
-            <a:extLst xmlns:a="http://schemas.openxmlformats.org/drawingml/2006/main">
-              <a:ext uri="{FF2B5EF4-FFF2-40B4-BE49-F238E27FC236}">
-                <a16:creationId xmlns:a16="http://schemas.microsoft.com/office/drawing/2014/main" id="{78C4D8A2-95A3-4FA3-B7D2-DC67AD84C745}"/>
+              <a:t>Personalization creates a cue people can recognize and share</a:t>
+            </a:r>
+          </a:p>
+        </p:txBody>
+      </p:sp>
+      <p:sp>
+        <p:nvSpPr>
+          <p:cNvPr id="3" name="text-spb76lpias">
+            <a:extLst xmlns:a="http://schemas.openxmlformats.org/drawingml/2006/main">
+              <a:ext uri="{FF2B5EF4-FFF2-40B4-BE49-F238E27FC236}">
+                <a16:creationId xmlns:a16="http://schemas.microsoft.com/office/drawing/2014/main" id="{20FE31F3-0176-4CC6-B6FC-D3D0A07B7873}"/>
               </a:ext>
             </a:extLst>
           </p:cNvPr>
@@ -4404,10 +4394,10 @@
       </p:sp>
       <p:sp>
         <p:nvSpPr>
-          <p:cNvPr id="4" name="text-91jgkhbw31j">
-            <a:extLst xmlns:a="http://schemas.openxmlformats.org/drawingml/2006/main">
-              <a:ext uri="{FF2B5EF4-FFF2-40B4-BE49-F238E27FC236}">
-                <a16:creationId xmlns:a16="http://schemas.microsoft.com/office/drawing/2014/main" id="{31B70F4E-C52D-4A71-AE9A-A5CBFEB64C4F}"/>
+          <p:cNvPr id="4" name="text-cbt2o04jetb">
+            <a:extLst xmlns:a="http://schemas.openxmlformats.org/drawingml/2006/main">
+              <a:ext uri="{FF2B5EF4-FFF2-40B4-BE49-F238E27FC236}">
+                <a16:creationId xmlns:a16="http://schemas.microsoft.com/office/drawing/2014/main" id="{3206EB6E-49FD-4A8C-8016-5EB76EBE51E2}"/>
               </a:ext>
             </a:extLst>
           </p:cNvPr>
@@ -4462,10 +4452,10 @@
       </p:sp>
       <p:sp>
         <p:nvSpPr>
-          <p:cNvPr id="5" name="text-mk9dfs2qyr">
-            <a:extLst xmlns:a="http://schemas.openxmlformats.org/drawingml/2006/main">
-              <a:ext uri="{FF2B5EF4-FFF2-40B4-BE49-F238E27FC236}">
-                <a16:creationId xmlns:a16="http://schemas.microsoft.com/office/drawing/2014/main" id="{D9148BC4-FAEE-4BBB-A811-B5CDA9A1E809}"/>
+          <p:cNvPr id="5" name="text-tml84dcm9ff">
+            <a:extLst xmlns:a="http://schemas.openxmlformats.org/drawingml/2006/main">
+              <a:ext uri="{FF2B5EF4-FFF2-40B4-BE49-F238E27FC236}">
+                <a16:creationId xmlns:a16="http://schemas.microsoft.com/office/drawing/2014/main" id="{5E3BE2D2-5477-45D5-AB23-277047B9C6C7}"/>
               </a:ext>
             </a:extLst>
           </p:cNvPr>
@@ -4542,10 +4532,10 @@
       </p:cxnSp>
       <p:sp>
         <p:nvSpPr>
-          <p:cNvPr id="7" name="text-xx54e3kv5ya">
-            <a:extLst xmlns:a="http://schemas.openxmlformats.org/drawingml/2006/main">
-              <a:ext uri="{FF2B5EF4-FFF2-40B4-BE49-F238E27FC236}">
-                <a16:creationId xmlns:a16="http://schemas.microsoft.com/office/drawing/2014/main" id="{0F986EB1-604A-4E1A-87F0-CC39119B8436}"/>
+          <p:cNvPr id="7" name="text-htg8mglocx">
+            <a:extLst xmlns:a="http://schemas.openxmlformats.org/drawingml/2006/main">
+              <a:ext uri="{FF2B5EF4-FFF2-40B4-BE49-F238E27FC236}">
+                <a16:creationId xmlns:a16="http://schemas.microsoft.com/office/drawing/2014/main" id="{D8DC9C73-170A-4A88-8B4E-C47252171B1A}"/>
               </a:ext>
             </a:extLst>
           </p:cNvPr>
@@ -4593,17 +4583,17 @@
                 <a:ea typeface="Arial"/>
                 <a:cs typeface="Arial"/>
               </a:rPr>
-              <a:t>Self-referential processing can make brand information easier to remember.</a:t>
-            </a:r>
-          </a:p>
-        </p:txBody>
-      </p:sp>
-      <p:sp>
-        <p:nvSpPr>
-          <p:cNvPr id="8" name="text-d752jblehe6">
-            <a:extLst xmlns:a="http://schemas.openxmlformats.org/drawingml/2006/main">
-              <a:ext uri="{FF2B5EF4-FFF2-40B4-BE49-F238E27FC236}">
-                <a16:creationId xmlns:a16="http://schemas.microsoft.com/office/drawing/2014/main" id="{2D3C1847-21D3-425D-998D-5523DC5AB4D8}"/>
+              <a:t>Self-reference can make brand information easier to remember.</a:t>
+            </a:r>
+          </a:p>
+        </p:txBody>
+      </p:sp>
+      <p:sp>
+        <p:nvSpPr>
+          <p:cNvPr id="8" name="text-8cdekx00i3q">
+            <a:extLst xmlns:a="http://schemas.openxmlformats.org/drawingml/2006/main">
+              <a:ext uri="{FF2B5EF4-FFF2-40B4-BE49-F238E27FC236}">
+                <a16:creationId xmlns:a16="http://schemas.microsoft.com/office/drawing/2014/main" id="{9529ABF9-9299-4EE3-B1FB-60466C6B6260}"/>
               </a:ext>
             </a:extLst>
           </p:cNvPr>
@@ -4658,10 +4648,10 @@
       </p:sp>
       <p:sp>
         <p:nvSpPr>
-          <p:cNvPr id="9" name="text-0l93zxmhfo">
-            <a:extLst xmlns:a="http://schemas.openxmlformats.org/drawingml/2006/main">
-              <a:ext uri="{FF2B5EF4-FFF2-40B4-BE49-F238E27FC236}">
-                <a16:creationId xmlns:a16="http://schemas.microsoft.com/office/drawing/2014/main" id="{02715694-6673-41C8-9176-F685AA35D79D}"/>
+          <p:cNvPr id="9" name="text-x3ij7h01nhr">
+            <a:extLst xmlns:a="http://schemas.openxmlformats.org/drawingml/2006/main">
+              <a:ext uri="{FF2B5EF4-FFF2-40B4-BE49-F238E27FC236}">
+                <a16:creationId xmlns:a16="http://schemas.microsoft.com/office/drawing/2014/main" id="{97BE8D56-F353-4EA5-BE5C-C810D820637C}"/>
               </a:ext>
             </a:extLst>
           </p:cNvPr>
@@ -4738,10 +4728,10 @@
       </p:cxnSp>
       <p:sp>
         <p:nvSpPr>
-          <p:cNvPr id="11" name="text-uf3on6193kk">
-            <a:extLst xmlns:a="http://schemas.openxmlformats.org/drawingml/2006/main">
-              <a:ext uri="{FF2B5EF4-FFF2-40B4-BE49-F238E27FC236}">
-                <a16:creationId xmlns:a16="http://schemas.microsoft.com/office/drawing/2014/main" id="{EA858077-E885-4EB0-8CEE-3AC3C49AD793}"/>
+          <p:cNvPr id="11" name="text-nje8jzq2tti">
+            <a:extLst xmlns:a="http://schemas.openxmlformats.org/drawingml/2006/main">
+              <a:ext uri="{FF2B5EF4-FFF2-40B4-BE49-F238E27FC236}">
+                <a16:creationId xmlns:a16="http://schemas.microsoft.com/office/drawing/2014/main" id="{423FDF63-2956-40B5-96F3-29EE5E948695}"/>
               </a:ext>
             </a:extLst>
           </p:cNvPr>
@@ -4789,17 +4779,17 @@
                 <a:ea typeface="Arial"/>
                 <a:cs typeface="Arial"/>
               </a:rPr>
-              <a:t>A study on adding a customer's name to a standard product linked the effect to psychological ownership and product attitude.</a:t>
-            </a:r>
-          </a:p>
-        </p:txBody>
-      </p:sp>
-      <p:sp>
-        <p:nvSpPr>
-          <p:cNvPr id="12" name="text-z6b8u1ov2q8">
-            <a:extLst xmlns:a="http://schemas.openxmlformats.org/drawingml/2006/main">
-              <a:ext uri="{FF2B5EF4-FFF2-40B4-BE49-F238E27FC236}">
-                <a16:creationId xmlns:a16="http://schemas.microsoft.com/office/drawing/2014/main" id="{A112509F-5F01-468C-8B49-F93231076B74}"/>
+              <a:t>Adding a customer's name may build psychological ownership and improve product attitude.</a:t>
+            </a:r>
+          </a:p>
+        </p:txBody>
+      </p:sp>
+      <p:sp>
+        <p:nvSpPr>
+          <p:cNvPr id="12" name="text-ylwmpzzy67">
+            <a:extLst xmlns:a="http://schemas.openxmlformats.org/drawingml/2006/main">
+              <a:ext uri="{FF2B5EF4-FFF2-40B4-BE49-F238E27FC236}">
+                <a16:creationId xmlns:a16="http://schemas.microsoft.com/office/drawing/2014/main" id="{8A083B83-219D-4C23-B5A3-B820D122013D}"/>
               </a:ext>
             </a:extLst>
           </p:cNvPr>
@@ -4854,10 +4844,10 @@
       </p:sp>
       <p:sp>
         <p:nvSpPr>
-          <p:cNvPr id="13" name="text-dx8ix8i0lag">
-            <a:extLst xmlns:a="http://schemas.openxmlformats.org/drawingml/2006/main">
-              <a:ext uri="{FF2B5EF4-FFF2-40B4-BE49-F238E27FC236}">
-                <a16:creationId xmlns:a16="http://schemas.microsoft.com/office/drawing/2014/main" id="{04B0C3F2-16C6-4EEA-9269-FFE0B7F42D9C}"/>
+          <p:cNvPr id="13" name="text-htzlumrzxgr">
+            <a:extLst xmlns:a="http://schemas.openxmlformats.org/drawingml/2006/main">
+              <a:ext uri="{FF2B5EF4-FFF2-40B4-BE49-F238E27FC236}">
+                <a16:creationId xmlns:a16="http://schemas.microsoft.com/office/drawing/2014/main" id="{DDA03136-1A06-492D-B4D5-6651FF3FBD8E}"/>
               </a:ext>
             </a:extLst>
           </p:cNvPr>
@@ -4934,10 +4924,10 @@
       </p:cxnSp>
       <p:sp>
         <p:nvSpPr>
-          <p:cNvPr id="15" name="text-vlpq4ho2zji">
-            <a:extLst xmlns:a="http://schemas.openxmlformats.org/drawingml/2006/main">
-              <a:ext uri="{FF2B5EF4-FFF2-40B4-BE49-F238E27FC236}">
-                <a16:creationId xmlns:a16="http://schemas.microsoft.com/office/drawing/2014/main" id="{409B8732-5C5F-475C-A003-7EF97F49BC74}"/>
+          <p:cNvPr id="15" name="text-e1fqsncnnfc">
+            <a:extLst xmlns:a="http://schemas.openxmlformats.org/drawingml/2006/main">
+              <a:ext uri="{FF2B5EF4-FFF2-40B4-BE49-F238E27FC236}">
+                <a16:creationId xmlns:a16="http://schemas.microsoft.com/office/drawing/2014/main" id="{311AB609-6D9A-428E-B0CE-2CC2D7EACD61}"/>
               </a:ext>
             </a:extLst>
           </p:cNvPr>
@@ -4985,17 +4975,17 @@
                 <a:ea typeface="Arial"/>
                 <a:cs typeface="Arial"/>
               </a:rPr>
-              <a:t>Share a Coke turns packaging into an invitation to give, post or start a group moment.</a:t>
-            </a:r>
-          </a:p>
-        </p:txBody>
-      </p:sp>
-      <p:sp>
-        <p:nvSpPr>
-          <p:cNvPr id="16" name="text-pw9kkdmo1nj">
-            <a:extLst xmlns:a="http://schemas.openxmlformats.org/drawingml/2006/main">
-              <a:ext uri="{FF2B5EF4-FFF2-40B4-BE49-F238E27FC236}">
-                <a16:creationId xmlns:a16="http://schemas.microsoft.com/office/drawing/2014/main" id="{C2820A50-30E3-41A2-8549-5489BC1B0F57}"/>
+              <a:t>Share a Coke turns the pack into an invitation to give or start a group moment.</a:t>
+            </a:r>
+          </a:p>
+        </p:txBody>
+      </p:sp>
+      <p:sp>
+        <p:nvSpPr>
+          <p:cNvPr id="16" name="text-bzlb4k3x4af">
+            <a:extLst xmlns:a="http://schemas.openxmlformats.org/drawingml/2006/main">
+              <a:ext uri="{FF2B5EF4-FFF2-40B4-BE49-F238E27FC236}">
+                <a16:creationId xmlns:a16="http://schemas.microsoft.com/office/drawing/2014/main" id="{A8E2D3F5-4319-4AA7-80B2-50515B43BD45}"/>
               </a:ext>
             </a:extLst>
           </p:cNvPr>
@@ -5050,10 +5040,10 @@
       </p:sp>
       <p:sp>
         <p:nvSpPr>
-          <p:cNvPr id="17" name="text-p3htuj9dre">
-            <a:extLst xmlns:a="http://schemas.openxmlformats.org/drawingml/2006/main">
-              <a:ext uri="{FF2B5EF4-FFF2-40B4-BE49-F238E27FC236}">
-                <a16:creationId xmlns:a16="http://schemas.microsoft.com/office/drawing/2014/main" id="{92265E74-A65B-4D7F-9E83-1A22102BCC1C}"/>
+          <p:cNvPr id="17" name="text-jb3el7uhlb">
+            <a:extLst xmlns:a="http://schemas.openxmlformats.org/drawingml/2006/main">
+              <a:ext uri="{FF2B5EF4-FFF2-40B4-BE49-F238E27FC236}">
+                <a16:creationId xmlns:a16="http://schemas.microsoft.com/office/drawing/2014/main" id="{EEFF1CA3-1ADA-4503-A962-A97E5FBD403B}"/>
               </a:ext>
             </a:extLst>
           </p:cNvPr>
@@ -5101,7 +5091,7 @@
                 <a:ea typeface="Arial"/>
                 <a:cs typeface="Arial"/>
               </a:rPr>
-              <a:t>Do not stop at printing names. Tie the cue to a real relationship and a second occasion that can be observed at the outlet.</a:t>
+              <a:t>Tie the name or role to a real relationship and a second occasion that can be observed at the outlet.</a:t>
             </a:r>
           </a:p>
         </p:txBody>
@@ -5109,7 +5099,7 @@
     </p:spTree>
     <p:extLst>
       <p:ext uri="{BB962C8B-B14F-4D97-AF65-F5344CB8AC3E}">
-        <p14:creationId xmlns:p14="http://schemas.microsoft.com/office/powerpoint/2010/main" val="403269921"/>
+        <p14:creationId xmlns:p14="http://schemas.microsoft.com/office/powerpoint/2010/main" val="1479944393"/>
       </p:ext>
     </p:extLst>
   </p:cSld>
@@ -5137,10 +5127,10 @@
       </p:grpSpPr>
       <p:sp>
         <p:nvSpPr>
-          <p:cNvPr id="30" name="text-vzcm5xu2akf">
-            <a:extLst xmlns:a="http://schemas.openxmlformats.org/drawingml/2006/main">
-              <a:ext uri="{FF2B5EF4-FFF2-40B4-BE49-F238E27FC236}">
-                <a16:creationId xmlns:a16="http://schemas.microsoft.com/office/drawing/2014/main" id="{D4FACC05-CEA6-479E-AF55-C61FA268A1D4}"/>
+          <p:cNvPr id="30" name="text-y7yqd0yrmoe">
+            <a:extLst xmlns:a="http://schemas.openxmlformats.org/drawingml/2006/main">
+              <a:ext uri="{FF2B5EF4-FFF2-40B4-BE49-F238E27FC236}">
+                <a16:creationId xmlns:a16="http://schemas.microsoft.com/office/drawing/2014/main" id="{22A5A81A-BD85-40CB-9C68-03E14C203B95}"/>
               </a:ext>
             </a:extLst>
           </p:cNvPr>
@@ -5195,10 +5185,10 @@
       </p:sp>
       <p:sp>
         <p:nvSpPr>
-          <p:cNvPr id="2" name="text-qnhgbclj99p">
-            <a:extLst xmlns:a="http://schemas.openxmlformats.org/drawingml/2006/main">
-              <a:ext uri="{FF2B5EF4-FFF2-40B4-BE49-F238E27FC236}">
-                <a16:creationId xmlns:a16="http://schemas.microsoft.com/office/drawing/2014/main" id="{A474E1DF-4010-4DE5-832D-BDFA5C064252}"/>
+          <p:cNvPr id="2" name="text-fm0sytt9oxw">
+            <a:extLst xmlns:a="http://schemas.openxmlformats.org/drawingml/2006/main">
+              <a:ext uri="{FF2B5EF4-FFF2-40B4-BE49-F238E27FC236}">
+                <a16:creationId xmlns:a16="http://schemas.microsoft.com/office/drawing/2014/main" id="{7EC665DB-CE3C-42F0-9434-C35F7C9F87B9}"/>
               </a:ext>
             </a:extLst>
           </p:cNvPr>
@@ -5223,7 +5213,7 @@
         </p:spPr>
         <p:txBody>
           <a:bodyPr xmlns:a="http://schemas.openxmlformats.org/drawingml/2006/main" anchor="t">
-            <a:normAutofit fontScale="94220"/>
+            <a:normAutofit fontScale="100000"/>
           </a:bodyPr>
           <a:lstStyle xmlns:a="http://schemas.openxmlformats.org/drawingml/2006/main"/>
           <a:p xmlns:a="http://schemas.openxmlformats.org/drawingml/2006/main">
@@ -5246,17 +5236,17 @@
                 <a:ea typeface="Arial"/>
                 <a:cs typeface="Arial"/>
               </a:rPr>
-              <a:t>The missing bridge sits between the first share and the second buy</a:t>
-            </a:r>
-          </a:p>
-        </p:txBody>
-      </p:sp>
-      <p:sp>
-        <p:nvSpPr>
-          <p:cNvPr id="3" name="text-ur8ml4t65qn">
-            <a:extLst xmlns:a="http://schemas.openxmlformats.org/drawingml/2006/main">
-              <a:ext uri="{FF2B5EF4-FFF2-40B4-BE49-F238E27FC236}">
-                <a16:creationId xmlns:a16="http://schemas.microsoft.com/office/drawing/2014/main" id="{2DDEBB27-B9D0-452C-9421-21DC5FD7FF76}"/>
+              <a:t>The repeat mechanism needs five linked steps</a:t>
+            </a:r>
+          </a:p>
+        </p:txBody>
+      </p:sp>
+      <p:sp>
+        <p:nvSpPr>
+          <p:cNvPr id="3" name="text-yulvs2toa5d">
+            <a:extLst xmlns:a="http://schemas.openxmlformats.org/drawingml/2006/main">
+              <a:ext uri="{FF2B5EF4-FFF2-40B4-BE49-F238E27FC236}">
+                <a16:creationId xmlns:a16="http://schemas.microsoft.com/office/drawing/2014/main" id="{0B442FBC-AF83-47DA-990C-F535592D8FEC}"/>
               </a:ext>
             </a:extLst>
           </p:cNvPr>
@@ -5336,7 +5326,7 @@
           <p:cNvPr id="5" name="">
             <a:extLst xmlns:a="http://schemas.openxmlformats.org/drawingml/2006/main">
               <a:ext uri="{FF2B5EF4-FFF2-40B4-BE49-F238E27FC236}">
-                <a16:creationId xmlns:a16="http://schemas.microsoft.com/office/drawing/2014/main" id="{FC57B6FB-9E36-4A58-95EA-C36ADCC6DD8B}"/>
+                <a16:creationId xmlns:a16="http://schemas.microsoft.com/office/drawing/2014/main" id="{5861A31F-4920-493C-B63F-D7ACBB56F24C}"/>
               </a:ext>
             </a:extLst>
           </p:cNvPr>
@@ -5366,10 +5356,10 @@
       </p:sp>
       <p:sp>
         <p:nvSpPr>
-          <p:cNvPr id="6" name="text-hee08dy8v4o">
-            <a:extLst xmlns:a="http://schemas.openxmlformats.org/drawingml/2006/main">
-              <a:ext uri="{FF2B5EF4-FFF2-40B4-BE49-F238E27FC236}">
-                <a16:creationId xmlns:a16="http://schemas.microsoft.com/office/drawing/2014/main" id="{11FE8D93-A3DB-449F-950C-57789DB3F1F0}"/>
+          <p:cNvPr id="6" name="text-5o06qknuci7">
+            <a:extLst xmlns:a="http://schemas.openxmlformats.org/drawingml/2006/main">
+              <a:ext uri="{FF2B5EF4-FFF2-40B4-BE49-F238E27FC236}">
+                <a16:creationId xmlns:a16="http://schemas.microsoft.com/office/drawing/2014/main" id="{2CFF1D5F-41E6-454E-9AEB-B2CFA6386AB2}"/>
               </a:ext>
             </a:extLst>
           </p:cNvPr>
@@ -5424,10 +5414,10 @@
       </p:sp>
       <p:sp>
         <p:nvSpPr>
-          <p:cNvPr id="7" name="text-s31m5imehhh">
-            <a:extLst xmlns:a="http://schemas.openxmlformats.org/drawingml/2006/main">
-              <a:ext uri="{FF2B5EF4-FFF2-40B4-BE49-F238E27FC236}">
-                <a16:creationId xmlns:a16="http://schemas.microsoft.com/office/drawing/2014/main" id="{841A500D-6AE5-4D49-992B-D0A4A1DC52A6}"/>
+          <p:cNvPr id="7" name="text-22icvk75376">
+            <a:extLst xmlns:a="http://schemas.openxmlformats.org/drawingml/2006/main">
+              <a:ext uri="{FF2B5EF4-FFF2-40B4-BE49-F238E27FC236}">
+                <a16:creationId xmlns:a16="http://schemas.microsoft.com/office/drawing/2014/main" id="{74EDB2EE-1201-49AD-A6EE-9E192940BD66}"/>
               </a:ext>
             </a:extLst>
           </p:cNvPr>
@@ -5482,10 +5472,10 @@
       </p:sp>
       <p:sp>
         <p:nvSpPr>
-          <p:cNvPr id="8" name="text-widf8l1bj9h">
-            <a:extLst xmlns:a="http://schemas.openxmlformats.org/drawingml/2006/main">
-              <a:ext uri="{FF2B5EF4-FFF2-40B4-BE49-F238E27FC236}">
-                <a16:creationId xmlns:a16="http://schemas.microsoft.com/office/drawing/2014/main" id="{BD2D3A69-A611-4C13-BC36-188BA689EB59}"/>
+          <p:cNvPr id="8" name="text-j658531yqaf">
+            <a:extLst xmlns:a="http://schemas.openxmlformats.org/drawingml/2006/main">
+              <a:ext uri="{FF2B5EF4-FFF2-40B4-BE49-F238E27FC236}">
+                <a16:creationId xmlns:a16="http://schemas.microsoft.com/office/drawing/2014/main" id="{6E8CDE2A-7726-4E03-9907-6EAD5EB99DB7}"/>
               </a:ext>
             </a:extLst>
           </p:cNvPr>
@@ -5565,7 +5555,7 @@
           <p:cNvPr id="10" name="">
             <a:extLst xmlns:a="http://schemas.openxmlformats.org/drawingml/2006/main">
               <a:ext uri="{FF2B5EF4-FFF2-40B4-BE49-F238E27FC236}">
-                <a16:creationId xmlns:a16="http://schemas.microsoft.com/office/drawing/2014/main" id="{2F434628-FF29-4C94-B4C4-67BD4190AD76}"/>
+                <a16:creationId xmlns:a16="http://schemas.microsoft.com/office/drawing/2014/main" id="{04CDE0C0-8D7D-4E5E-B113-8B78D7A248CF}"/>
               </a:ext>
             </a:extLst>
           </p:cNvPr>
@@ -5595,10 +5585,10 @@
       </p:sp>
       <p:sp>
         <p:nvSpPr>
-          <p:cNvPr id="11" name="text-noexwmk7be">
-            <a:extLst xmlns:a="http://schemas.openxmlformats.org/drawingml/2006/main">
-              <a:ext uri="{FF2B5EF4-FFF2-40B4-BE49-F238E27FC236}">
-                <a16:creationId xmlns:a16="http://schemas.microsoft.com/office/drawing/2014/main" id="{34F1E619-6886-4AC2-85BD-CF43D125D8DE}"/>
+          <p:cNvPr id="11" name="text-7gnm8qmtnzx">
+            <a:extLst xmlns:a="http://schemas.openxmlformats.org/drawingml/2006/main">
+              <a:ext uri="{FF2B5EF4-FFF2-40B4-BE49-F238E27FC236}">
+                <a16:creationId xmlns:a16="http://schemas.microsoft.com/office/drawing/2014/main" id="{5E7FD104-4436-4704-A66C-0488A70A9C06}"/>
               </a:ext>
             </a:extLst>
           </p:cNvPr>
@@ -5653,10 +5643,10 @@
       </p:sp>
       <p:sp>
         <p:nvSpPr>
-          <p:cNvPr id="12" name="text-t9uid2wb3bc">
-            <a:extLst xmlns:a="http://schemas.openxmlformats.org/drawingml/2006/main">
-              <a:ext uri="{FF2B5EF4-FFF2-40B4-BE49-F238E27FC236}">
-                <a16:creationId xmlns:a16="http://schemas.microsoft.com/office/drawing/2014/main" id="{9EBCB2D8-6D0E-4412-A09C-31E223C71DC7}"/>
+          <p:cNvPr id="12" name="text-s90fvyccc7">
+            <a:extLst xmlns:a="http://schemas.openxmlformats.org/drawingml/2006/main">
+              <a:ext uri="{FF2B5EF4-FFF2-40B4-BE49-F238E27FC236}">
+                <a16:creationId xmlns:a16="http://schemas.microsoft.com/office/drawing/2014/main" id="{BECFED0D-D82F-41C0-974C-51F8F17CAD54}"/>
               </a:ext>
             </a:extLst>
           </p:cNvPr>
@@ -5711,10 +5701,10 @@
       </p:sp>
       <p:sp>
         <p:nvSpPr>
-          <p:cNvPr id="13" name="text-2uvh242hsfc">
-            <a:extLst xmlns:a="http://schemas.openxmlformats.org/drawingml/2006/main">
-              <a:ext uri="{FF2B5EF4-FFF2-40B4-BE49-F238E27FC236}">
-                <a16:creationId xmlns:a16="http://schemas.microsoft.com/office/drawing/2014/main" id="{FBCF0376-116F-42AD-871B-DB0097FAA9BD}"/>
+          <p:cNvPr id="13" name="text-a8cxkz8czbe">
+            <a:extLst xmlns:a="http://schemas.openxmlformats.org/drawingml/2006/main">
+              <a:ext uri="{FF2B5EF4-FFF2-40B4-BE49-F238E27FC236}">
+                <a16:creationId xmlns:a16="http://schemas.microsoft.com/office/drawing/2014/main" id="{4E912214-BFFA-4BC0-8813-BA7F555DE591}"/>
               </a:ext>
             </a:extLst>
           </p:cNvPr>
@@ -5794,7 +5784,7 @@
           <p:cNvPr id="15" name="">
             <a:extLst xmlns:a="http://schemas.openxmlformats.org/drawingml/2006/main">
               <a:ext uri="{FF2B5EF4-FFF2-40B4-BE49-F238E27FC236}">
-                <a16:creationId xmlns:a16="http://schemas.microsoft.com/office/drawing/2014/main" id="{995BB15D-2292-49A7-BF52-3AF0F3258FF8}"/>
+                <a16:creationId xmlns:a16="http://schemas.microsoft.com/office/drawing/2014/main" id="{E222D94A-3147-44CA-9364-ABCDEE1109B8}"/>
               </a:ext>
             </a:extLst>
           </p:cNvPr>
@@ -5824,10 +5814,10 @@
       </p:sp>
       <p:sp>
         <p:nvSpPr>
-          <p:cNvPr id="16" name="text-1jx73s5ui53">
-            <a:extLst xmlns:a="http://schemas.openxmlformats.org/drawingml/2006/main">
-              <a:ext uri="{FF2B5EF4-FFF2-40B4-BE49-F238E27FC236}">
-                <a16:creationId xmlns:a16="http://schemas.microsoft.com/office/drawing/2014/main" id="{57EA9A2D-1D26-43C4-89F8-AEDDCD02F2C4}"/>
+          <p:cNvPr id="16" name="text-1ckz4ege3l3">
+            <a:extLst xmlns:a="http://schemas.openxmlformats.org/drawingml/2006/main">
+              <a:ext uri="{FF2B5EF4-FFF2-40B4-BE49-F238E27FC236}">
+                <a16:creationId xmlns:a16="http://schemas.microsoft.com/office/drawing/2014/main" id="{4E286399-A1B9-4672-89DC-C39E5CCB6D13}"/>
               </a:ext>
             </a:extLst>
           </p:cNvPr>
@@ -5882,10 +5872,10 @@
       </p:sp>
       <p:sp>
         <p:nvSpPr>
-          <p:cNvPr id="17" name="text-zkere0w1i8d">
-            <a:extLst xmlns:a="http://schemas.openxmlformats.org/drawingml/2006/main">
-              <a:ext uri="{FF2B5EF4-FFF2-40B4-BE49-F238E27FC236}">
-                <a16:creationId xmlns:a16="http://schemas.microsoft.com/office/drawing/2014/main" id="{8FC3DFA8-9FCC-4EC7-B898-0C9969406ACC}"/>
+          <p:cNvPr id="17" name="text-6unjfh833yt">
+            <a:extLst xmlns:a="http://schemas.openxmlformats.org/drawingml/2006/main">
+              <a:ext uri="{FF2B5EF4-FFF2-40B4-BE49-F238E27FC236}">
+                <a16:creationId xmlns:a16="http://schemas.microsoft.com/office/drawing/2014/main" id="{CA5057C5-FD7A-4D1E-A58E-8BBEAB168899}"/>
               </a:ext>
             </a:extLst>
           </p:cNvPr>
@@ -5940,10 +5930,10 @@
       </p:sp>
       <p:sp>
         <p:nvSpPr>
-          <p:cNvPr id="18" name="text-02s11z2wp3yh">
-            <a:extLst xmlns:a="http://schemas.openxmlformats.org/drawingml/2006/main">
-              <a:ext uri="{FF2B5EF4-FFF2-40B4-BE49-F238E27FC236}">
-                <a16:creationId xmlns:a16="http://schemas.microsoft.com/office/drawing/2014/main" id="{0DF8DCC1-5B69-486A-8DB1-BB00A0737B6D}"/>
+          <p:cNvPr id="18" name="text-0z38canu6mvd">
+            <a:extLst xmlns:a="http://schemas.openxmlformats.org/drawingml/2006/main">
+              <a:ext uri="{FF2B5EF4-FFF2-40B4-BE49-F238E27FC236}">
+                <a16:creationId xmlns:a16="http://schemas.microsoft.com/office/drawing/2014/main" id="{9328D1FD-2D38-480D-BC4E-E1E6582D451C}"/>
               </a:ext>
             </a:extLst>
           </p:cNvPr>
@@ -5991,7 +5981,7 @@
                 <a:ea typeface="Arial"/>
                 <a:cs typeface="Arial"/>
               </a:rPr>
-              <a:t>A visible social action, not passive reach</a:t>
+              <a:t>A visible group action at the occasion</a:t>
             </a:r>
           </a:p>
         </p:txBody>
@@ -6023,7 +6013,7 @@
           <p:cNvPr id="20" name="">
             <a:extLst xmlns:a="http://schemas.openxmlformats.org/drawingml/2006/main">
               <a:ext uri="{FF2B5EF4-FFF2-40B4-BE49-F238E27FC236}">
-                <a16:creationId xmlns:a16="http://schemas.microsoft.com/office/drawing/2014/main" id="{27D69023-8B14-4BE3-A875-25460BE4437D}"/>
+                <a16:creationId xmlns:a16="http://schemas.microsoft.com/office/drawing/2014/main" id="{98B52CD5-2C79-4275-8B96-E519346CEC78}"/>
               </a:ext>
             </a:extLst>
           </p:cNvPr>
@@ -6053,10 +6043,10 @@
       </p:sp>
       <p:sp>
         <p:nvSpPr>
-          <p:cNvPr id="21" name="text-0aky9lr2sw4">
-            <a:extLst xmlns:a="http://schemas.openxmlformats.org/drawingml/2006/main">
-              <a:ext uri="{FF2B5EF4-FFF2-40B4-BE49-F238E27FC236}">
-                <a16:creationId xmlns:a16="http://schemas.microsoft.com/office/drawing/2014/main" id="{79C13ADC-EA3F-418F-AC0C-6CC320E5F6DE}"/>
+          <p:cNvPr id="21" name="text-22arg6fv9cvj">
+            <a:extLst xmlns:a="http://schemas.openxmlformats.org/drawingml/2006/main">
+              <a:ext uri="{FF2B5EF4-FFF2-40B4-BE49-F238E27FC236}">
+                <a16:creationId xmlns:a16="http://schemas.microsoft.com/office/drawing/2014/main" id="{40669A0D-1911-4BE5-BA1F-B59FA0143B77}"/>
               </a:ext>
             </a:extLst>
           </p:cNvPr>
@@ -6111,10 +6101,10 @@
       </p:sp>
       <p:sp>
         <p:nvSpPr>
-          <p:cNvPr id="22" name="text-78welq56m5">
-            <a:extLst xmlns:a="http://schemas.openxmlformats.org/drawingml/2006/main">
-              <a:ext uri="{FF2B5EF4-FFF2-40B4-BE49-F238E27FC236}">
-                <a16:creationId xmlns:a16="http://schemas.microsoft.com/office/drawing/2014/main" id="{DCA96086-C7DA-4B8D-A984-A7B4CE870C8A}"/>
+          <p:cNvPr id="22" name="text-qzunq5ryeq">
+            <a:extLst xmlns:a="http://schemas.openxmlformats.org/drawingml/2006/main">
+              <a:ext uri="{FF2B5EF4-FFF2-40B4-BE49-F238E27FC236}">
+                <a16:creationId xmlns:a16="http://schemas.microsoft.com/office/drawing/2014/main" id="{0E9DF9AB-ED49-4C61-B8BD-C8686188469A}"/>
               </a:ext>
             </a:extLst>
           </p:cNvPr>
@@ -6169,10 +6159,10 @@
       </p:sp>
       <p:sp>
         <p:nvSpPr>
-          <p:cNvPr id="23" name="text-knopsmybpnm">
-            <a:extLst xmlns:a="http://schemas.openxmlformats.org/drawingml/2006/main">
-              <a:ext uri="{FF2B5EF4-FFF2-40B4-BE49-F238E27FC236}">
-                <a16:creationId xmlns:a16="http://schemas.microsoft.com/office/drawing/2014/main" id="{67FE69CC-44DA-4F7E-B006-983623A438BF}"/>
+          <p:cNvPr id="23" name="text-ptmrh43c33">
+            <a:extLst xmlns:a="http://schemas.openxmlformats.org/drawingml/2006/main">
+              <a:ext uri="{FF2B5EF4-FFF2-40B4-BE49-F238E27FC236}">
+                <a16:creationId xmlns:a16="http://schemas.microsoft.com/office/drawing/2014/main" id="{09F5ED44-39FB-4D44-B51B-1F68BE6A0554}"/>
               </a:ext>
             </a:extLst>
           </p:cNvPr>
@@ -6230,7 +6220,7 @@
           <p:cNvPr id="24" name="">
             <a:extLst xmlns:a="http://schemas.openxmlformats.org/drawingml/2006/main">
               <a:ext uri="{FF2B5EF4-FFF2-40B4-BE49-F238E27FC236}">
-                <a16:creationId xmlns:a16="http://schemas.microsoft.com/office/drawing/2014/main" id="{40CE7840-E96F-4BA4-9539-398D6DCFCDC4}"/>
+                <a16:creationId xmlns:a16="http://schemas.microsoft.com/office/drawing/2014/main" id="{824BDADB-21A9-436B-9EE0-DFEEE0FDE09F}"/>
               </a:ext>
             </a:extLst>
           </p:cNvPr>
@@ -6260,10 +6250,10 @@
       </p:sp>
       <p:sp>
         <p:nvSpPr>
-          <p:cNvPr id="25" name="text-odb97a6s0co">
-            <a:extLst xmlns:a="http://schemas.openxmlformats.org/drawingml/2006/main">
-              <a:ext uri="{FF2B5EF4-FFF2-40B4-BE49-F238E27FC236}">
-                <a16:creationId xmlns:a16="http://schemas.microsoft.com/office/drawing/2014/main" id="{729F2E18-6007-49BA-8227-1D0D320BEA79}"/>
+          <p:cNvPr id="25" name="text-9chobe12s1u">
+            <a:extLst xmlns:a="http://schemas.openxmlformats.org/drawingml/2006/main">
+              <a:ext uri="{FF2B5EF4-FFF2-40B4-BE49-F238E27FC236}">
+                <a16:creationId xmlns:a16="http://schemas.microsoft.com/office/drawing/2014/main" id="{83574BDA-83D5-461B-B8CE-A998AD107537}"/>
               </a:ext>
             </a:extLst>
           </p:cNvPr>
@@ -6318,10 +6308,10 @@
       </p:sp>
       <p:sp>
         <p:nvSpPr>
-          <p:cNvPr id="26" name="text-4a809a1bftf">
-            <a:extLst xmlns:a="http://schemas.openxmlformats.org/drawingml/2006/main">
-              <a:ext uri="{FF2B5EF4-FFF2-40B4-BE49-F238E27FC236}">
-                <a16:creationId xmlns:a16="http://schemas.microsoft.com/office/drawing/2014/main" id="{C676F80A-522A-4945-A3F2-979AE589385C}"/>
+          <p:cNvPr id="26" name="text-zna5ezpq8cn">
+            <a:extLst xmlns:a="http://schemas.openxmlformats.org/drawingml/2006/main">
+              <a:ext uri="{FF2B5EF4-FFF2-40B4-BE49-F238E27FC236}">
+                <a16:creationId xmlns:a16="http://schemas.microsoft.com/office/drawing/2014/main" id="{3213A8E3-75C4-4CAB-AB6F-9CF66B6CA29D}"/>
               </a:ext>
             </a:extLst>
           </p:cNvPr>
@@ -6376,10 +6366,10 @@
       </p:sp>
       <p:sp>
         <p:nvSpPr>
-          <p:cNvPr id="27" name="text-xkftoltty0n">
-            <a:extLst xmlns:a="http://schemas.openxmlformats.org/drawingml/2006/main">
-              <a:ext uri="{FF2B5EF4-FFF2-40B4-BE49-F238E27FC236}">
-                <a16:creationId xmlns:a16="http://schemas.microsoft.com/office/drawing/2014/main" id="{7FB0ED9D-18DB-410F-89DF-B482B65CE089}"/>
+          <p:cNvPr id="27" name="text-3hvmj4k4p0r">
+            <a:extLst xmlns:a="http://schemas.openxmlformats.org/drawingml/2006/main">
+              <a:ext uri="{FF2B5EF4-FFF2-40B4-BE49-F238E27FC236}">
+                <a16:creationId xmlns:a16="http://schemas.microsoft.com/office/drawing/2014/main" id="{68339137-189F-45FE-A636-1CC73D179128}"/>
               </a:ext>
             </a:extLst>
           </p:cNvPr>
@@ -6437,7 +6427,7 @@
           <p:cNvPr id="28" name="">
             <a:extLst xmlns:a="http://schemas.openxmlformats.org/drawingml/2006/main">
               <a:ext uri="{FF2B5EF4-FFF2-40B4-BE49-F238E27FC236}">
-                <a16:creationId xmlns:a16="http://schemas.microsoft.com/office/drawing/2014/main" id="{A7224E48-F86B-46FE-9AF6-B9E1C7E31C89}"/>
+                <a16:creationId xmlns:a16="http://schemas.microsoft.com/office/drawing/2014/main" id="{0BACBB59-955A-4AE4-88AC-A0967A11B349}"/>
               </a:ext>
             </a:extLst>
           </p:cNvPr>
@@ -6465,10 +6455,10 @@
       </p:sp>
       <p:sp>
         <p:nvSpPr>
-          <p:cNvPr id="29" name="text-6menv0mdbz">
-            <a:extLst xmlns:a="http://schemas.openxmlformats.org/drawingml/2006/main">
-              <a:ext uri="{FF2B5EF4-FFF2-40B4-BE49-F238E27FC236}">
-                <a16:creationId xmlns:a16="http://schemas.microsoft.com/office/drawing/2014/main" id="{73C4E757-CE4A-4677-A8F7-0F82BDF6E6B3}"/>
+          <p:cNvPr id="29" name="text-p4maz537as">
+            <a:extLst xmlns:a="http://schemas.openxmlformats.org/drawingml/2006/main">
+              <a:ext uri="{FF2B5EF4-FFF2-40B4-BE49-F238E27FC236}">
+                <a16:creationId xmlns:a16="http://schemas.microsoft.com/office/drawing/2014/main" id="{A73E4D17-ECA0-40FA-B9D9-AB7BD321243F}"/>
               </a:ext>
             </a:extLst>
           </p:cNvPr>
@@ -6516,7 +6506,7 @@
                 <a:ea typeface="Arial"/>
                 <a:cs typeface="Arial"/>
               </a:rPr>
-              <a:t>Test the bridge. If the second buy does not move, the growth loop has not formed.</a:t>
+              <a:t>The second purchase decides whether the loop is working.</a:t>
             </a:r>
           </a:p>
         </p:txBody>
@@ -6524,7 +6514,7 @@
     </p:spTree>
     <p:extLst>
       <p:ext uri="{BB962C8B-B14F-4D97-AF65-F5344CB8AC3E}">
-        <p14:creationId xmlns:p14="http://schemas.microsoft.com/office/powerpoint/2010/main" val="715472734"/>
+        <p14:creationId xmlns:p14="http://schemas.microsoft.com/office/powerpoint/2010/main" val="1441230711"/>
       </p:ext>
     </p:extLst>
   </p:cSld>
@@ -6552,10 +6542,10 @@
       </p:grpSpPr>
       <p:sp>
         <p:nvSpPr>
-          <p:cNvPr id="21" name="text-qkgwcp0dnz8">
-            <a:extLst xmlns:a="http://schemas.openxmlformats.org/drawingml/2006/main">
-              <a:ext uri="{FF2B5EF4-FFF2-40B4-BE49-F238E27FC236}">
-                <a16:creationId xmlns:a16="http://schemas.microsoft.com/office/drawing/2014/main" id="{24D338DE-63C8-4240-B497-7B16965926C5}"/>
+          <p:cNvPr id="21" name="text-p4a2p0ex66t">
+            <a:extLst xmlns:a="http://schemas.openxmlformats.org/drawingml/2006/main">
+              <a:ext uri="{FF2B5EF4-FFF2-40B4-BE49-F238E27FC236}">
+                <a16:creationId xmlns:a16="http://schemas.microsoft.com/office/drawing/2014/main" id="{7B20C00D-8DCC-4828-BF6A-123278CC2DA2}"/>
               </a:ext>
             </a:extLst>
           </p:cNvPr>
@@ -6610,10 +6600,10 @@
       </p:sp>
       <p:sp>
         <p:nvSpPr>
-          <p:cNvPr id="2" name="text-3vyy36edu0a">
-            <a:extLst xmlns:a="http://schemas.openxmlformats.org/drawingml/2006/main">
-              <a:ext uri="{FF2B5EF4-FFF2-40B4-BE49-F238E27FC236}">
-                <a16:creationId xmlns:a16="http://schemas.microsoft.com/office/drawing/2014/main" id="{D3ADD4F4-D564-4531-8F2D-EB6F17D373F2}"/>
+          <p:cNvPr id="2" name="text-yx6pouv7zqj">
+            <a:extLst xmlns:a="http://schemas.openxmlformats.org/drawingml/2006/main">
+              <a:ext uri="{FF2B5EF4-FFF2-40B4-BE49-F238E27FC236}">
+                <a16:creationId xmlns:a16="http://schemas.microsoft.com/office/drawing/2014/main" id="{EB769AB3-FB39-4D49-BCA1-01F1E305AA52}"/>
               </a:ext>
             </a:extLst>
           </p:cNvPr>
@@ -6661,17 +6651,17 @@
                 <a:ea typeface="Arial"/>
                 <a:cs typeface="Arial"/>
               </a:rPr>
-              <a:t>Run a pilot that can be measured, not admired</a:t>
-            </a:r>
-          </a:p>
-        </p:txBody>
-      </p:sp>
-      <p:sp>
-        <p:nvSpPr>
-          <p:cNvPr id="3" name="text-27x8raci1ms">
-            <a:extLst xmlns:a="http://schemas.openxmlformats.org/drawingml/2006/main">
-              <a:ext uri="{FF2B5EF4-FFF2-40B4-BE49-F238E27FC236}">
-                <a16:creationId xmlns:a16="http://schemas.microsoft.com/office/drawing/2014/main" id="{2FFA84F1-BC3D-4B61-B405-2D223E14FD53}"/>
+              <a:t>Test three outlet treatments</a:t>
+            </a:r>
+          </a:p>
+        </p:txBody>
+      </p:sp>
+      <p:sp>
+        <p:nvSpPr>
+          <p:cNvPr id="3" name="text-lvvwn0mv0z">
+            <a:extLst xmlns:a="http://schemas.openxmlformats.org/drawingml/2006/main">
+              <a:ext uri="{FF2B5EF4-FFF2-40B4-BE49-F238E27FC236}">
+                <a16:creationId xmlns:a16="http://schemas.microsoft.com/office/drawing/2014/main" id="{D8545336-CF78-496A-80CE-62707EB0BDD9}"/>
               </a:ext>
             </a:extLst>
           </p:cNvPr>
@@ -6726,10 +6716,10 @@
       </p:sp>
       <p:sp>
         <p:nvSpPr>
-          <p:cNvPr id="4" name="text-2y1klvdas7h">
-            <a:extLst xmlns:a="http://schemas.openxmlformats.org/drawingml/2006/main">
-              <a:ext uri="{FF2B5EF4-FFF2-40B4-BE49-F238E27FC236}">
-                <a16:creationId xmlns:a16="http://schemas.microsoft.com/office/drawing/2014/main" id="{83B29B75-5058-4A21-8F04-4D95965B0E29}"/>
+          <p:cNvPr id="4" name="text-32gtrkajave">
+            <a:extLst xmlns:a="http://schemas.openxmlformats.org/drawingml/2006/main">
+              <a:ext uri="{FF2B5EF4-FFF2-40B4-BE49-F238E27FC236}">
+                <a16:creationId xmlns:a16="http://schemas.microsoft.com/office/drawing/2014/main" id="{896143F4-EE03-4B73-BA6E-9E53E9F40B0F}"/>
               </a:ext>
             </a:extLst>
           </p:cNvPr>
@@ -6784,10 +6774,10 @@
       </p:sp>
       <p:sp>
         <p:nvSpPr>
-          <p:cNvPr id="5" name="text-fpxqqkf7wr8">
-            <a:extLst xmlns:a="http://schemas.openxmlformats.org/drawingml/2006/main">
-              <a:ext uri="{FF2B5EF4-FFF2-40B4-BE49-F238E27FC236}">
-                <a16:creationId xmlns:a16="http://schemas.microsoft.com/office/drawing/2014/main" id="{15D91390-0384-44AE-A03A-B8781628248F}"/>
+          <p:cNvPr id="5" name="text-0egf8o90mm75">
+            <a:extLst xmlns:a="http://schemas.openxmlformats.org/drawingml/2006/main">
+              <a:ext uri="{FF2B5EF4-FFF2-40B4-BE49-F238E27FC236}">
+                <a16:creationId xmlns:a16="http://schemas.microsoft.com/office/drawing/2014/main" id="{C9C93E19-2D11-4241-968B-64832C82D07C}"/>
               </a:ext>
             </a:extLst>
           </p:cNvPr>
@@ -6842,10 +6832,10 @@
       </p:sp>
       <p:sp>
         <p:nvSpPr>
-          <p:cNvPr id="6" name="text-u0lhvivbe4f">
-            <a:extLst xmlns:a="http://schemas.openxmlformats.org/drawingml/2006/main">
-              <a:ext uri="{FF2B5EF4-FFF2-40B4-BE49-F238E27FC236}">
-                <a16:creationId xmlns:a16="http://schemas.microsoft.com/office/drawing/2014/main" id="{DE67C67C-D584-495B-8EC8-53203EB16430}"/>
+          <p:cNvPr id="6" name="text-iyj1ziekdf">
+            <a:extLst xmlns:a="http://schemas.openxmlformats.org/drawingml/2006/main">
+              <a:ext uri="{FF2B5EF4-FFF2-40B4-BE49-F238E27FC236}">
+                <a16:creationId xmlns:a16="http://schemas.microsoft.com/office/drawing/2014/main" id="{7FE9FE88-0BE5-493A-902B-01B9265347DC}"/>
               </a:ext>
             </a:extLst>
           </p:cNvPr>
@@ -6922,10 +6912,10 @@
       </p:cxnSp>
       <p:sp>
         <p:nvSpPr>
-          <p:cNvPr id="8" name="text-7fd0bk02a5">
-            <a:extLst xmlns:a="http://schemas.openxmlformats.org/drawingml/2006/main">
-              <a:ext uri="{FF2B5EF4-FFF2-40B4-BE49-F238E27FC236}">
-                <a16:creationId xmlns:a16="http://schemas.microsoft.com/office/drawing/2014/main" id="{25F22BD3-80D8-4EEB-967E-9E090E7557CB}"/>
+          <p:cNvPr id="8" name="text-cnudhr69zh6">
+            <a:extLst xmlns:a="http://schemas.openxmlformats.org/drawingml/2006/main">
+              <a:ext uri="{FF2B5EF4-FFF2-40B4-BE49-F238E27FC236}">
+                <a16:creationId xmlns:a16="http://schemas.microsoft.com/office/drawing/2014/main" id="{5F40ACCD-4D70-445D-B693-614A73D18608}"/>
               </a:ext>
             </a:extLst>
           </p:cNvPr>
@@ -6980,10 +6970,10 @@
       </p:sp>
       <p:sp>
         <p:nvSpPr>
-          <p:cNvPr id="9" name="text-a4iace6f8i6">
-            <a:extLst xmlns:a="http://schemas.openxmlformats.org/drawingml/2006/main">
-              <a:ext uri="{FF2B5EF4-FFF2-40B4-BE49-F238E27FC236}">
-                <a16:creationId xmlns:a16="http://schemas.microsoft.com/office/drawing/2014/main" id="{31436091-B1DC-4707-8DA7-C3BA51C88178}"/>
+          <p:cNvPr id="9" name="text-lz7arv2nme">
+            <a:extLst xmlns:a="http://schemas.openxmlformats.org/drawingml/2006/main">
+              <a:ext uri="{FF2B5EF4-FFF2-40B4-BE49-F238E27FC236}">
+                <a16:creationId xmlns:a16="http://schemas.microsoft.com/office/drawing/2014/main" id="{FC013618-BE43-47A3-93D8-D918FED22A14}"/>
               </a:ext>
             </a:extLst>
           </p:cNvPr>
@@ -7038,10 +7028,10 @@
       </p:sp>
       <p:sp>
         <p:nvSpPr>
-          <p:cNvPr id="10" name="text-d64gnzvloub">
-            <a:extLst xmlns:a="http://schemas.openxmlformats.org/drawingml/2006/main">
-              <a:ext uri="{FF2B5EF4-FFF2-40B4-BE49-F238E27FC236}">
-                <a16:creationId xmlns:a16="http://schemas.microsoft.com/office/drawing/2014/main" id="{DFB5AADF-3B7A-4545-B1A1-E2B837073AE1}"/>
+          <p:cNvPr id="10" name="text-7qwxvx0hjlh">
+            <a:extLst xmlns:a="http://schemas.openxmlformats.org/drawingml/2006/main">
+              <a:ext uri="{FF2B5EF4-FFF2-40B4-BE49-F238E27FC236}">
+                <a16:creationId xmlns:a16="http://schemas.microsoft.com/office/drawing/2014/main" id="{43BECAA7-78EF-4866-8621-213F9AD35038}"/>
               </a:ext>
             </a:extLst>
           </p:cNvPr>
@@ -7118,10 +7108,10 @@
       </p:cxnSp>
       <p:sp>
         <p:nvSpPr>
-          <p:cNvPr id="12" name="text-t3pqn9dfs7b">
-            <a:extLst xmlns:a="http://schemas.openxmlformats.org/drawingml/2006/main">
-              <a:ext uri="{FF2B5EF4-FFF2-40B4-BE49-F238E27FC236}">
-                <a16:creationId xmlns:a16="http://schemas.microsoft.com/office/drawing/2014/main" id="{F447F6DD-F3F2-4396-9EC9-A7E7B66EC851}"/>
+          <p:cNvPr id="12" name="text-kmbuq8u35hs">
+            <a:extLst xmlns:a="http://schemas.openxmlformats.org/drawingml/2006/main">
+              <a:ext uri="{FF2B5EF4-FFF2-40B4-BE49-F238E27FC236}">
+                <a16:creationId xmlns:a16="http://schemas.microsoft.com/office/drawing/2014/main" id="{9E9BC6D8-31AE-48B1-8816-847F29C88D14}"/>
               </a:ext>
             </a:extLst>
           </p:cNvPr>
@@ -7176,10 +7166,10 @@
       </p:sp>
       <p:sp>
         <p:nvSpPr>
-          <p:cNvPr id="13" name="text-ksjn65gl71l">
-            <a:extLst xmlns:a="http://schemas.openxmlformats.org/drawingml/2006/main">
-              <a:ext uri="{FF2B5EF4-FFF2-40B4-BE49-F238E27FC236}">
-                <a16:creationId xmlns:a16="http://schemas.microsoft.com/office/drawing/2014/main" id="{9E5360D2-C9B8-4B7D-A052-6CF0C58119DC}"/>
+          <p:cNvPr id="13" name="text-7vtmlfiakcr">
+            <a:extLst xmlns:a="http://schemas.openxmlformats.org/drawingml/2006/main">
+              <a:ext uri="{FF2B5EF4-FFF2-40B4-BE49-F238E27FC236}">
+                <a16:creationId xmlns:a16="http://schemas.microsoft.com/office/drawing/2014/main" id="{53B6777F-D617-4D72-942A-7A957992A02B}"/>
               </a:ext>
             </a:extLst>
           </p:cNvPr>
@@ -7234,10 +7224,10 @@
       </p:sp>
       <p:sp>
         <p:nvSpPr>
-          <p:cNvPr id="14" name="text-48i9dk5t3vd">
-            <a:extLst xmlns:a="http://schemas.openxmlformats.org/drawingml/2006/main">
-              <a:ext uri="{FF2B5EF4-FFF2-40B4-BE49-F238E27FC236}">
-                <a16:creationId xmlns:a16="http://schemas.microsoft.com/office/drawing/2014/main" id="{3BB23C1C-43EC-4D8B-911C-F9A1768FBA9B}"/>
+          <p:cNvPr id="14" name="text-ga4iixqt9y9">
+            <a:extLst xmlns:a="http://schemas.openxmlformats.org/drawingml/2006/main">
+              <a:ext uri="{FF2B5EF4-FFF2-40B4-BE49-F238E27FC236}">
+                <a16:creationId xmlns:a16="http://schemas.microsoft.com/office/drawing/2014/main" id="{2D0705A1-27D8-4C00-B1CB-918EC8F6C05C}"/>
               </a:ext>
             </a:extLst>
           </p:cNvPr>
@@ -7314,10 +7304,10 @@
       </p:cxnSp>
       <p:sp>
         <p:nvSpPr>
-          <p:cNvPr id="16" name="text-cj7ayd3h6i">
-            <a:extLst xmlns:a="http://schemas.openxmlformats.org/drawingml/2006/main">
-              <a:ext uri="{FF2B5EF4-FFF2-40B4-BE49-F238E27FC236}">
-                <a16:creationId xmlns:a16="http://schemas.microsoft.com/office/drawing/2014/main" id="{150B6AF0-5D90-47BF-876A-94AD05DA3BDA}"/>
+          <p:cNvPr id="16" name="text-eujypfvbgif">
+            <a:extLst xmlns:a="http://schemas.openxmlformats.org/drawingml/2006/main">
+              <a:ext uri="{FF2B5EF4-FFF2-40B4-BE49-F238E27FC236}">
+                <a16:creationId xmlns:a16="http://schemas.microsoft.com/office/drawing/2014/main" id="{56B686A1-8211-4C8F-AD71-BEF0CE580035}"/>
               </a:ext>
             </a:extLst>
           </p:cNvPr>
@@ -7372,10 +7362,10 @@
       </p:sp>
       <p:sp>
         <p:nvSpPr>
-          <p:cNvPr id="17" name="text-xj22kkvh4d">
-            <a:extLst xmlns:a="http://schemas.openxmlformats.org/drawingml/2006/main">
-              <a:ext uri="{FF2B5EF4-FFF2-40B4-BE49-F238E27FC236}">
-                <a16:creationId xmlns:a16="http://schemas.microsoft.com/office/drawing/2014/main" id="{C1BCCC5B-51B7-4C72-9CAB-C9C153A5F521}"/>
+          <p:cNvPr id="17" name="text-a6krououqe8">
+            <a:extLst xmlns:a="http://schemas.openxmlformats.org/drawingml/2006/main">
+              <a:ext uri="{FF2B5EF4-FFF2-40B4-BE49-F238E27FC236}">
+                <a16:creationId xmlns:a16="http://schemas.microsoft.com/office/drawing/2014/main" id="{577F7465-1830-48DF-8759-A549D42C42C7}"/>
               </a:ext>
             </a:extLst>
           </p:cNvPr>
@@ -7430,10 +7420,10 @@
       </p:sp>
       <p:sp>
         <p:nvSpPr>
-          <p:cNvPr id="18" name="text-flctbipyixc">
-            <a:extLst xmlns:a="http://schemas.openxmlformats.org/drawingml/2006/main">
-              <a:ext uri="{FF2B5EF4-FFF2-40B4-BE49-F238E27FC236}">
-                <a16:creationId xmlns:a16="http://schemas.microsoft.com/office/drawing/2014/main" id="{CDC6637A-CE64-460C-8B38-D56DE87C7345}"/>
+          <p:cNvPr id="18" name="text-9papuv32sh8">
+            <a:extLst xmlns:a="http://schemas.openxmlformats.org/drawingml/2006/main">
+              <a:ext uri="{FF2B5EF4-FFF2-40B4-BE49-F238E27FC236}">
+                <a16:creationId xmlns:a16="http://schemas.microsoft.com/office/drawing/2014/main" id="{629A5087-7810-4C05-811A-43B7D5CF0C70}"/>
               </a:ext>
             </a:extLst>
           </p:cNvPr>
@@ -7510,10 +7500,10 @@
       </p:cxnSp>
       <p:sp>
         <p:nvSpPr>
-          <p:cNvPr id="20" name="text-1tttc08m4om">
-            <a:extLst xmlns:a="http://schemas.openxmlformats.org/drawingml/2006/main">
-              <a:ext uri="{FF2B5EF4-FFF2-40B4-BE49-F238E27FC236}">
-                <a16:creationId xmlns:a16="http://schemas.microsoft.com/office/drawing/2014/main" id="{DF4B3825-0BA7-4C99-B8CF-FA4E0AEFC413}"/>
+          <p:cNvPr id="20" name="text-0k86dmpasrqa">
+            <a:extLst xmlns:a="http://schemas.openxmlformats.org/drawingml/2006/main">
+              <a:ext uri="{FF2B5EF4-FFF2-40B4-BE49-F238E27FC236}">
+                <a16:creationId xmlns:a16="http://schemas.microsoft.com/office/drawing/2014/main" id="{5EFB4C3E-D057-479D-B728-0141F402414B}"/>
               </a:ext>
             </a:extLst>
           </p:cNvPr>
@@ -7569,7 +7559,7 @@
     </p:spTree>
     <p:extLst>
       <p:ext uri="{BB962C8B-B14F-4D97-AF65-F5344CB8AC3E}">
-        <p14:creationId xmlns:p14="http://schemas.microsoft.com/office/powerpoint/2010/main" val="1801103638"/>
+        <p14:creationId xmlns:p14="http://schemas.microsoft.com/office/powerpoint/2010/main" val="894791360"/>
       </p:ext>
     </p:extLst>
   </p:cSld>
@@ -7597,10 +7587,10 @@
       </p:grpSpPr>
       <p:sp>
         <p:nvSpPr>
-          <p:cNvPr id="24" name="text-1xmmfih4bkb">
-            <a:extLst xmlns:a="http://schemas.openxmlformats.org/drawingml/2006/main">
-              <a:ext uri="{FF2B5EF4-FFF2-40B4-BE49-F238E27FC236}">
-                <a16:creationId xmlns:a16="http://schemas.microsoft.com/office/drawing/2014/main" id="{042F611D-47BE-44DE-B65F-638F2E7B69A5}"/>
+          <p:cNvPr id="24" name="text-89t95upsrwm">
+            <a:extLst xmlns:a="http://schemas.openxmlformats.org/drawingml/2006/main">
+              <a:ext uri="{FF2B5EF4-FFF2-40B4-BE49-F238E27FC236}">
+                <a16:creationId xmlns:a16="http://schemas.microsoft.com/office/drawing/2014/main" id="{CC036180-7C7C-4915-9049-ADC3B51EB1D2}"/>
               </a:ext>
             </a:extLst>
           </p:cNvPr>
@@ -7655,10 +7645,10 @@
       </p:sp>
       <p:sp>
         <p:nvSpPr>
-          <p:cNvPr id="2" name="text-ise5gmn6gj">
-            <a:extLst xmlns:a="http://schemas.openxmlformats.org/drawingml/2006/main">
-              <a:ext uri="{FF2B5EF4-FFF2-40B4-BE49-F238E27FC236}">
-                <a16:creationId xmlns:a16="http://schemas.microsoft.com/office/drawing/2014/main" id="{D7AD2B58-2F65-4C5A-B53A-BCD5842EA38F}"/>
+          <p:cNvPr id="2" name="text-93jnvjaenp">
+            <a:extLst xmlns:a="http://schemas.openxmlformats.org/drawingml/2006/main">
+              <a:ext uri="{FF2B5EF4-FFF2-40B4-BE49-F238E27FC236}">
+                <a16:creationId xmlns:a16="http://schemas.microsoft.com/office/drawing/2014/main" id="{FC09D400-283C-4D65-8E75-5356F6E997FF}"/>
               </a:ext>
             </a:extLst>
           </p:cNvPr>
@@ -7713,10 +7703,10 @@
       </p:sp>
       <p:sp>
         <p:nvSpPr>
-          <p:cNvPr id="3" name="text-qoi7ua0llom">
-            <a:extLst xmlns:a="http://schemas.openxmlformats.org/drawingml/2006/main">
-              <a:ext uri="{FF2B5EF4-FFF2-40B4-BE49-F238E27FC236}">
-                <a16:creationId xmlns:a16="http://schemas.microsoft.com/office/drawing/2014/main" id="{08371C3C-EE3F-4E23-A6BE-E2257F4CA121}"/>
+          <p:cNvPr id="3" name="text-fn9yknxt2jn">
+            <a:extLst xmlns:a="http://schemas.openxmlformats.org/drawingml/2006/main">
+              <a:ext uri="{FF2B5EF4-FFF2-40B4-BE49-F238E27FC236}">
+                <a16:creationId xmlns:a16="http://schemas.microsoft.com/office/drawing/2014/main" id="{145EB7B4-FEB2-498A-92C1-7606A493E327}"/>
               </a:ext>
             </a:extLst>
           </p:cNvPr>
@@ -7774,7 +7764,7 @@
           <p:cNvPr id="4" name="">
             <a:extLst xmlns:a="http://schemas.openxmlformats.org/drawingml/2006/main">
               <a:ext uri="{FF2B5EF4-FFF2-40B4-BE49-F238E27FC236}">
-                <a16:creationId xmlns:a16="http://schemas.microsoft.com/office/drawing/2014/main" id="{B6E8B376-4A2E-4A99-8947-60371F960CE1}"/>
+                <a16:creationId xmlns:a16="http://schemas.microsoft.com/office/drawing/2014/main" id="{48979EAB-389B-4544-B85D-8C26B3C8432C}"/>
               </a:ext>
             </a:extLst>
           </p:cNvPr>
@@ -7802,10 +7792,10 @@
       </p:sp>
       <p:sp>
         <p:nvSpPr>
-          <p:cNvPr id="5" name="text-b6w07heyx3">
-            <a:extLst xmlns:a="http://schemas.openxmlformats.org/drawingml/2006/main">
-              <a:ext uri="{FF2B5EF4-FFF2-40B4-BE49-F238E27FC236}">
-                <a16:creationId xmlns:a16="http://schemas.microsoft.com/office/drawing/2014/main" id="{0C34F00B-DBEE-4A9D-90A5-5953A5427680}"/>
+          <p:cNvPr id="5" name="text-wj90emyzqfs">
+            <a:extLst xmlns:a="http://schemas.openxmlformats.org/drawingml/2006/main">
+              <a:ext uri="{FF2B5EF4-FFF2-40B4-BE49-F238E27FC236}">
+                <a16:creationId xmlns:a16="http://schemas.microsoft.com/office/drawing/2014/main" id="{E5354D5E-75B5-41D5-B732-DB25D7293F25}"/>
               </a:ext>
             </a:extLst>
           </p:cNvPr>
@@ -7860,10 +7850,10 @@
       </p:sp>
       <p:sp>
         <p:nvSpPr>
-          <p:cNvPr id="6" name="text-11o9nsoy37m">
-            <a:extLst xmlns:a="http://schemas.openxmlformats.org/drawingml/2006/main">
-              <a:ext uri="{FF2B5EF4-FFF2-40B4-BE49-F238E27FC236}">
-                <a16:creationId xmlns:a16="http://schemas.microsoft.com/office/drawing/2014/main" id="{66A6ED81-806B-438F-A95A-C0AEAB6E3757}"/>
+          <p:cNvPr id="6" name="text-pt78w0x5js">
+            <a:extLst xmlns:a="http://schemas.openxmlformats.org/drawingml/2006/main">
+              <a:ext uri="{FF2B5EF4-FFF2-40B4-BE49-F238E27FC236}">
+                <a16:creationId xmlns:a16="http://schemas.microsoft.com/office/drawing/2014/main" id="{E4C6C3A7-100F-4388-8F62-BD433FD7132A}"/>
               </a:ext>
             </a:extLst>
           </p:cNvPr>
@@ -7918,10 +7908,10 @@
       </p:sp>
       <p:sp>
         <p:nvSpPr>
-          <p:cNvPr id="7" name="text-16otnfmggxf">
-            <a:extLst xmlns:a="http://schemas.openxmlformats.org/drawingml/2006/main">
-              <a:ext uri="{FF2B5EF4-FFF2-40B4-BE49-F238E27FC236}">
-                <a16:creationId xmlns:a16="http://schemas.microsoft.com/office/drawing/2014/main" id="{AB829270-7B50-4B20-B934-8E40EC79707A}"/>
+          <p:cNvPr id="7" name="text-gnttm6w48jm">
+            <a:extLst xmlns:a="http://schemas.openxmlformats.org/drawingml/2006/main">
+              <a:ext uri="{FF2B5EF4-FFF2-40B4-BE49-F238E27FC236}">
+                <a16:creationId xmlns:a16="http://schemas.microsoft.com/office/drawing/2014/main" id="{7BEC57D8-D118-4ED8-B23A-808C81BDF58D}"/>
               </a:ext>
             </a:extLst>
           </p:cNvPr>
@@ -7976,10 +7966,10 @@
       </p:sp>
       <p:sp>
         <p:nvSpPr>
-          <p:cNvPr id="8" name="text-yp2e6vjwvd9">
-            <a:extLst xmlns:a="http://schemas.openxmlformats.org/drawingml/2006/main">
-              <a:ext uri="{FF2B5EF4-FFF2-40B4-BE49-F238E27FC236}">
-                <a16:creationId xmlns:a16="http://schemas.microsoft.com/office/drawing/2014/main" id="{3DA74DBA-F1FA-47C3-AECF-D1CA04EDEF8A}"/>
+          <p:cNvPr id="8" name="text-50387vwnehs">
+            <a:extLst xmlns:a="http://schemas.openxmlformats.org/drawingml/2006/main">
+              <a:ext uri="{FF2B5EF4-FFF2-40B4-BE49-F238E27FC236}">
+                <a16:creationId xmlns:a16="http://schemas.microsoft.com/office/drawing/2014/main" id="{90F7B419-3693-476D-99FA-BC4781B33917}"/>
               </a:ext>
             </a:extLst>
           </p:cNvPr>
@@ -8034,10 +8024,10 @@
       </p:sp>
       <p:sp>
         <p:nvSpPr>
-          <p:cNvPr id="9" name="text-ls3jtfhz6y">
-            <a:extLst xmlns:a="http://schemas.openxmlformats.org/drawingml/2006/main">
-              <a:ext uri="{FF2B5EF4-FFF2-40B4-BE49-F238E27FC236}">
-                <a16:creationId xmlns:a16="http://schemas.microsoft.com/office/drawing/2014/main" id="{618C8775-1960-4344-ABE2-B1B8FB8EE325}"/>
+          <p:cNvPr id="9" name="text-a8c6u0lgax">
+            <a:extLst xmlns:a="http://schemas.openxmlformats.org/drawingml/2006/main">
+              <a:ext uri="{FF2B5EF4-FFF2-40B4-BE49-F238E27FC236}">
+                <a16:creationId xmlns:a16="http://schemas.microsoft.com/office/drawing/2014/main" id="{2F7BA751-5B7A-4933-A883-1E7BACAA5A8B}"/>
               </a:ext>
             </a:extLst>
           </p:cNvPr>
@@ -8114,10 +8104,10 @@
       </p:cxnSp>
       <p:sp>
         <p:nvSpPr>
-          <p:cNvPr id="11" name="text-qphezpm9sta">
-            <a:extLst xmlns:a="http://schemas.openxmlformats.org/drawingml/2006/main">
-              <a:ext uri="{FF2B5EF4-FFF2-40B4-BE49-F238E27FC236}">
-                <a16:creationId xmlns:a16="http://schemas.microsoft.com/office/drawing/2014/main" id="{85E0D1BE-7C8D-4FAF-98D2-3986BCED5A77}"/>
+          <p:cNvPr id="11" name="text-8r50ij5y44n">
+            <a:extLst xmlns:a="http://schemas.openxmlformats.org/drawingml/2006/main">
+              <a:ext uri="{FF2B5EF4-FFF2-40B4-BE49-F238E27FC236}">
+                <a16:creationId xmlns:a16="http://schemas.microsoft.com/office/drawing/2014/main" id="{2BB2751C-3ACB-43E1-82EC-DB80C6670324}"/>
               </a:ext>
             </a:extLst>
           </p:cNvPr>
@@ -8172,10 +8162,10 @@
       </p:sp>
       <p:sp>
         <p:nvSpPr>
-          <p:cNvPr id="12" name="text-fcd4nxx3y1v">
-            <a:extLst xmlns:a="http://schemas.openxmlformats.org/drawingml/2006/main">
-              <a:ext uri="{FF2B5EF4-FFF2-40B4-BE49-F238E27FC236}">
-                <a16:creationId xmlns:a16="http://schemas.microsoft.com/office/drawing/2014/main" id="{BAFF0C77-55E4-4865-9429-06CC52B7183C}"/>
+          <p:cNvPr id="12" name="text-i0dh51kas3g">
+            <a:extLst xmlns:a="http://schemas.openxmlformats.org/drawingml/2006/main">
+              <a:ext uri="{FF2B5EF4-FFF2-40B4-BE49-F238E27FC236}">
+                <a16:creationId xmlns:a16="http://schemas.microsoft.com/office/drawing/2014/main" id="{9D843777-B4FD-4957-AD9D-189A3D3EE85B}"/>
               </a:ext>
             </a:extLst>
           </p:cNvPr>
@@ -8252,10 +8242,10 @@
       </p:cxnSp>
       <p:sp>
         <p:nvSpPr>
-          <p:cNvPr id="14" name="text-624kn0hjp77">
-            <a:extLst xmlns:a="http://schemas.openxmlformats.org/drawingml/2006/main">
-              <a:ext uri="{FF2B5EF4-FFF2-40B4-BE49-F238E27FC236}">
-                <a16:creationId xmlns:a16="http://schemas.microsoft.com/office/drawing/2014/main" id="{F5874BF8-E5B6-48DF-99EF-31E825270ECA}"/>
+          <p:cNvPr id="14" name="text-3znviubmcw1">
+            <a:extLst xmlns:a="http://schemas.openxmlformats.org/drawingml/2006/main">
+              <a:ext uri="{FF2B5EF4-FFF2-40B4-BE49-F238E27FC236}">
+                <a16:creationId xmlns:a16="http://schemas.microsoft.com/office/drawing/2014/main" id="{A6192C65-A2DE-4B97-9CE7-52096570B3F2}"/>
               </a:ext>
             </a:extLst>
           </p:cNvPr>
@@ -8310,10 +8300,10 @@
       </p:sp>
       <p:sp>
         <p:nvSpPr>
-          <p:cNvPr id="15" name="text-fqpq0k3dprm">
-            <a:extLst xmlns:a="http://schemas.openxmlformats.org/drawingml/2006/main">
-              <a:ext uri="{FF2B5EF4-FFF2-40B4-BE49-F238E27FC236}">
-                <a16:creationId xmlns:a16="http://schemas.microsoft.com/office/drawing/2014/main" id="{D4DA95BA-15D3-401B-BE9E-FE954E42F678}"/>
+          <p:cNvPr id="15" name="text-c0i7k9vriml">
+            <a:extLst xmlns:a="http://schemas.openxmlformats.org/drawingml/2006/main">
+              <a:ext uri="{FF2B5EF4-FFF2-40B4-BE49-F238E27FC236}">
+                <a16:creationId xmlns:a16="http://schemas.microsoft.com/office/drawing/2014/main" id="{A4BFB6EF-CE5A-45CD-B843-CC72FDCC4DA2}"/>
               </a:ext>
             </a:extLst>
           </p:cNvPr>
@@ -8390,10 +8380,10 @@
       </p:cxnSp>
       <p:sp>
         <p:nvSpPr>
-          <p:cNvPr id="17" name="text-euas1astodb">
-            <a:extLst xmlns:a="http://schemas.openxmlformats.org/drawingml/2006/main">
-              <a:ext uri="{FF2B5EF4-FFF2-40B4-BE49-F238E27FC236}">
-                <a16:creationId xmlns:a16="http://schemas.microsoft.com/office/drawing/2014/main" id="{4D73AE08-6858-4CAE-AA67-605CCF76984A}"/>
+          <p:cNvPr id="17" name="text-g3gz2r1k1bt">
+            <a:extLst xmlns:a="http://schemas.openxmlformats.org/drawingml/2006/main">
+              <a:ext uri="{FF2B5EF4-FFF2-40B4-BE49-F238E27FC236}">
+                <a16:creationId xmlns:a16="http://schemas.microsoft.com/office/drawing/2014/main" id="{F50E1C4C-862A-404C-BA37-84EFAFB1D450}"/>
               </a:ext>
             </a:extLst>
           </p:cNvPr>
@@ -8448,10 +8438,10 @@
       </p:sp>
       <p:sp>
         <p:nvSpPr>
-          <p:cNvPr id="18" name="text-yoahnfxyezk">
-            <a:extLst xmlns:a="http://schemas.openxmlformats.org/drawingml/2006/main">
-              <a:ext uri="{FF2B5EF4-FFF2-40B4-BE49-F238E27FC236}">
-                <a16:creationId xmlns:a16="http://schemas.microsoft.com/office/drawing/2014/main" id="{5E03E319-279F-4342-B229-DCB2A5BEC418}"/>
+          <p:cNvPr id="18" name="text-k1ctcx3dq88">
+            <a:extLst xmlns:a="http://schemas.openxmlformats.org/drawingml/2006/main">
+              <a:ext uri="{FF2B5EF4-FFF2-40B4-BE49-F238E27FC236}">
+                <a16:creationId xmlns:a16="http://schemas.microsoft.com/office/drawing/2014/main" id="{A29C86FA-538C-47AF-974F-501D67710F45}"/>
               </a:ext>
             </a:extLst>
           </p:cNvPr>
@@ -8528,10 +8518,10 @@
       </p:cxnSp>
       <p:sp>
         <p:nvSpPr>
-          <p:cNvPr id="20" name="text-wn32y5vtd0l">
-            <a:extLst xmlns:a="http://schemas.openxmlformats.org/drawingml/2006/main">
-              <a:ext uri="{FF2B5EF4-FFF2-40B4-BE49-F238E27FC236}">
-                <a16:creationId xmlns:a16="http://schemas.microsoft.com/office/drawing/2014/main" id="{254C1439-7DA8-435F-A66F-F1C889A3C794}"/>
+          <p:cNvPr id="20" name="text-xbpguy5iood">
+            <a:extLst xmlns:a="http://schemas.openxmlformats.org/drawingml/2006/main">
+              <a:ext uri="{FF2B5EF4-FFF2-40B4-BE49-F238E27FC236}">
+                <a16:creationId xmlns:a16="http://schemas.microsoft.com/office/drawing/2014/main" id="{230037BC-CAD6-4F82-84AC-CAB33DB5675A}"/>
               </a:ext>
             </a:extLst>
           </p:cNvPr>
@@ -8586,10 +8576,10 @@
       </p:sp>
       <p:sp>
         <p:nvSpPr>
-          <p:cNvPr id="21" name="text-nvprm3z3nq">
-            <a:extLst xmlns:a="http://schemas.openxmlformats.org/drawingml/2006/main">
-              <a:ext uri="{FF2B5EF4-FFF2-40B4-BE49-F238E27FC236}">
-                <a16:creationId xmlns:a16="http://schemas.microsoft.com/office/drawing/2014/main" id="{621DA943-67AF-423B-BCA6-65444BEF5AFC}"/>
+          <p:cNvPr id="21" name="text-3po2a4nmtri">
+            <a:extLst xmlns:a="http://schemas.openxmlformats.org/drawingml/2006/main">
+              <a:ext uri="{FF2B5EF4-FFF2-40B4-BE49-F238E27FC236}">
+                <a16:creationId xmlns:a16="http://schemas.microsoft.com/office/drawing/2014/main" id="{61ABADEF-AF76-42ED-B9A9-39E55EEFE106}"/>
               </a:ext>
             </a:extLst>
           </p:cNvPr>
@@ -8666,10 +8656,10 @@
       </p:cxnSp>
       <p:sp>
         <p:nvSpPr>
-          <p:cNvPr id="23" name="text-xk8q9c5ho9o">
-            <a:extLst xmlns:a="http://schemas.openxmlformats.org/drawingml/2006/main">
-              <a:ext uri="{FF2B5EF4-FFF2-40B4-BE49-F238E27FC236}">
-                <a16:creationId xmlns:a16="http://schemas.microsoft.com/office/drawing/2014/main" id="{D39CEB8D-07C8-41F5-A9EF-09BF78521083}"/>
+          <p:cNvPr id="23" name="text-lcfai5mt2h">
+            <a:extLst xmlns:a="http://schemas.openxmlformats.org/drawingml/2006/main">
+              <a:ext uri="{FF2B5EF4-FFF2-40B4-BE49-F238E27FC236}">
+                <a16:creationId xmlns:a16="http://schemas.microsoft.com/office/drawing/2014/main" id="{DE5DEE91-F0DB-4FC8-A233-29BB9E352893}"/>
               </a:ext>
             </a:extLst>
           </p:cNvPr>
@@ -8717,7 +8707,7 @@
                 <a:ea typeface="Arial"/>
                 <a:cs typeface="Arial"/>
               </a:rPr>
-              <a:t>A scan-rate spike without transaction lift is not a win.</a:t>
+              <a:t>A scan-rate spike matters only if transactions also move.</a:t>
             </a:r>
           </a:p>
         </p:txBody>
@@ -8725,7 +8715,7 @@
     </p:spTree>
     <p:extLst>
       <p:ext uri="{BB962C8B-B14F-4D97-AF65-F5344CB8AC3E}">
-        <p14:creationId xmlns:p14="http://schemas.microsoft.com/office/powerpoint/2010/main" val="563709984"/>
+        <p14:creationId xmlns:p14="http://schemas.microsoft.com/office/powerpoint/2010/main" val="102013771"/>
       </p:ext>
     </p:extLst>
   </p:cSld>
@@ -8753,10 +8743,10 @@
       </p:grpSpPr>
       <p:sp>
         <p:nvSpPr>
-          <p:cNvPr id="14" name="text-w1rfduzq1k">
-            <a:extLst xmlns:a="http://schemas.openxmlformats.org/drawingml/2006/main">
-              <a:ext uri="{FF2B5EF4-FFF2-40B4-BE49-F238E27FC236}">
-                <a16:creationId xmlns:a16="http://schemas.microsoft.com/office/drawing/2014/main" id="{480103B0-5503-46C8-8C4A-3C6A932E9181}"/>
+          <p:cNvPr id="14" name="text-07y5xyufsy3">
+            <a:extLst xmlns:a="http://schemas.openxmlformats.org/drawingml/2006/main">
+              <a:ext uri="{FF2B5EF4-FFF2-40B4-BE49-F238E27FC236}">
+                <a16:creationId xmlns:a16="http://schemas.microsoft.com/office/drawing/2014/main" id="{C13E2B3E-347B-40B7-8007-33E6E043EFC3}"/>
               </a:ext>
             </a:extLst>
           </p:cNvPr>
@@ -8811,10 +8801,10 @@
       </p:sp>
       <p:sp>
         <p:nvSpPr>
-          <p:cNvPr id="2" name="text-miqsq527hb">
-            <a:extLst xmlns:a="http://schemas.openxmlformats.org/drawingml/2006/main">
-              <a:ext uri="{FF2B5EF4-FFF2-40B4-BE49-F238E27FC236}">
-                <a16:creationId xmlns:a16="http://schemas.microsoft.com/office/drawing/2014/main" id="{10844CAE-E9CA-4FE4-AC08-4A6219BD0DFC}"/>
+          <p:cNvPr id="2" name="text-8pn7i6e053v">
+            <a:extLst xmlns:a="http://schemas.openxmlformats.org/drawingml/2006/main">
+              <a:ext uri="{FF2B5EF4-FFF2-40B4-BE49-F238E27FC236}">
+                <a16:creationId xmlns:a16="http://schemas.microsoft.com/office/drawing/2014/main" id="{CE98AF71-83C2-4113-B7F0-802851CC3C6A}"/>
               </a:ext>
             </a:extLst>
           </p:cNvPr>
@@ -8869,10 +8859,10 @@
       </p:sp>
       <p:sp>
         <p:nvSpPr>
-          <p:cNvPr id="3" name="text-zursb05cev">
-            <a:extLst xmlns:a="http://schemas.openxmlformats.org/drawingml/2006/main">
-              <a:ext uri="{FF2B5EF4-FFF2-40B4-BE49-F238E27FC236}">
-                <a16:creationId xmlns:a16="http://schemas.microsoft.com/office/drawing/2014/main" id="{F41B10BA-24CF-49DC-AD64-BC044DC6E3C6}"/>
+          <p:cNvPr id="3" name="text-u6kpglrhk3">
+            <a:extLst xmlns:a="http://schemas.openxmlformats.org/drawingml/2006/main">
+              <a:ext uri="{FF2B5EF4-FFF2-40B4-BE49-F238E27FC236}">
+                <a16:creationId xmlns:a16="http://schemas.microsoft.com/office/drawing/2014/main" id="{ACB2760B-B1B3-4E70-BE08-375908654D46}"/>
               </a:ext>
             </a:extLst>
           </p:cNvPr>
@@ -8927,10 +8917,10 @@
       </p:sp>
       <p:sp>
         <p:nvSpPr>
-          <p:cNvPr id="4" name="text-f9teq02tbf">
-            <a:extLst xmlns:a="http://schemas.openxmlformats.org/drawingml/2006/main">
-              <a:ext uri="{FF2B5EF4-FFF2-40B4-BE49-F238E27FC236}">
-                <a16:creationId xmlns:a16="http://schemas.microsoft.com/office/drawing/2014/main" id="{A6AB1B6D-3A0E-4402-B1F4-F699AC035045}"/>
+          <p:cNvPr id="4" name="text-kakddv1x677">
+            <a:extLst xmlns:a="http://schemas.openxmlformats.org/drawingml/2006/main">
+              <a:ext uri="{FF2B5EF4-FFF2-40B4-BE49-F238E27FC236}">
+                <a16:creationId xmlns:a16="http://schemas.microsoft.com/office/drawing/2014/main" id="{AA6AA7B6-B7AE-40CB-991B-3EB61C0246B3}"/>
               </a:ext>
             </a:extLst>
           </p:cNvPr>
@@ -8985,10 +8975,10 @@
       </p:sp>
       <p:sp>
         <p:nvSpPr>
-          <p:cNvPr id="5" name="text-lm26q0oglu">
-            <a:extLst xmlns:a="http://schemas.openxmlformats.org/drawingml/2006/main">
-              <a:ext uri="{FF2B5EF4-FFF2-40B4-BE49-F238E27FC236}">
-                <a16:creationId xmlns:a16="http://schemas.microsoft.com/office/drawing/2014/main" id="{351AB475-9551-4A08-8715-2CEE1830B42E}"/>
+          <p:cNvPr id="5" name="text-qjje4t4m6">
+            <a:extLst xmlns:a="http://schemas.openxmlformats.org/drawingml/2006/main">
+              <a:ext uri="{FF2B5EF4-FFF2-40B4-BE49-F238E27FC236}">
+                <a16:creationId xmlns:a16="http://schemas.microsoft.com/office/drawing/2014/main" id="{16BD3ED4-F571-4295-ADF1-0E9BACBE8C34}"/>
               </a:ext>
             </a:extLst>
           </p:cNvPr>
@@ -9043,10 +9033,10 @@
       </p:sp>
       <p:sp>
         <p:nvSpPr>
-          <p:cNvPr id="6" name="text-vx18lews839">
-            <a:extLst xmlns:a="http://schemas.openxmlformats.org/drawingml/2006/main">
-              <a:ext uri="{FF2B5EF4-FFF2-40B4-BE49-F238E27FC236}">
-                <a16:creationId xmlns:a16="http://schemas.microsoft.com/office/drawing/2014/main" id="{6167D223-0A8C-49E5-9986-1B70F57661BD}"/>
+          <p:cNvPr id="6" name="text-sypuy31dthm">
+            <a:extLst xmlns:a="http://schemas.openxmlformats.org/drawingml/2006/main">
+              <a:ext uri="{FF2B5EF4-FFF2-40B4-BE49-F238E27FC236}">
+                <a16:creationId xmlns:a16="http://schemas.microsoft.com/office/drawing/2014/main" id="{7EB07B85-AD9F-437E-96B2-B23EDCFC0729}"/>
               </a:ext>
             </a:extLst>
           </p:cNvPr>
@@ -9101,10 +9091,10 @@
       </p:sp>
       <p:sp>
         <p:nvSpPr>
-          <p:cNvPr id="7" name="text-gb2h53ycdv7">
-            <a:extLst xmlns:a="http://schemas.openxmlformats.org/drawingml/2006/main">
-              <a:ext uri="{FF2B5EF4-FFF2-40B4-BE49-F238E27FC236}">
-                <a16:creationId xmlns:a16="http://schemas.microsoft.com/office/drawing/2014/main" id="{01A68C77-1AFC-46E9-AEB1-2938723A918F}"/>
+          <p:cNvPr id="7" name="text-c36ncm7vo66">
+            <a:extLst xmlns:a="http://schemas.openxmlformats.org/drawingml/2006/main">
+              <a:ext uri="{FF2B5EF4-FFF2-40B4-BE49-F238E27FC236}">
+                <a16:creationId xmlns:a16="http://schemas.microsoft.com/office/drawing/2014/main" id="{3F037DAF-8D70-497F-A452-DBDDD9407C1D}"/>
               </a:ext>
             </a:extLst>
           </p:cNvPr>
@@ -9159,10 +9149,10 @@
       </p:sp>
       <p:sp>
         <p:nvSpPr>
-          <p:cNvPr id="8" name="text-nhc4hvhqk4e">
-            <a:extLst xmlns:a="http://schemas.openxmlformats.org/drawingml/2006/main">
-              <a:ext uri="{FF2B5EF4-FFF2-40B4-BE49-F238E27FC236}">
-                <a16:creationId xmlns:a16="http://schemas.microsoft.com/office/drawing/2014/main" id="{0557BDEB-F2DC-4EA8-9874-41A4BF460E98}"/>
+          <p:cNvPr id="8" name="text-b09azmmzr2">
+            <a:extLst xmlns:a="http://schemas.openxmlformats.org/drawingml/2006/main">
+              <a:ext uri="{FF2B5EF4-FFF2-40B4-BE49-F238E27FC236}">
+                <a16:creationId xmlns:a16="http://schemas.microsoft.com/office/drawing/2014/main" id="{90829DC3-F8B3-48AD-BE33-9D501D4522BD}"/>
               </a:ext>
             </a:extLst>
           </p:cNvPr>
@@ -9217,10 +9207,10 @@
       </p:sp>
       <p:sp>
         <p:nvSpPr>
-          <p:cNvPr id="9" name="text-n6yzla36ytq">
-            <a:extLst xmlns:a="http://schemas.openxmlformats.org/drawingml/2006/main">
-              <a:ext uri="{FF2B5EF4-FFF2-40B4-BE49-F238E27FC236}">
-                <a16:creationId xmlns:a16="http://schemas.microsoft.com/office/drawing/2014/main" id="{1C00D584-E31F-468F-94C9-8486A849FB19}"/>
+          <p:cNvPr id="9" name="text-t3vrvwtowxf">
+            <a:extLst xmlns:a="http://schemas.openxmlformats.org/drawingml/2006/main">
+              <a:ext uri="{FF2B5EF4-FFF2-40B4-BE49-F238E27FC236}">
+                <a16:creationId xmlns:a16="http://schemas.microsoft.com/office/drawing/2014/main" id="{2765F657-4159-4E01-80D2-A51EB669EE57}"/>
               </a:ext>
             </a:extLst>
           </p:cNvPr>
@@ -9297,10 +9287,10 @@
       </p:cxnSp>
       <p:sp>
         <p:nvSpPr>
-          <p:cNvPr id="11" name="text-5l82d469f27">
-            <a:extLst xmlns:a="http://schemas.openxmlformats.org/drawingml/2006/main">
-              <a:ext uri="{FF2B5EF4-FFF2-40B4-BE49-F238E27FC236}">
-                <a16:creationId xmlns:a16="http://schemas.microsoft.com/office/drawing/2014/main" id="{B8F109E6-7F91-424B-85A6-093EFDB355A3}"/>
+          <p:cNvPr id="11" name="text-s8dyqmnqyg">
+            <a:extLst xmlns:a="http://schemas.openxmlformats.org/drawingml/2006/main">
+              <a:ext uri="{FF2B5EF4-FFF2-40B4-BE49-F238E27FC236}">
+                <a16:creationId xmlns:a16="http://schemas.microsoft.com/office/drawing/2014/main" id="{313CFC47-DDB6-423A-BE83-9545FE280002}"/>
               </a:ext>
             </a:extLst>
           </p:cNvPr>
@@ -9348,17 +9338,17 @@
                 <a:ea typeface="Arial"/>
                 <a:cs typeface="Arial"/>
               </a:rPr>
-              <a:t>My commercial rule</a:t>
-            </a:r>
-          </a:p>
-        </p:txBody>
-      </p:sp>
-      <p:sp>
-        <p:nvSpPr>
-          <p:cNvPr id="12" name="text-gwkicymoy3r">
-            <a:extLst xmlns:a="http://schemas.openxmlformats.org/drawingml/2006/main">
-              <a:ext uri="{FF2B5EF4-FFF2-40B4-BE49-F238E27FC236}">
-                <a16:creationId xmlns:a16="http://schemas.microsoft.com/office/drawing/2014/main" id="{052CD5EC-A733-44F8-8032-74D5B34F691A}"/>
+              <a:t>Commercial rule</a:t>
+            </a:r>
+          </a:p>
+        </p:txBody>
+      </p:sp>
+      <p:sp>
+        <p:nvSpPr>
+          <p:cNvPr id="12" name="text-jo6poqi7yk">
+            <a:extLst xmlns:a="http://schemas.openxmlformats.org/drawingml/2006/main">
+              <a:ext uri="{FF2B5EF4-FFF2-40B4-BE49-F238E27FC236}">
+                <a16:creationId xmlns:a16="http://schemas.microsoft.com/office/drawing/2014/main" id="{4D20B449-62F9-4F32-89BC-8D4AD5EA5671}"/>
               </a:ext>
             </a:extLst>
           </p:cNvPr>
@@ -9406,17 +9396,17 @@
                 <a:ea typeface="Arial"/>
                 <a:cs typeface="Arial"/>
               </a:rPr>
-              <a:t>Choose the package, price point and message together, using outlet economics. Do not bolt a creative idea onto a pack that is unavailable or unaffordable in the target moment.</a:t>
-            </a:r>
-          </a:p>
-        </p:txBody>
-      </p:sp>
-      <p:sp>
-        <p:nvSpPr>
-          <p:cNvPr id="13" name="text-gwzi04clrk7">
-            <a:extLst xmlns:a="http://schemas.openxmlformats.org/drawingml/2006/main">
-              <a:ext uri="{FF2B5EF4-FFF2-40B4-BE49-F238E27FC236}">
-                <a16:creationId xmlns:a16="http://schemas.microsoft.com/office/drawing/2014/main" id="{FC0B5019-9525-48C8-9074-01B1C36E11FE}"/>
+              <a:t>Choose the package, price point and message together using outlet economics. The target pack must be available and affordable in the chosen moment.</a:t>
+            </a:r>
+          </a:p>
+        </p:txBody>
+      </p:sp>
+      <p:sp>
+        <p:nvSpPr>
+          <p:cNvPr id="13" name="text-xzda67ou27e">
+            <a:extLst xmlns:a="http://schemas.openxmlformats.org/drawingml/2006/main">
+              <a:ext uri="{FF2B5EF4-FFF2-40B4-BE49-F238E27FC236}">
+                <a16:creationId xmlns:a16="http://schemas.microsoft.com/office/drawing/2014/main" id="{FCC4C462-9331-4EAC-B2B4-54610BF3A0FF}"/>
               </a:ext>
             </a:extLst>
           </p:cNvPr>
@@ -9464,7 +9454,7 @@
                 <a:ea typeface="Arial"/>
                 <a:cs typeface="Arial"/>
               </a:rPr>
-              <a:t>The 130 million figure relates to juice drinks and multiple markets. I use it as a revenue-growth-management signal, not as a forecast for this pilot.</a:t>
+              <a:t>The 130 million figure covers juice drinks across several markets. It is a revenue-growth-management signal for pack choice, not a pilot forecast.</a:t>
             </a:r>
           </a:p>
         </p:txBody>
@@ -9472,7 +9462,7 @@
     </p:spTree>
     <p:extLst>
       <p:ext uri="{BB962C8B-B14F-4D97-AF65-F5344CB8AC3E}">
-        <p14:creationId xmlns:p14="http://schemas.microsoft.com/office/powerpoint/2010/main" val="968288819"/>
+        <p14:creationId xmlns:p14="http://schemas.microsoft.com/office/powerpoint/2010/main" val="78500996"/>
       </p:ext>
     </p:extLst>
   </p:cSld>
@@ -9500,10 +9490,10 @@
       </p:grpSpPr>
       <p:sp>
         <p:nvSpPr>
-          <p:cNvPr id="19" name="text-nbyif5uvq5q">
-            <a:extLst xmlns:a="http://schemas.openxmlformats.org/drawingml/2006/main">
-              <a:ext uri="{FF2B5EF4-FFF2-40B4-BE49-F238E27FC236}">
-                <a16:creationId xmlns:a16="http://schemas.microsoft.com/office/drawing/2014/main" id="{9705A8DF-BBD9-4AAC-81AC-6DC810C395DC}"/>
+          <p:cNvPr id="19" name="text-1o1u85e43my">
+            <a:extLst xmlns:a="http://schemas.openxmlformats.org/drawingml/2006/main">
+              <a:ext uri="{FF2B5EF4-FFF2-40B4-BE49-F238E27FC236}">
+                <a16:creationId xmlns:a16="http://schemas.microsoft.com/office/drawing/2014/main" id="{18F7E646-9838-4FFA-B48B-9C48E324AE1C}"/>
               </a:ext>
             </a:extLst>
           </p:cNvPr>
@@ -9558,10 +9548,10 @@
       </p:sp>
       <p:sp>
         <p:nvSpPr>
-          <p:cNvPr id="2" name="text-g9ibho4q4ob">
-            <a:extLst xmlns:a="http://schemas.openxmlformats.org/drawingml/2006/main">
-              <a:ext uri="{FF2B5EF4-FFF2-40B4-BE49-F238E27FC236}">
-                <a16:creationId xmlns:a16="http://schemas.microsoft.com/office/drawing/2014/main" id="{B791BB88-F586-4A54-8BF2-5D7A76057E74}"/>
+          <p:cNvPr id="2" name="text-w15q1idtb1">
+            <a:extLst xmlns:a="http://schemas.openxmlformats.org/drawingml/2006/main">
+              <a:ext uri="{FF2B5EF4-FFF2-40B4-BE49-F238E27FC236}">
+                <a16:creationId xmlns:a16="http://schemas.microsoft.com/office/drawing/2014/main" id="{44316FFC-B84E-4EA6-AB81-747670819EEE}"/>
               </a:ext>
             </a:extLst>
           </p:cNvPr>
@@ -9616,10 +9606,10 @@
       </p:sp>
       <p:sp>
         <p:nvSpPr>
-          <p:cNvPr id="3" name="text-uzoou5jg8w">
-            <a:extLst xmlns:a="http://schemas.openxmlformats.org/drawingml/2006/main">
-              <a:ext uri="{FF2B5EF4-FFF2-40B4-BE49-F238E27FC236}">
-                <a16:creationId xmlns:a16="http://schemas.microsoft.com/office/drawing/2014/main" id="{673F84D7-0F5F-4B62-8EBE-74C6C73BADD0}"/>
+          <p:cNvPr id="3" name="text-h1azecz2i84">
+            <a:extLst xmlns:a="http://schemas.openxmlformats.org/drawingml/2006/main">
+              <a:ext uri="{FF2B5EF4-FFF2-40B4-BE49-F238E27FC236}">
+                <a16:creationId xmlns:a16="http://schemas.microsoft.com/office/drawing/2014/main" id="{4B37E4C4-8914-479E-B389-001A47AAC040}"/>
               </a:ext>
             </a:extLst>
           </p:cNvPr>
@@ -9699,7 +9689,7 @@
           <p:cNvPr id="5" name="">
             <a:extLst xmlns:a="http://schemas.openxmlformats.org/drawingml/2006/main">
               <a:ext uri="{FF2B5EF4-FFF2-40B4-BE49-F238E27FC236}">
-                <a16:creationId xmlns:a16="http://schemas.microsoft.com/office/drawing/2014/main" id="{8308BA78-1CFF-441E-AE08-4ABFF542213B}"/>
+                <a16:creationId xmlns:a16="http://schemas.microsoft.com/office/drawing/2014/main" id="{AD957356-131F-4847-AF38-F6A57DE931FC}"/>
               </a:ext>
             </a:extLst>
           </p:cNvPr>
@@ -9729,10 +9719,10 @@
       </p:sp>
       <p:sp>
         <p:nvSpPr>
-          <p:cNvPr id="6" name="text-qstkpxvgy2g">
-            <a:extLst xmlns:a="http://schemas.openxmlformats.org/drawingml/2006/main">
-              <a:ext uri="{FF2B5EF4-FFF2-40B4-BE49-F238E27FC236}">
-                <a16:creationId xmlns:a16="http://schemas.microsoft.com/office/drawing/2014/main" id="{40007FA6-0005-46CC-A22B-48EE6AEA2F30}"/>
+          <p:cNvPr id="6" name="text-tcvgpy1gr6s">
+            <a:extLst xmlns:a="http://schemas.openxmlformats.org/drawingml/2006/main">
+              <a:ext uri="{FF2B5EF4-FFF2-40B4-BE49-F238E27FC236}">
+                <a16:creationId xmlns:a16="http://schemas.microsoft.com/office/drawing/2014/main" id="{8626E5ED-0E8B-457D-9413-C0DDA4B8B29E}"/>
               </a:ext>
             </a:extLst>
           </p:cNvPr>
@@ -9787,10 +9777,10 @@
       </p:sp>
       <p:sp>
         <p:nvSpPr>
-          <p:cNvPr id="7" name="text-yrgc035had">
-            <a:extLst xmlns:a="http://schemas.openxmlformats.org/drawingml/2006/main">
-              <a:ext uri="{FF2B5EF4-FFF2-40B4-BE49-F238E27FC236}">
-                <a16:creationId xmlns:a16="http://schemas.microsoft.com/office/drawing/2014/main" id="{BB84DF75-E6E7-4E3B-88FF-4B1DD53740C5}"/>
+          <p:cNvPr id="7" name="text-i1ax4yfq5">
+            <a:extLst xmlns:a="http://schemas.openxmlformats.org/drawingml/2006/main">
+              <a:ext uri="{FF2B5EF4-FFF2-40B4-BE49-F238E27FC236}">
+                <a16:creationId xmlns:a16="http://schemas.microsoft.com/office/drawing/2014/main" id="{52CB694D-BEC5-4DA6-B9E7-8A6467A84B4A}"/>
               </a:ext>
             </a:extLst>
           </p:cNvPr>
@@ -9838,17 +9828,17 @@
                 <a:ea typeface="Arial"/>
                 <a:cs typeface="Arial"/>
               </a:rPr>
-              <a:t>Design the truth</a:t>
-            </a:r>
-          </a:p>
-        </p:txBody>
-      </p:sp>
-      <p:sp>
-        <p:nvSpPr>
-          <p:cNvPr id="8" name="text-j96gshl40ce">
-            <a:extLst xmlns:a="http://schemas.openxmlformats.org/drawingml/2006/main">
-              <a:ext uri="{FF2B5EF4-FFF2-40B4-BE49-F238E27FC236}">
-                <a16:creationId xmlns:a16="http://schemas.microsoft.com/office/drawing/2014/main" id="{BC06C210-C311-46E4-83D9-838F82A69D1F}"/>
+              <a:t>Set the test</a:t>
+            </a:r>
+          </a:p>
+        </p:txBody>
+      </p:sp>
+      <p:sp>
+        <p:nvSpPr>
+          <p:cNvPr id="8" name="text-l28zibtgxt">
+            <a:extLst xmlns:a="http://schemas.openxmlformats.org/drawingml/2006/main">
+              <a:ext uri="{FF2B5EF4-FFF2-40B4-BE49-F238E27FC236}">
+                <a16:creationId xmlns:a16="http://schemas.microsoft.com/office/drawing/2014/main" id="{DC9D0615-0640-464E-9EBF-607D40BBBBF3}"/>
               </a:ext>
             </a:extLst>
           </p:cNvPr>
@@ -9906,7 +9896,7 @@
           <p:cNvPr id="9" name="">
             <a:extLst xmlns:a="http://schemas.openxmlformats.org/drawingml/2006/main">
               <a:ext uri="{FF2B5EF4-FFF2-40B4-BE49-F238E27FC236}">
-                <a16:creationId xmlns:a16="http://schemas.microsoft.com/office/drawing/2014/main" id="{7B5F6B9D-8918-4574-A80D-C37F58D183FB}"/>
+                <a16:creationId xmlns:a16="http://schemas.microsoft.com/office/drawing/2014/main" id="{FD4B0E1F-A20D-493B-ABF4-E9280AA8A947}"/>
               </a:ext>
             </a:extLst>
           </p:cNvPr>
@@ -9936,10 +9926,10 @@
       </p:sp>
       <p:sp>
         <p:nvSpPr>
-          <p:cNvPr id="10" name="text-gytv9tptzya">
-            <a:extLst xmlns:a="http://schemas.openxmlformats.org/drawingml/2006/main">
-              <a:ext uri="{FF2B5EF4-FFF2-40B4-BE49-F238E27FC236}">
-                <a16:creationId xmlns:a16="http://schemas.microsoft.com/office/drawing/2014/main" id="{2CE6B687-47B3-4B2F-9268-4D6D197D7341}"/>
+          <p:cNvPr id="10" name="text-1r5hqcycdd7">
+            <a:extLst xmlns:a="http://schemas.openxmlformats.org/drawingml/2006/main">
+              <a:ext uri="{FF2B5EF4-FFF2-40B4-BE49-F238E27FC236}">
+                <a16:creationId xmlns:a16="http://schemas.microsoft.com/office/drawing/2014/main" id="{057CCAA9-385B-49C5-A1F6-FF2D379C2D54}"/>
               </a:ext>
             </a:extLst>
           </p:cNvPr>
@@ -9994,10 +9984,10 @@
       </p:sp>
       <p:sp>
         <p:nvSpPr>
-          <p:cNvPr id="11" name="text-okkpvsv4uym">
-            <a:extLst xmlns:a="http://schemas.openxmlformats.org/drawingml/2006/main">
-              <a:ext uri="{FF2B5EF4-FFF2-40B4-BE49-F238E27FC236}">
-                <a16:creationId xmlns:a16="http://schemas.microsoft.com/office/drawing/2014/main" id="{59038F40-D0DD-4099-9776-A34299BE0B18}"/>
+          <p:cNvPr id="11" name="text-gs8ttugmb7b">
+            <a:extLst xmlns:a="http://schemas.openxmlformats.org/drawingml/2006/main">
+              <a:ext uri="{FF2B5EF4-FFF2-40B4-BE49-F238E27FC236}">
+                <a16:creationId xmlns:a16="http://schemas.microsoft.com/office/drawing/2014/main" id="{505685CD-6BB9-4AC1-9072-6D0E3E2A8698}"/>
               </a:ext>
             </a:extLst>
           </p:cNvPr>
@@ -10052,10 +10042,10 @@
       </p:sp>
       <p:sp>
         <p:nvSpPr>
-          <p:cNvPr id="12" name="text-0jhwgswe4w15">
-            <a:extLst xmlns:a="http://schemas.openxmlformats.org/drawingml/2006/main">
-              <a:ext uri="{FF2B5EF4-FFF2-40B4-BE49-F238E27FC236}">
-                <a16:creationId xmlns:a16="http://schemas.microsoft.com/office/drawing/2014/main" id="{1ADFC482-1099-4589-B914-7BA01190D4CE}"/>
+          <p:cNvPr id="12" name="text-bocovew3fbc">
+            <a:extLst xmlns:a="http://schemas.openxmlformats.org/drawingml/2006/main">
+              <a:ext uri="{FF2B5EF4-FFF2-40B4-BE49-F238E27FC236}">
+                <a16:creationId xmlns:a16="http://schemas.microsoft.com/office/drawing/2014/main" id="{6D4B7BE6-2B98-4A30-8300-E591075AA6BC}"/>
               </a:ext>
             </a:extLst>
           </p:cNvPr>
@@ -10113,7 +10103,7 @@
           <p:cNvPr id="13" name="">
             <a:extLst xmlns:a="http://schemas.openxmlformats.org/drawingml/2006/main">
               <a:ext uri="{FF2B5EF4-FFF2-40B4-BE49-F238E27FC236}">
-                <a16:creationId xmlns:a16="http://schemas.microsoft.com/office/drawing/2014/main" id="{459A925A-550A-4BD5-BEE8-B02B91B8D1C0}"/>
+                <a16:creationId xmlns:a16="http://schemas.microsoft.com/office/drawing/2014/main" id="{51B27E79-B450-45A8-B18C-F88C931FA39C}"/>
               </a:ext>
             </a:extLst>
           </p:cNvPr>
@@ -10143,10 +10133,10 @@
       </p:sp>
       <p:sp>
         <p:nvSpPr>
-          <p:cNvPr id="14" name="text-waaz8blc7hq">
-            <a:extLst xmlns:a="http://schemas.openxmlformats.org/drawingml/2006/main">
-              <a:ext uri="{FF2B5EF4-FFF2-40B4-BE49-F238E27FC236}">
-                <a16:creationId xmlns:a16="http://schemas.microsoft.com/office/drawing/2014/main" id="{C869DF40-25D9-4E9D-8496-5F59BEBD741B}"/>
+          <p:cNvPr id="14" name="text-5a4i421uzzv">
+            <a:extLst xmlns:a="http://schemas.openxmlformats.org/drawingml/2006/main">
+              <a:ext uri="{FF2B5EF4-FFF2-40B4-BE49-F238E27FC236}">
+                <a16:creationId xmlns:a16="http://schemas.microsoft.com/office/drawing/2014/main" id="{C558CE2C-DC45-4A53-9872-BB4E5A65E1B2}"/>
               </a:ext>
             </a:extLst>
           </p:cNvPr>
@@ -10201,10 +10191,10 @@
       </p:sp>
       <p:sp>
         <p:nvSpPr>
-          <p:cNvPr id="15" name="text-twvqcj0i5ag">
-            <a:extLst xmlns:a="http://schemas.openxmlformats.org/drawingml/2006/main">
-              <a:ext uri="{FF2B5EF4-FFF2-40B4-BE49-F238E27FC236}">
-                <a16:creationId xmlns:a16="http://schemas.microsoft.com/office/drawing/2014/main" id="{C9A44217-DE1D-4EFF-A5C5-615D93C5CF71}"/>
+          <p:cNvPr id="15" name="text-okm71db7u4e">
+            <a:extLst xmlns:a="http://schemas.openxmlformats.org/drawingml/2006/main">
+              <a:ext uri="{FF2B5EF4-FFF2-40B4-BE49-F238E27FC236}">
+                <a16:creationId xmlns:a16="http://schemas.microsoft.com/office/drawing/2014/main" id="{6963B3ED-953C-456D-962D-A4BA5A0B4497}"/>
               </a:ext>
             </a:extLst>
           </p:cNvPr>
@@ -10252,17 +10242,17 @@
                 <a:ea typeface="Arial"/>
                 <a:cs typeface="Arial"/>
               </a:rPr>
-              <a:t>Read the behaviour</a:t>
-            </a:r>
-          </a:p>
-        </p:txBody>
-      </p:sp>
-      <p:sp>
-        <p:nvSpPr>
-          <p:cNvPr id="16" name="text-o75q4cgmh3i">
-            <a:extLst xmlns:a="http://schemas.openxmlformats.org/drawingml/2006/main">
-              <a:ext uri="{FF2B5EF4-FFF2-40B4-BE49-F238E27FC236}">
-                <a16:creationId xmlns:a16="http://schemas.microsoft.com/office/drawing/2014/main" id="{21B5F3A7-6462-4388-B8A4-AD560E00BA99}"/>
+              <a:t>Review the results</a:t>
+            </a:r>
+          </a:p>
+        </p:txBody>
+      </p:sp>
+      <p:sp>
+        <p:nvSpPr>
+          <p:cNvPr id="16" name="text-0qc5t5c3mogg">
+            <a:extLst xmlns:a="http://schemas.openxmlformats.org/drawingml/2006/main">
+              <a:ext uri="{FF2B5EF4-FFF2-40B4-BE49-F238E27FC236}">
+                <a16:creationId xmlns:a16="http://schemas.microsoft.com/office/drawing/2014/main" id="{D5EC4082-F548-4FF3-9A86-38DBF174BCEC}"/>
               </a:ext>
             </a:extLst>
           </p:cNvPr>
@@ -10320,7 +10310,7 @@
           <p:cNvPr id="17" name="">
             <a:extLst xmlns:a="http://schemas.openxmlformats.org/drawingml/2006/main">
               <a:ext uri="{FF2B5EF4-FFF2-40B4-BE49-F238E27FC236}">
-                <a16:creationId xmlns:a16="http://schemas.microsoft.com/office/drawing/2014/main" id="{B78A6FED-72EA-4134-8D40-00AADABF13D6}"/>
+                <a16:creationId xmlns:a16="http://schemas.microsoft.com/office/drawing/2014/main" id="{87E29653-7C00-4609-9950-D6047E6C6135}"/>
               </a:ext>
             </a:extLst>
           </p:cNvPr>
@@ -10348,10 +10338,10 @@
       </p:sp>
       <p:sp>
         <p:nvSpPr>
-          <p:cNvPr id="18" name="text-67jumy7i91j">
-            <a:extLst xmlns:a="http://schemas.openxmlformats.org/drawingml/2006/main">
-              <a:ext uri="{FF2B5EF4-FFF2-40B4-BE49-F238E27FC236}">
-                <a16:creationId xmlns:a16="http://schemas.microsoft.com/office/drawing/2014/main" id="{3A2B44DC-D6E5-40C9-AA5B-38DA97110577}"/>
+          <p:cNvPr id="18" name="text-3n1lage8rve">
+            <a:extLst xmlns:a="http://schemas.openxmlformats.org/drawingml/2006/main">
+              <a:ext uri="{FF2B5EF4-FFF2-40B4-BE49-F238E27FC236}">
+                <a16:creationId xmlns:a16="http://schemas.microsoft.com/office/drawing/2014/main" id="{22EECFB4-2104-4AB8-9DE7-D6F6E30320D3}"/>
               </a:ext>
             </a:extLst>
           </p:cNvPr>
@@ -10399,7 +10389,7 @@
                 <a:ea typeface="Arial"/>
                 <a:cs typeface="Arial"/>
               </a:rPr>
-              <a:t>Decision: scale, redesign or stop. A polished activation is not the output. A better growth decision is.</a:t>
+              <a:t>Use the readout to scale, revise or stop the treatment.</a:t>
             </a:r>
           </a:p>
         </p:txBody>
@@ -10407,7 +10397,7 @@
     </p:spTree>
     <p:extLst>
       <p:ext uri="{BB962C8B-B14F-4D97-AF65-F5344CB8AC3E}">
-        <p14:creationId xmlns:p14="http://schemas.microsoft.com/office/powerpoint/2010/main" val="2111602426"/>
+        <p14:creationId xmlns:p14="http://schemas.microsoft.com/office/powerpoint/2010/main" val="1669885116"/>
       </p:ext>
     </p:extLst>
   </p:cSld>

</xml_diff>